<commit_message>
docs: aplica cores de planejamento e legenda na arquitetura Beagle
</commit_message>
<xml_diff>
--- a/projects/Arquitetura Beagle/Arquitetura_Beagle.pptx
+++ b/projects/Arquitetura Beagle/Arquitetura_Beagle.pptx
@@ -4263,12 +4263,12 @@
             <a:prstGeom xmlns:a="http://schemas.openxmlformats.org/drawingml/2006/main" prst="rect">
               <a:avLst/>
             </a:prstGeom>
-            <a:solidFill xmlns:a="http://schemas.openxmlformats.org/drawingml/2006/main">
-              <a:srgbClr val="F3F5F6"/>
-            </a:solidFill>
+            <ns0:solidFill xmlns:ns0="http://schemas.openxmlformats.org/drawingml/2006/main">
+              <ns0:srgbClr val="E2F0E7"/>
+            </ns0:solidFill>
             <a:ln xmlns:a="http://schemas.openxmlformats.org/drawingml/2006/main" w="9525">
               <a:solidFill>
-                <a:srgbClr val="D6DDE2"/>
+                <a:srgbClr val="B8D6C4"/>
               </a:solidFill>
               <a:prstDash val="solid"/>
             </a:ln>
@@ -4310,7 +4310,7 @@
               <a:defPPr>
                 <a:defRPr sz="1350" b="1">
                   <a:solidFill>
-                    <a:srgbClr val="A95120"/>
+                    <a:srgbClr val="26705D"/>
                   </a:solidFill>
                   <a:latin typeface="Arial"/>
                   <a:ea typeface="Arial"/>
@@ -4320,7 +4320,7 @@
               <a:lvl1pPr>
                 <a:defRPr sz="1350" b="1">
                   <a:solidFill>
-                    <a:srgbClr val="A95120"/>
+                    <a:srgbClr val="26705D"/>
                   </a:solidFill>
                   <a:latin typeface="Arial"/>
                   <a:ea typeface="Arial"/>
@@ -4330,7 +4330,7 @@
               <a:lvl2pPr>
                 <a:defRPr sz="1350" b="1">
                   <a:solidFill>
-                    <a:srgbClr val="A95120"/>
+                    <a:srgbClr val="26705D"/>
                   </a:solidFill>
                   <a:latin typeface="Arial"/>
                   <a:ea typeface="Arial"/>
@@ -4340,7 +4340,7 @@
               <a:lvl3pPr>
                 <a:defRPr sz="1350" b="1">
                   <a:solidFill>
-                    <a:srgbClr val="A95120"/>
+                    <a:srgbClr val="26705D"/>
                   </a:solidFill>
                   <a:latin typeface="Arial"/>
                   <a:ea typeface="Arial"/>
@@ -4350,7 +4350,7 @@
               <a:lvl4pPr>
                 <a:defRPr sz="1350" b="1">
                   <a:solidFill>
-                    <a:srgbClr val="A95120"/>
+                    <a:srgbClr val="26705D"/>
                   </a:solidFill>
                   <a:latin typeface="Arial"/>
                   <a:ea typeface="Arial"/>
@@ -4360,7 +4360,7 @@
               <a:lvl5pPr>
                 <a:defRPr sz="1350" b="1">
                   <a:solidFill>
-                    <a:srgbClr val="A95120"/>
+                    <a:srgbClr val="26705D"/>
                   </a:solidFill>
                   <a:latin typeface="Arial"/>
                   <a:ea typeface="Arial"/>
@@ -4370,7 +4370,7 @@
               <a:lvl6pPr>
                 <a:defRPr sz="1350" b="1">
                   <a:solidFill>
-                    <a:srgbClr val="A95120"/>
+                    <a:srgbClr val="26705D"/>
                   </a:solidFill>
                   <a:latin typeface="Arial"/>
                   <a:ea typeface="Arial"/>
@@ -4380,7 +4380,7 @@
               <a:lvl7pPr>
                 <a:defRPr sz="1350" b="1">
                   <a:solidFill>
-                    <a:srgbClr val="A95120"/>
+                    <a:srgbClr val="26705D"/>
                   </a:solidFill>
                   <a:latin typeface="Arial"/>
                   <a:ea typeface="Arial"/>
@@ -4390,7 +4390,7 @@
               <a:lvl8pPr>
                 <a:defRPr sz="1350" b="1">
                   <a:solidFill>
-                    <a:srgbClr val="A95120"/>
+                    <a:srgbClr val="26705D"/>
                   </a:solidFill>
                   <a:latin typeface="Arial"/>
                   <a:ea typeface="Arial"/>
@@ -4400,7 +4400,7 @@
               <a:lvl9pPr>
                 <a:defRPr sz="1350" b="1">
                   <a:solidFill>
-                    <a:srgbClr val="A95120"/>
+                    <a:srgbClr val="26705D"/>
                   </a:solidFill>
                   <a:latin typeface="Arial"/>
                   <a:ea typeface="Arial"/>
@@ -4412,7 +4412,7 @@
               <a:pPr>
                 <a:defRPr sz="1350" b="1">
                   <a:solidFill>
-                    <a:srgbClr val="A95120"/>
+                    <a:srgbClr val="26705D"/>
                   </a:solidFill>
                   <a:latin typeface="Arial"/>
                   <a:ea typeface="Arial"/>
@@ -4422,7 +4422,7 @@
               <a:r>
                 <a:rPr sz="1350" b="1">
                   <a:solidFill>
-                    <a:srgbClr val="A95120"/>
+                    <a:srgbClr val="26705D"/>
                   </a:solidFill>
                   <a:latin typeface="Arial"/>
                   <a:ea typeface="Arial"/>
@@ -5327,11 +5327,13 @@
             <a:prstGeom xmlns:a="http://schemas.openxmlformats.org/drawingml/2006/main" prst="rect">
               <a:avLst/>
             </a:prstGeom>
-            <a:solidFill xmlns:a="http://schemas.openxmlformats.org/drawingml/2006/main">
-              <a:srgbClr val="142E49"/>
-            </a:solidFill>
+            <ns0:solidFill xmlns:ns0="http://schemas.openxmlformats.org/drawingml/2006/main">
+              <ns0:srgbClr val="E2F0E7"/>
+            </ns0:solidFill>
             <a:ln xmlns:a="http://schemas.openxmlformats.org/drawingml/2006/main" w="0">
-              <a:noFill/>
+              <a:solidFill>
+                <a:srgbClr val="B8D6C4"/>
+              </a:solidFill>
               <a:prstDash val="solid"/>
             </a:ln>
           </p:spPr>
@@ -5372,7 +5374,7 @@
               <a:defPPr>
                 <a:defRPr sz="1425" b="1">
                   <a:solidFill>
-                    <a:srgbClr val="FFFFFF"/>
+                    <a:srgbClr val="142E49"/>
                   </a:solidFill>
                   <a:latin typeface="Arial"/>
                   <a:ea typeface="Arial"/>
@@ -5382,7 +5384,7 @@
               <a:lvl1pPr>
                 <a:defRPr sz="1425" b="1">
                   <a:solidFill>
-                    <a:srgbClr val="FFFFFF"/>
+                    <a:srgbClr val="142E49"/>
                   </a:solidFill>
                   <a:latin typeface="Arial"/>
                   <a:ea typeface="Arial"/>
@@ -5392,7 +5394,7 @@
               <a:lvl2pPr>
                 <a:defRPr sz="1425" b="1">
                   <a:solidFill>
-                    <a:srgbClr val="FFFFFF"/>
+                    <a:srgbClr val="142E49"/>
                   </a:solidFill>
                   <a:latin typeface="Arial"/>
                   <a:ea typeface="Arial"/>
@@ -5402,7 +5404,7 @@
               <a:lvl3pPr>
                 <a:defRPr sz="1425" b="1">
                   <a:solidFill>
-                    <a:srgbClr val="FFFFFF"/>
+                    <a:srgbClr val="142E49"/>
                   </a:solidFill>
                   <a:latin typeface="Arial"/>
                   <a:ea typeface="Arial"/>
@@ -5412,7 +5414,7 @@
               <a:lvl4pPr>
                 <a:defRPr sz="1425" b="1">
                   <a:solidFill>
-                    <a:srgbClr val="FFFFFF"/>
+                    <a:srgbClr val="142E49"/>
                   </a:solidFill>
                   <a:latin typeface="Arial"/>
                   <a:ea typeface="Arial"/>
@@ -5422,7 +5424,7 @@
               <a:lvl5pPr>
                 <a:defRPr sz="1425" b="1">
                   <a:solidFill>
-                    <a:srgbClr val="FFFFFF"/>
+                    <a:srgbClr val="142E49"/>
                   </a:solidFill>
                   <a:latin typeface="Arial"/>
                   <a:ea typeface="Arial"/>
@@ -5432,7 +5434,7 @@
               <a:lvl6pPr>
                 <a:defRPr sz="1425" b="1">
                   <a:solidFill>
-                    <a:srgbClr val="FFFFFF"/>
+                    <a:srgbClr val="142E49"/>
                   </a:solidFill>
                   <a:latin typeface="Arial"/>
                   <a:ea typeface="Arial"/>
@@ -5442,7 +5444,7 @@
               <a:lvl7pPr>
                 <a:defRPr sz="1425" b="1">
                   <a:solidFill>
-                    <a:srgbClr val="FFFFFF"/>
+                    <a:srgbClr val="142E49"/>
                   </a:solidFill>
                   <a:latin typeface="Arial"/>
                   <a:ea typeface="Arial"/>
@@ -5452,7 +5454,7 @@
               <a:lvl8pPr>
                 <a:defRPr sz="1425" b="1">
                   <a:solidFill>
-                    <a:srgbClr val="FFFFFF"/>
+                    <a:srgbClr val="142E49"/>
                   </a:solidFill>
                   <a:latin typeface="Arial"/>
                   <a:ea typeface="Arial"/>
@@ -5462,7 +5464,7 @@
               <a:lvl9pPr>
                 <a:defRPr sz="1425" b="1">
                   <a:solidFill>
-                    <a:srgbClr val="FFFFFF"/>
+                    <a:srgbClr val="142E49"/>
                   </a:solidFill>
                   <a:latin typeface="Arial"/>
                   <a:ea typeface="Arial"/>
@@ -5474,7 +5476,7 @@
               <a:pPr>
                 <a:defRPr sz="1425" b="1">
                   <a:solidFill>
-                    <a:srgbClr val="FFFFFF"/>
+                    <a:srgbClr val="142E49"/>
                   </a:solidFill>
                   <a:latin typeface="Arial"/>
                   <a:ea typeface="Arial"/>
@@ -5484,7 +5486,7 @@
               <a:r>
                 <a:rPr sz="1425" b="1">
                   <a:solidFill>
-                    <a:srgbClr val="FFFFFF"/>
+                    <a:srgbClr val="142E49"/>
                   </a:solidFill>
                   <a:latin typeface="Arial"/>
                   <a:ea typeface="Arial"/>
@@ -5531,7 +5533,7 @@
               <a:defPPr>
                 <a:defRPr sz="1200" b="0">
                   <a:solidFill>
-                    <a:srgbClr val="C8E0DA"/>
+                    <a:srgbClr val="26705D"/>
                   </a:solidFill>
                   <a:latin typeface="Arial"/>
                   <a:ea typeface="Arial"/>
@@ -5541,7 +5543,7 @@
               <a:lvl1pPr>
                 <a:defRPr sz="1200" b="0">
                   <a:solidFill>
-                    <a:srgbClr val="C8E0DA"/>
+                    <a:srgbClr val="26705D"/>
                   </a:solidFill>
                   <a:latin typeface="Arial"/>
                   <a:ea typeface="Arial"/>
@@ -5551,7 +5553,7 @@
               <a:lvl2pPr>
                 <a:defRPr sz="1200" b="0">
                   <a:solidFill>
-                    <a:srgbClr val="C8E0DA"/>
+                    <a:srgbClr val="26705D"/>
                   </a:solidFill>
                   <a:latin typeface="Arial"/>
                   <a:ea typeface="Arial"/>
@@ -5561,7 +5563,7 @@
               <a:lvl3pPr>
                 <a:defRPr sz="1200" b="0">
                   <a:solidFill>
-                    <a:srgbClr val="C8E0DA"/>
+                    <a:srgbClr val="26705D"/>
                   </a:solidFill>
                   <a:latin typeface="Arial"/>
                   <a:ea typeface="Arial"/>
@@ -5571,7 +5573,7 @@
               <a:lvl4pPr>
                 <a:defRPr sz="1200" b="0">
                   <a:solidFill>
-                    <a:srgbClr val="C8E0DA"/>
+                    <a:srgbClr val="26705D"/>
                   </a:solidFill>
                   <a:latin typeface="Arial"/>
                   <a:ea typeface="Arial"/>
@@ -5581,7 +5583,7 @@
               <a:lvl5pPr>
                 <a:defRPr sz="1200" b="0">
                   <a:solidFill>
-                    <a:srgbClr val="C8E0DA"/>
+                    <a:srgbClr val="26705D"/>
                   </a:solidFill>
                   <a:latin typeface="Arial"/>
                   <a:ea typeface="Arial"/>
@@ -5591,7 +5593,7 @@
               <a:lvl6pPr>
                 <a:defRPr sz="1200" b="0">
                   <a:solidFill>
-                    <a:srgbClr val="C8E0DA"/>
+                    <a:srgbClr val="26705D"/>
                   </a:solidFill>
                   <a:latin typeface="Arial"/>
                   <a:ea typeface="Arial"/>
@@ -5601,7 +5603,7 @@
               <a:lvl7pPr>
                 <a:defRPr sz="1200" b="0">
                   <a:solidFill>
-                    <a:srgbClr val="C8E0DA"/>
+                    <a:srgbClr val="26705D"/>
                   </a:solidFill>
                   <a:latin typeface="Arial"/>
                   <a:ea typeface="Arial"/>
@@ -5611,7 +5613,7 @@
               <a:lvl8pPr>
                 <a:defRPr sz="1200" b="0">
                   <a:solidFill>
-                    <a:srgbClr val="C8E0DA"/>
+                    <a:srgbClr val="26705D"/>
                   </a:solidFill>
                   <a:latin typeface="Arial"/>
                   <a:ea typeface="Arial"/>
@@ -5621,7 +5623,7 @@
               <a:lvl9pPr>
                 <a:defRPr sz="1200" b="0">
                   <a:solidFill>
-                    <a:srgbClr val="C8E0DA"/>
+                    <a:srgbClr val="26705D"/>
                   </a:solidFill>
                   <a:latin typeface="Arial"/>
                   <a:ea typeface="Arial"/>
@@ -5633,7 +5635,7 @@
               <a:pPr>
                 <a:defRPr sz="1200" b="0">
                   <a:solidFill>
-                    <a:srgbClr val="C8E0DA"/>
+                    <a:srgbClr val="26705D"/>
                   </a:solidFill>
                   <a:latin typeface="Arial"/>
                   <a:ea typeface="Arial"/>
@@ -5643,7 +5645,7 @@
               <a:r>
                 <a:rPr sz="1200" b="0">
                   <a:solidFill>
-                    <a:srgbClr val="C8E0DA"/>
+                    <a:srgbClr val="26705D"/>
                   </a:solidFill>
                   <a:latin typeface="Arial"/>
                   <a:ea typeface="Arial"/>
@@ -5690,7 +5692,7 @@
               <a:defPPr>
                 <a:defRPr sz="2100" b="1">
                   <a:solidFill>
-                    <a:srgbClr val="FFFFFF"/>
+                    <a:srgbClr val="142E49"/>
                   </a:solidFill>
                   <a:latin typeface="Arial"/>
                   <a:ea typeface="Arial"/>
@@ -5700,7 +5702,7 @@
               <a:lvl1pPr>
                 <a:defRPr sz="2100" b="1">
                   <a:solidFill>
-                    <a:srgbClr val="FFFFFF"/>
+                    <a:srgbClr val="142E49"/>
                   </a:solidFill>
                   <a:latin typeface="Arial"/>
                   <a:ea typeface="Arial"/>
@@ -5710,7 +5712,7 @@
               <a:lvl2pPr>
                 <a:defRPr sz="2100" b="1">
                   <a:solidFill>
-                    <a:srgbClr val="FFFFFF"/>
+                    <a:srgbClr val="142E49"/>
                   </a:solidFill>
                   <a:latin typeface="Arial"/>
                   <a:ea typeface="Arial"/>
@@ -5720,7 +5722,7 @@
               <a:lvl3pPr>
                 <a:defRPr sz="2100" b="1">
                   <a:solidFill>
-                    <a:srgbClr val="FFFFFF"/>
+                    <a:srgbClr val="142E49"/>
                   </a:solidFill>
                   <a:latin typeface="Arial"/>
                   <a:ea typeface="Arial"/>
@@ -5730,7 +5732,7 @@
               <a:lvl4pPr>
                 <a:defRPr sz="2100" b="1">
                   <a:solidFill>
-                    <a:srgbClr val="FFFFFF"/>
+                    <a:srgbClr val="142E49"/>
                   </a:solidFill>
                   <a:latin typeface="Arial"/>
                   <a:ea typeface="Arial"/>
@@ -5740,7 +5742,7 @@
               <a:lvl5pPr>
                 <a:defRPr sz="2100" b="1">
                   <a:solidFill>
-                    <a:srgbClr val="FFFFFF"/>
+                    <a:srgbClr val="142E49"/>
                   </a:solidFill>
                   <a:latin typeface="Arial"/>
                   <a:ea typeface="Arial"/>
@@ -5750,7 +5752,7 @@
               <a:lvl6pPr>
                 <a:defRPr sz="2100" b="1">
                   <a:solidFill>
-                    <a:srgbClr val="FFFFFF"/>
+                    <a:srgbClr val="142E49"/>
                   </a:solidFill>
                   <a:latin typeface="Arial"/>
                   <a:ea typeface="Arial"/>
@@ -5760,7 +5762,7 @@
               <a:lvl7pPr>
                 <a:defRPr sz="2100" b="1">
                   <a:solidFill>
-                    <a:srgbClr val="FFFFFF"/>
+                    <a:srgbClr val="142E49"/>
                   </a:solidFill>
                   <a:latin typeface="Arial"/>
                   <a:ea typeface="Arial"/>
@@ -5770,7 +5772,7 @@
               <a:lvl8pPr>
                 <a:defRPr sz="2100" b="1">
                   <a:solidFill>
-                    <a:srgbClr val="FFFFFF"/>
+                    <a:srgbClr val="142E49"/>
                   </a:solidFill>
                   <a:latin typeface="Arial"/>
                   <a:ea typeface="Arial"/>
@@ -5780,7 +5782,7 @@
               <a:lvl9pPr>
                 <a:defRPr sz="2100" b="1">
                   <a:solidFill>
-                    <a:srgbClr val="FFFFFF"/>
+                    <a:srgbClr val="142E49"/>
                   </a:solidFill>
                   <a:latin typeface="Arial"/>
                   <a:ea typeface="Arial"/>
@@ -5792,7 +5794,7 @@
               <a:pPr>
                 <a:defRPr sz="2100" b="1">
                   <a:solidFill>
-                    <a:srgbClr val="FFFFFF"/>
+                    <a:srgbClr val="142E49"/>
                   </a:solidFill>
                   <a:latin typeface="Arial"/>
                   <a:ea typeface="Arial"/>
@@ -5802,7 +5804,7 @@
               <a:r>
                 <a:rPr sz="2100" b="1">
                   <a:solidFill>
-                    <a:srgbClr val="FFFFFF"/>
+                    <a:srgbClr val="142E49"/>
                   </a:solidFill>
                   <a:latin typeface="Arial"/>
                   <a:ea typeface="Arial"/>
@@ -5849,7 +5851,7 @@
               <a:defPPr>
                 <a:defRPr sz="1650" b="0">
                   <a:solidFill>
-                    <a:srgbClr val="FFFFFF"/>
+                    <a:srgbClr val="142E49"/>
                   </a:solidFill>
                   <a:latin typeface="Arial"/>
                   <a:ea typeface="Arial"/>
@@ -5859,7 +5861,7 @@
               <a:lvl1pPr>
                 <a:defRPr sz="1650" b="0">
                   <a:solidFill>
-                    <a:srgbClr val="FFFFFF"/>
+                    <a:srgbClr val="142E49"/>
                   </a:solidFill>
                   <a:latin typeface="Arial"/>
                   <a:ea typeface="Arial"/>
@@ -5869,7 +5871,7 @@
               <a:lvl2pPr>
                 <a:defRPr sz="1650" b="0">
                   <a:solidFill>
-                    <a:srgbClr val="FFFFFF"/>
+                    <a:srgbClr val="142E49"/>
                   </a:solidFill>
                   <a:latin typeface="Arial"/>
                   <a:ea typeface="Arial"/>
@@ -5879,7 +5881,7 @@
               <a:lvl3pPr>
                 <a:defRPr sz="1650" b="0">
                   <a:solidFill>
-                    <a:srgbClr val="FFFFFF"/>
+                    <a:srgbClr val="142E49"/>
                   </a:solidFill>
                   <a:latin typeface="Arial"/>
                   <a:ea typeface="Arial"/>
@@ -5889,7 +5891,7 @@
               <a:lvl4pPr>
                 <a:defRPr sz="1650" b="0">
                   <a:solidFill>
-                    <a:srgbClr val="FFFFFF"/>
+                    <a:srgbClr val="142E49"/>
                   </a:solidFill>
                   <a:latin typeface="Arial"/>
                   <a:ea typeface="Arial"/>
@@ -5899,7 +5901,7 @@
               <a:lvl5pPr>
                 <a:defRPr sz="1650" b="0">
                   <a:solidFill>
-                    <a:srgbClr val="FFFFFF"/>
+                    <a:srgbClr val="142E49"/>
                   </a:solidFill>
                   <a:latin typeface="Arial"/>
                   <a:ea typeface="Arial"/>
@@ -5909,7 +5911,7 @@
               <a:lvl6pPr>
                 <a:defRPr sz="1650" b="0">
                   <a:solidFill>
-                    <a:srgbClr val="FFFFFF"/>
+                    <a:srgbClr val="142E49"/>
                   </a:solidFill>
                   <a:latin typeface="Arial"/>
                   <a:ea typeface="Arial"/>
@@ -5919,7 +5921,7 @@
               <a:lvl7pPr>
                 <a:defRPr sz="1650" b="0">
                   <a:solidFill>
-                    <a:srgbClr val="FFFFFF"/>
+                    <a:srgbClr val="142E49"/>
                   </a:solidFill>
                   <a:latin typeface="Arial"/>
                   <a:ea typeface="Arial"/>
@@ -5929,7 +5931,7 @@
               <a:lvl8pPr>
                 <a:defRPr sz="1650" b="0">
                   <a:solidFill>
-                    <a:srgbClr val="FFFFFF"/>
+                    <a:srgbClr val="142E49"/>
                   </a:solidFill>
                   <a:latin typeface="Arial"/>
                   <a:ea typeface="Arial"/>
@@ -5939,7 +5941,7 @@
               <a:lvl9pPr>
                 <a:defRPr sz="1650" b="0">
                   <a:solidFill>
-                    <a:srgbClr val="FFFFFF"/>
+                    <a:srgbClr val="142E49"/>
                   </a:solidFill>
                   <a:latin typeface="Arial"/>
                   <a:ea typeface="Arial"/>
@@ -5951,7 +5953,7 @@
               <a:pPr>
                 <a:defRPr sz="1650" b="0">
                   <a:solidFill>
-                    <a:srgbClr val="FFFFFF"/>
+                    <a:srgbClr val="142E49"/>
                   </a:solidFill>
                   <a:latin typeface="Arial"/>
                   <a:ea typeface="Arial"/>
@@ -5961,7 +5963,7 @@
               <a:r>
                 <a:rPr sz="1650" b="0">
                   <a:solidFill>
-                    <a:srgbClr val="FFFFFF"/>
+                    <a:srgbClr val="142E49"/>
                   </a:solidFill>
                   <a:latin typeface="Arial"/>
                   <a:ea typeface="Arial"/>
@@ -6356,11 +6358,13 @@
             <a:prstGeom xmlns:a="http://schemas.openxmlformats.org/drawingml/2006/main" prst="rect">
               <a:avLst/>
             </a:prstGeom>
-            <a:solidFill xmlns:a="http://schemas.openxmlformats.org/drawingml/2006/main">
-              <a:srgbClr val="D6DDE2"/>
-            </a:solidFill>
+            <ns0:solidFill xmlns:ns0="http://schemas.openxmlformats.org/drawingml/2006/main">
+              <ns0:srgbClr val="ECEEF0"/>
+            </ns0:solidFill>
             <a:ln xmlns:a="http://schemas.openxmlformats.org/drawingml/2006/main" w="0">
-              <a:noFill/>
+              <a:solidFill>
+                <a:srgbClr val="D3D7DB"/>
+              </a:solidFill>
               <a:prstDash val="solid"/>
             </a:ln>
           </p:spPr>
@@ -6387,12 +6391,12 @@
             <a:prstGeom xmlns:a="http://schemas.openxmlformats.org/drawingml/2006/main" prst="rect">
               <a:avLst/>
             </a:prstGeom>
-            <a:solidFill xmlns:a="http://schemas.openxmlformats.org/drawingml/2006/main">
-              <a:srgbClr val="FFFFFF"/>
-            </a:solidFill>
+            <ns0:solidFill xmlns:ns0="http://schemas.openxmlformats.org/drawingml/2006/main">
+              <ns0:srgbClr val="E2F0E7"/>
+            </ns0:solidFill>
             <a:ln xmlns:a="http://schemas.openxmlformats.org/drawingml/2006/main" w="9525">
               <a:solidFill>
-                <a:srgbClr val="D6DDE2"/>
+                <a:srgbClr val="B8D6C4"/>
               </a:solidFill>
               <a:prstDash val="solid"/>
             </a:ln>
@@ -6920,12 +6924,12 @@
             <a:prstGeom xmlns:a="http://schemas.openxmlformats.org/drawingml/2006/main" prst="rect">
               <a:avLst/>
             </a:prstGeom>
-            <a:solidFill xmlns:a="http://schemas.openxmlformats.org/drawingml/2006/main">
-              <a:srgbClr val="FFFFFF"/>
-            </a:solidFill>
+            <ns0:solidFill xmlns:ns0="http://schemas.openxmlformats.org/drawingml/2006/main">
+              <ns0:srgbClr val="E2F0E7"/>
+            </ns0:solidFill>
             <a:ln xmlns:a="http://schemas.openxmlformats.org/drawingml/2006/main" w="9525">
               <a:solidFill>
-                <a:srgbClr val="D6DDE2"/>
+                <a:srgbClr val="B8D6C4"/>
               </a:solidFill>
               <a:prstDash val="solid"/>
             </a:ln>
@@ -7974,11 +7978,13 @@
             <a:prstGeom xmlns:a="http://schemas.openxmlformats.org/drawingml/2006/main" prst="rect">
               <a:avLst/>
             </a:prstGeom>
-            <a:solidFill xmlns:a="http://schemas.openxmlformats.org/drawingml/2006/main">
-              <a:srgbClr val="D6DDE2"/>
-            </a:solidFill>
+            <ns0:solidFill xmlns:ns0="http://schemas.openxmlformats.org/drawingml/2006/main">
+              <ns0:srgbClr val="ECEEF0"/>
+            </ns0:solidFill>
             <a:ln xmlns:a="http://schemas.openxmlformats.org/drawingml/2006/main" w="0">
-              <a:noFill/>
+              <a:solidFill>
+                <a:srgbClr val="D3D7DB"/>
+              </a:solidFill>
               <a:prstDash val="solid"/>
             </a:ln>
           </p:spPr>
@@ -8005,12 +8011,12 @@
             <a:prstGeom xmlns:a="http://schemas.openxmlformats.org/drawingml/2006/main" prst="rect">
               <a:avLst/>
             </a:prstGeom>
-            <a:solidFill xmlns:a="http://schemas.openxmlformats.org/drawingml/2006/main">
-              <a:srgbClr val="FFFFFF"/>
-            </a:solidFill>
+            <ns0:solidFill xmlns:ns0="http://schemas.openxmlformats.org/drawingml/2006/main">
+              <ns0:srgbClr val="ECEEF0"/>
+            </ns0:solidFill>
             <a:ln xmlns:a="http://schemas.openxmlformats.org/drawingml/2006/main" w="9525">
               <a:solidFill>
-                <a:srgbClr val="D6DDE2"/>
+                <a:srgbClr val="D3D7DB"/>
               </a:solidFill>
               <a:prstDash val="solid"/>
             </a:ln>
@@ -8052,7 +8058,7 @@
               <a:defPPr>
                 <a:defRPr sz="1950" b="1">
                   <a:solidFill>
-                    <a:srgbClr val="142E49"/>
+                    <a:srgbClr val="56636E"/>
                   </a:solidFill>
                   <a:latin typeface="Arial"/>
                   <a:ea typeface="Arial"/>
@@ -8062,7 +8068,7 @@
               <a:lvl1pPr>
                 <a:defRPr sz="1950" b="1">
                   <a:solidFill>
-                    <a:srgbClr val="142E49"/>
+                    <a:srgbClr val="56636E"/>
                   </a:solidFill>
                   <a:latin typeface="Arial"/>
                   <a:ea typeface="Arial"/>
@@ -8072,7 +8078,7 @@
               <a:lvl2pPr>
                 <a:defRPr sz="1950" b="1">
                   <a:solidFill>
-                    <a:srgbClr val="142E49"/>
+                    <a:srgbClr val="56636E"/>
                   </a:solidFill>
                   <a:latin typeface="Arial"/>
                   <a:ea typeface="Arial"/>
@@ -8082,7 +8088,7 @@
               <a:lvl3pPr>
                 <a:defRPr sz="1950" b="1">
                   <a:solidFill>
-                    <a:srgbClr val="142E49"/>
+                    <a:srgbClr val="56636E"/>
                   </a:solidFill>
                   <a:latin typeface="Arial"/>
                   <a:ea typeface="Arial"/>
@@ -8092,7 +8098,7 @@
               <a:lvl4pPr>
                 <a:defRPr sz="1950" b="1">
                   <a:solidFill>
-                    <a:srgbClr val="142E49"/>
+                    <a:srgbClr val="56636E"/>
                   </a:solidFill>
                   <a:latin typeface="Arial"/>
                   <a:ea typeface="Arial"/>
@@ -8102,7 +8108,7 @@
               <a:lvl5pPr>
                 <a:defRPr sz="1950" b="1">
                   <a:solidFill>
-                    <a:srgbClr val="142E49"/>
+                    <a:srgbClr val="56636E"/>
                   </a:solidFill>
                   <a:latin typeface="Arial"/>
                   <a:ea typeface="Arial"/>
@@ -8112,7 +8118,7 @@
               <a:lvl6pPr>
                 <a:defRPr sz="1950" b="1">
                   <a:solidFill>
-                    <a:srgbClr val="142E49"/>
+                    <a:srgbClr val="56636E"/>
                   </a:solidFill>
                   <a:latin typeface="Arial"/>
                   <a:ea typeface="Arial"/>
@@ -8122,7 +8128,7 @@
               <a:lvl7pPr>
                 <a:defRPr sz="1950" b="1">
                   <a:solidFill>
-                    <a:srgbClr val="142E49"/>
+                    <a:srgbClr val="56636E"/>
                   </a:solidFill>
                   <a:latin typeface="Arial"/>
                   <a:ea typeface="Arial"/>
@@ -8132,7 +8138,7 @@
               <a:lvl8pPr>
                 <a:defRPr sz="1950" b="1">
                   <a:solidFill>
-                    <a:srgbClr val="142E49"/>
+                    <a:srgbClr val="56636E"/>
                   </a:solidFill>
                   <a:latin typeface="Arial"/>
                   <a:ea typeface="Arial"/>
@@ -8142,7 +8148,7 @@
               <a:lvl9pPr>
                 <a:defRPr sz="1950" b="1">
                   <a:solidFill>
-                    <a:srgbClr val="142E49"/>
+                    <a:srgbClr val="56636E"/>
                   </a:solidFill>
                   <a:latin typeface="Arial"/>
                   <a:ea typeface="Arial"/>
@@ -8154,7 +8160,7 @@
               <a:pPr>
                 <a:defRPr sz="1950" b="1">
                   <a:solidFill>
-                    <a:srgbClr val="142E49"/>
+                    <a:srgbClr val="56636E"/>
                   </a:solidFill>
                   <a:latin typeface="Arial"/>
                   <a:ea typeface="Arial"/>
@@ -8164,7 +8170,7 @@
               <a:r>
                 <a:rPr sz="1950" b="1">
                   <a:solidFill>
-                    <a:srgbClr val="142E49"/>
+                    <a:srgbClr val="56636E"/>
                   </a:solidFill>
                   <a:latin typeface="Arial"/>
                   <a:ea typeface="Arial"/>
@@ -8211,7 +8217,7 @@
               <a:defPPr>
                 <a:defRPr sz="1650" b="0">
                   <a:solidFill>
-                    <a:srgbClr val="243746"/>
+                    <a:srgbClr val="56636E"/>
                   </a:solidFill>
                   <a:latin typeface="Arial"/>
                   <a:ea typeface="Arial"/>
@@ -8221,7 +8227,7 @@
               <a:lvl1pPr>
                 <a:defRPr sz="1650" b="0">
                   <a:solidFill>
-                    <a:srgbClr val="243746"/>
+                    <a:srgbClr val="56636E"/>
                   </a:solidFill>
                   <a:latin typeface="Arial"/>
                   <a:ea typeface="Arial"/>
@@ -8231,7 +8237,7 @@
               <a:lvl2pPr>
                 <a:defRPr sz="1650" b="0">
                   <a:solidFill>
-                    <a:srgbClr val="243746"/>
+                    <a:srgbClr val="56636E"/>
                   </a:solidFill>
                   <a:latin typeface="Arial"/>
                   <a:ea typeface="Arial"/>
@@ -8241,7 +8247,7 @@
               <a:lvl3pPr>
                 <a:defRPr sz="1650" b="0">
                   <a:solidFill>
-                    <a:srgbClr val="243746"/>
+                    <a:srgbClr val="56636E"/>
                   </a:solidFill>
                   <a:latin typeface="Arial"/>
                   <a:ea typeface="Arial"/>
@@ -8251,7 +8257,7 @@
               <a:lvl4pPr>
                 <a:defRPr sz="1650" b="0">
                   <a:solidFill>
-                    <a:srgbClr val="243746"/>
+                    <a:srgbClr val="56636E"/>
                   </a:solidFill>
                   <a:latin typeface="Arial"/>
                   <a:ea typeface="Arial"/>
@@ -8261,7 +8267,7 @@
               <a:lvl5pPr>
                 <a:defRPr sz="1650" b="0">
                   <a:solidFill>
-                    <a:srgbClr val="243746"/>
+                    <a:srgbClr val="56636E"/>
                   </a:solidFill>
                   <a:latin typeface="Arial"/>
                   <a:ea typeface="Arial"/>
@@ -8271,7 +8277,7 @@
               <a:lvl6pPr>
                 <a:defRPr sz="1650" b="0">
                   <a:solidFill>
-                    <a:srgbClr val="243746"/>
+                    <a:srgbClr val="56636E"/>
                   </a:solidFill>
                   <a:latin typeface="Arial"/>
                   <a:ea typeface="Arial"/>
@@ -8281,7 +8287,7 @@
               <a:lvl7pPr>
                 <a:defRPr sz="1650" b="0">
                   <a:solidFill>
-                    <a:srgbClr val="243746"/>
+                    <a:srgbClr val="56636E"/>
                   </a:solidFill>
                   <a:latin typeface="Arial"/>
                   <a:ea typeface="Arial"/>
@@ -8291,7 +8297,7 @@
               <a:lvl8pPr>
                 <a:defRPr sz="1650" b="0">
                   <a:solidFill>
-                    <a:srgbClr val="243746"/>
+                    <a:srgbClr val="56636E"/>
                   </a:solidFill>
                   <a:latin typeface="Arial"/>
                   <a:ea typeface="Arial"/>
@@ -8301,7 +8307,7 @@
               <a:lvl9pPr>
                 <a:defRPr sz="1650" b="0">
                   <a:solidFill>
-                    <a:srgbClr val="243746"/>
+                    <a:srgbClr val="56636E"/>
                   </a:solidFill>
                   <a:latin typeface="Arial"/>
                   <a:ea typeface="Arial"/>
@@ -8313,7 +8319,7 @@
               <a:pPr>
                 <a:defRPr sz="1650" b="0">
                   <a:solidFill>
-                    <a:srgbClr val="243746"/>
+                    <a:srgbClr val="56636E"/>
                   </a:solidFill>
                   <a:latin typeface="Arial"/>
                   <a:ea typeface="Arial"/>
@@ -8323,7 +8329,7 @@
               <a:r>
                 <a:rPr sz="1650" b="0">
                   <a:solidFill>
-                    <a:srgbClr val="243746"/>
+                    <a:srgbClr val="56636E"/>
                   </a:solidFill>
                   <a:latin typeface="Arial"/>
                   <a:ea typeface="Arial"/>
@@ -8336,7 +8342,7 @@
               <a:pPr>
                 <a:defRPr sz="1650" b="0">
                   <a:solidFill>
-                    <a:srgbClr val="243746"/>
+                    <a:srgbClr val="56636E"/>
                   </a:solidFill>
                   <a:latin typeface="Arial"/>
                   <a:ea typeface="Arial"/>
@@ -8346,7 +8352,7 @@
               <a:r>
                 <a:rPr sz="1650" b="0">
                   <a:solidFill>
-                    <a:srgbClr val="243746"/>
+                    <a:srgbClr val="56636E"/>
                   </a:solidFill>
                   <a:latin typeface="Arial"/>
                   <a:ea typeface="Arial"/>
@@ -8393,7 +8399,7 @@
               <a:defPPr>
                 <a:defRPr sz="1200" b="1">
                   <a:solidFill>
-                    <a:srgbClr val="28637A"/>
+                    <a:srgbClr val="68737D"/>
                   </a:solidFill>
                   <a:latin typeface="Arial"/>
                   <a:ea typeface="Arial"/>
@@ -8403,7 +8409,7 @@
               <a:lvl1pPr>
                 <a:defRPr sz="1200" b="1">
                   <a:solidFill>
-                    <a:srgbClr val="28637A"/>
+                    <a:srgbClr val="68737D"/>
                   </a:solidFill>
                   <a:latin typeface="Arial"/>
                   <a:ea typeface="Arial"/>
@@ -8413,7 +8419,7 @@
               <a:lvl2pPr>
                 <a:defRPr sz="1200" b="1">
                   <a:solidFill>
-                    <a:srgbClr val="28637A"/>
+                    <a:srgbClr val="68737D"/>
                   </a:solidFill>
                   <a:latin typeface="Arial"/>
                   <a:ea typeface="Arial"/>
@@ -8423,7 +8429,7 @@
               <a:lvl3pPr>
                 <a:defRPr sz="1200" b="1">
                   <a:solidFill>
-                    <a:srgbClr val="28637A"/>
+                    <a:srgbClr val="68737D"/>
                   </a:solidFill>
                   <a:latin typeface="Arial"/>
                   <a:ea typeface="Arial"/>
@@ -8433,7 +8439,7 @@
               <a:lvl4pPr>
                 <a:defRPr sz="1200" b="1">
                   <a:solidFill>
-                    <a:srgbClr val="28637A"/>
+                    <a:srgbClr val="68737D"/>
                   </a:solidFill>
                   <a:latin typeface="Arial"/>
                   <a:ea typeface="Arial"/>
@@ -8443,7 +8449,7 @@
               <a:lvl5pPr>
                 <a:defRPr sz="1200" b="1">
                   <a:solidFill>
-                    <a:srgbClr val="28637A"/>
+                    <a:srgbClr val="68737D"/>
                   </a:solidFill>
                   <a:latin typeface="Arial"/>
                   <a:ea typeface="Arial"/>
@@ -8453,7 +8459,7 @@
               <a:lvl6pPr>
                 <a:defRPr sz="1200" b="1">
                   <a:solidFill>
-                    <a:srgbClr val="28637A"/>
+                    <a:srgbClr val="68737D"/>
                   </a:solidFill>
                   <a:latin typeface="Arial"/>
                   <a:ea typeface="Arial"/>
@@ -8463,7 +8469,7 @@
               <a:lvl7pPr>
                 <a:defRPr sz="1200" b="1">
                   <a:solidFill>
-                    <a:srgbClr val="28637A"/>
+                    <a:srgbClr val="68737D"/>
                   </a:solidFill>
                   <a:latin typeface="Arial"/>
                   <a:ea typeface="Arial"/>
@@ -8473,7 +8479,7 @@
               <a:lvl8pPr>
                 <a:defRPr sz="1200" b="1">
                   <a:solidFill>
-                    <a:srgbClr val="28637A"/>
+                    <a:srgbClr val="68737D"/>
                   </a:solidFill>
                   <a:latin typeface="Arial"/>
                   <a:ea typeface="Arial"/>
@@ -8483,7 +8489,7 @@
               <a:lvl9pPr>
                 <a:defRPr sz="1200" b="1">
                   <a:solidFill>
-                    <a:srgbClr val="28637A"/>
+                    <a:srgbClr val="68737D"/>
                   </a:solidFill>
                   <a:latin typeface="Arial"/>
                   <a:ea typeface="Arial"/>
@@ -8495,7 +8501,7 @@
               <a:pPr>
                 <a:defRPr sz="1200" b="1">
                   <a:solidFill>
-                    <a:srgbClr val="28637A"/>
+                    <a:srgbClr val="68737D"/>
                   </a:solidFill>
                   <a:latin typeface="Arial"/>
                   <a:ea typeface="Arial"/>
@@ -8505,7 +8511,7 @@
               <a:r>
                 <a:rPr sz="1200" b="1">
                   <a:solidFill>
-                    <a:srgbClr val="28637A"/>
+                    <a:srgbClr val="68737D"/>
                   </a:solidFill>
                   <a:latin typeface="Arial"/>
                   <a:ea typeface="Arial"/>
@@ -8538,12 +8544,12 @@
             <a:prstGeom xmlns:a="http://schemas.openxmlformats.org/drawingml/2006/main" prst="rect">
               <a:avLst/>
             </a:prstGeom>
-            <a:solidFill xmlns:a="http://schemas.openxmlformats.org/drawingml/2006/main">
-              <a:srgbClr val="FFFFFF"/>
-            </a:solidFill>
+            <ns0:solidFill xmlns:ns0="http://schemas.openxmlformats.org/drawingml/2006/main">
+              <ns0:srgbClr val="FBE9D8"/>
+            </ns0:solidFill>
             <a:ln xmlns:a="http://schemas.openxmlformats.org/drawingml/2006/main" w="9525">
               <a:solidFill>
-                <a:srgbClr val="D6DDE2"/>
+                <a:srgbClr val="E5C4A5"/>
               </a:solidFill>
               <a:prstDash val="solid"/>
             </a:ln>
@@ -8903,7 +8909,7 @@
               <a:defPPr>
                 <a:defRPr sz="1200" b="1">
                   <a:solidFill>
-                    <a:srgbClr val="685779"/>
+                    <a:srgbClr val="A95120"/>
                   </a:solidFill>
                   <a:latin typeface="Arial"/>
                   <a:ea typeface="Arial"/>
@@ -8913,7 +8919,7 @@
               <a:lvl1pPr>
                 <a:defRPr sz="1200" b="1">
                   <a:solidFill>
-                    <a:srgbClr val="685779"/>
+                    <a:srgbClr val="A95120"/>
                   </a:solidFill>
                   <a:latin typeface="Arial"/>
                   <a:ea typeface="Arial"/>
@@ -8923,7 +8929,7 @@
               <a:lvl2pPr>
                 <a:defRPr sz="1200" b="1">
                   <a:solidFill>
-                    <a:srgbClr val="685779"/>
+                    <a:srgbClr val="A95120"/>
                   </a:solidFill>
                   <a:latin typeface="Arial"/>
                   <a:ea typeface="Arial"/>
@@ -8933,7 +8939,7 @@
               <a:lvl3pPr>
                 <a:defRPr sz="1200" b="1">
                   <a:solidFill>
-                    <a:srgbClr val="685779"/>
+                    <a:srgbClr val="A95120"/>
                   </a:solidFill>
                   <a:latin typeface="Arial"/>
                   <a:ea typeface="Arial"/>
@@ -8943,7 +8949,7 @@
               <a:lvl4pPr>
                 <a:defRPr sz="1200" b="1">
                   <a:solidFill>
-                    <a:srgbClr val="685779"/>
+                    <a:srgbClr val="A95120"/>
                   </a:solidFill>
                   <a:latin typeface="Arial"/>
                   <a:ea typeface="Arial"/>
@@ -8953,7 +8959,7 @@
               <a:lvl5pPr>
                 <a:defRPr sz="1200" b="1">
                   <a:solidFill>
-                    <a:srgbClr val="685779"/>
+                    <a:srgbClr val="A95120"/>
                   </a:solidFill>
                   <a:latin typeface="Arial"/>
                   <a:ea typeface="Arial"/>
@@ -8963,7 +8969,7 @@
               <a:lvl6pPr>
                 <a:defRPr sz="1200" b="1">
                   <a:solidFill>
-                    <a:srgbClr val="685779"/>
+                    <a:srgbClr val="A95120"/>
                   </a:solidFill>
                   <a:latin typeface="Arial"/>
                   <a:ea typeface="Arial"/>
@@ -8973,7 +8979,7 @@
               <a:lvl7pPr>
                 <a:defRPr sz="1200" b="1">
                   <a:solidFill>
-                    <a:srgbClr val="685779"/>
+                    <a:srgbClr val="A95120"/>
                   </a:solidFill>
                   <a:latin typeface="Arial"/>
                   <a:ea typeface="Arial"/>
@@ -8983,7 +8989,7 @@
               <a:lvl8pPr>
                 <a:defRPr sz="1200" b="1">
                   <a:solidFill>
-                    <a:srgbClr val="685779"/>
+                    <a:srgbClr val="A95120"/>
                   </a:solidFill>
                   <a:latin typeface="Arial"/>
                   <a:ea typeface="Arial"/>
@@ -8993,7 +8999,7 @@
               <a:lvl9pPr>
                 <a:defRPr sz="1200" b="1">
                   <a:solidFill>
-                    <a:srgbClr val="685779"/>
+                    <a:srgbClr val="A95120"/>
                   </a:solidFill>
                   <a:latin typeface="Arial"/>
                   <a:ea typeface="Arial"/>
@@ -9005,7 +9011,7 @@
               <a:pPr>
                 <a:defRPr sz="1200" b="1">
                   <a:solidFill>
-                    <a:srgbClr val="685779"/>
+                    <a:srgbClr val="A95120"/>
                   </a:solidFill>
                   <a:latin typeface="Arial"/>
                   <a:ea typeface="Arial"/>
@@ -9015,7 +9021,7 @@
               <a:r>
                 <a:rPr sz="1200" b="1">
                   <a:solidFill>
-                    <a:srgbClr val="685779"/>
+                    <a:srgbClr val="A95120"/>
                   </a:solidFill>
                   <a:latin typeface="Arial"/>
                   <a:ea typeface="Arial"/>
@@ -9048,12 +9054,12 @@
             <a:prstGeom xmlns:a="http://schemas.openxmlformats.org/drawingml/2006/main" prst="rect">
               <a:avLst/>
             </a:prstGeom>
-            <a:solidFill xmlns:a="http://schemas.openxmlformats.org/drawingml/2006/main">
-              <a:srgbClr val="FFFFFF"/>
-            </a:solidFill>
+            <ns0:solidFill xmlns:ns0="http://schemas.openxmlformats.org/drawingml/2006/main">
+              <ns0:srgbClr val="ECEEF0"/>
+            </ns0:solidFill>
             <a:ln xmlns:a="http://schemas.openxmlformats.org/drawingml/2006/main" w="9525">
               <a:solidFill>
-                <a:srgbClr val="D6DDE2"/>
+                <a:srgbClr val="D3D7DB"/>
               </a:solidFill>
               <a:prstDash val="solid"/>
             </a:ln>
@@ -9095,7 +9101,7 @@
               <a:defPPr>
                 <a:defRPr sz="1950" b="1">
                   <a:solidFill>
-                    <a:srgbClr val="142E49"/>
+                    <a:srgbClr val="56636E"/>
                   </a:solidFill>
                   <a:latin typeface="Arial"/>
                   <a:ea typeface="Arial"/>
@@ -9105,7 +9111,7 @@
               <a:lvl1pPr>
                 <a:defRPr sz="1950" b="1">
                   <a:solidFill>
-                    <a:srgbClr val="142E49"/>
+                    <a:srgbClr val="56636E"/>
                   </a:solidFill>
                   <a:latin typeface="Arial"/>
                   <a:ea typeface="Arial"/>
@@ -9115,7 +9121,7 @@
               <a:lvl2pPr>
                 <a:defRPr sz="1950" b="1">
                   <a:solidFill>
-                    <a:srgbClr val="142E49"/>
+                    <a:srgbClr val="56636E"/>
                   </a:solidFill>
                   <a:latin typeface="Arial"/>
                   <a:ea typeface="Arial"/>
@@ -9125,7 +9131,7 @@
               <a:lvl3pPr>
                 <a:defRPr sz="1950" b="1">
                   <a:solidFill>
-                    <a:srgbClr val="142E49"/>
+                    <a:srgbClr val="56636E"/>
                   </a:solidFill>
                   <a:latin typeface="Arial"/>
                   <a:ea typeface="Arial"/>
@@ -9135,7 +9141,7 @@
               <a:lvl4pPr>
                 <a:defRPr sz="1950" b="1">
                   <a:solidFill>
-                    <a:srgbClr val="142E49"/>
+                    <a:srgbClr val="56636E"/>
                   </a:solidFill>
                   <a:latin typeface="Arial"/>
                   <a:ea typeface="Arial"/>
@@ -9145,7 +9151,7 @@
               <a:lvl5pPr>
                 <a:defRPr sz="1950" b="1">
                   <a:solidFill>
-                    <a:srgbClr val="142E49"/>
+                    <a:srgbClr val="56636E"/>
                   </a:solidFill>
                   <a:latin typeface="Arial"/>
                   <a:ea typeface="Arial"/>
@@ -9155,7 +9161,7 @@
               <a:lvl6pPr>
                 <a:defRPr sz="1950" b="1">
                   <a:solidFill>
-                    <a:srgbClr val="142E49"/>
+                    <a:srgbClr val="56636E"/>
                   </a:solidFill>
                   <a:latin typeface="Arial"/>
                   <a:ea typeface="Arial"/>
@@ -9165,7 +9171,7 @@
               <a:lvl7pPr>
                 <a:defRPr sz="1950" b="1">
                   <a:solidFill>
-                    <a:srgbClr val="142E49"/>
+                    <a:srgbClr val="56636E"/>
                   </a:solidFill>
                   <a:latin typeface="Arial"/>
                   <a:ea typeface="Arial"/>
@@ -9175,7 +9181,7 @@
               <a:lvl8pPr>
                 <a:defRPr sz="1950" b="1">
                   <a:solidFill>
-                    <a:srgbClr val="142E49"/>
+                    <a:srgbClr val="56636E"/>
                   </a:solidFill>
                   <a:latin typeface="Arial"/>
                   <a:ea typeface="Arial"/>
@@ -9185,7 +9191,7 @@
               <a:lvl9pPr>
                 <a:defRPr sz="1950" b="1">
                   <a:solidFill>
-                    <a:srgbClr val="142E49"/>
+                    <a:srgbClr val="56636E"/>
                   </a:solidFill>
                   <a:latin typeface="Arial"/>
                   <a:ea typeface="Arial"/>
@@ -9197,7 +9203,7 @@
               <a:pPr>
                 <a:defRPr sz="1950" b="1">
                   <a:solidFill>
-                    <a:srgbClr val="142E49"/>
+                    <a:srgbClr val="56636E"/>
                   </a:solidFill>
                   <a:latin typeface="Arial"/>
                   <a:ea typeface="Arial"/>
@@ -9207,7 +9213,7 @@
               <a:r>
                 <a:rPr sz="1950" b="1">
                   <a:solidFill>
-                    <a:srgbClr val="142E49"/>
+                    <a:srgbClr val="56636E"/>
                   </a:solidFill>
                   <a:latin typeface="Arial"/>
                   <a:ea typeface="Arial"/>
@@ -9254,7 +9260,7 @@
               <a:defPPr>
                 <a:defRPr sz="1575" b="0">
                   <a:solidFill>
-                    <a:srgbClr val="243746"/>
+                    <a:srgbClr val="56636E"/>
                   </a:solidFill>
                   <a:latin typeface="Arial"/>
                   <a:ea typeface="Arial"/>
@@ -9264,7 +9270,7 @@
               <a:lvl1pPr>
                 <a:defRPr sz="1575" b="0">
                   <a:solidFill>
-                    <a:srgbClr val="243746"/>
+                    <a:srgbClr val="56636E"/>
                   </a:solidFill>
                   <a:latin typeface="Arial"/>
                   <a:ea typeface="Arial"/>
@@ -9274,7 +9280,7 @@
               <a:lvl2pPr>
                 <a:defRPr sz="1575" b="0">
                   <a:solidFill>
-                    <a:srgbClr val="243746"/>
+                    <a:srgbClr val="56636E"/>
                   </a:solidFill>
                   <a:latin typeface="Arial"/>
                   <a:ea typeface="Arial"/>
@@ -9284,7 +9290,7 @@
               <a:lvl3pPr>
                 <a:defRPr sz="1575" b="0">
                   <a:solidFill>
-                    <a:srgbClr val="243746"/>
+                    <a:srgbClr val="56636E"/>
                   </a:solidFill>
                   <a:latin typeface="Arial"/>
                   <a:ea typeface="Arial"/>
@@ -9294,7 +9300,7 @@
               <a:lvl4pPr>
                 <a:defRPr sz="1575" b="0">
                   <a:solidFill>
-                    <a:srgbClr val="243746"/>
+                    <a:srgbClr val="56636E"/>
                   </a:solidFill>
                   <a:latin typeface="Arial"/>
                   <a:ea typeface="Arial"/>
@@ -9304,7 +9310,7 @@
               <a:lvl5pPr>
                 <a:defRPr sz="1575" b="0">
                   <a:solidFill>
-                    <a:srgbClr val="243746"/>
+                    <a:srgbClr val="56636E"/>
                   </a:solidFill>
                   <a:latin typeface="Arial"/>
                   <a:ea typeface="Arial"/>
@@ -9314,7 +9320,7 @@
               <a:lvl6pPr>
                 <a:defRPr sz="1575" b="0">
                   <a:solidFill>
-                    <a:srgbClr val="243746"/>
+                    <a:srgbClr val="56636E"/>
                   </a:solidFill>
                   <a:latin typeface="Arial"/>
                   <a:ea typeface="Arial"/>
@@ -9324,7 +9330,7 @@
               <a:lvl7pPr>
                 <a:defRPr sz="1575" b="0">
                   <a:solidFill>
-                    <a:srgbClr val="243746"/>
+                    <a:srgbClr val="56636E"/>
                   </a:solidFill>
                   <a:latin typeface="Arial"/>
                   <a:ea typeface="Arial"/>
@@ -9334,7 +9340,7 @@
               <a:lvl8pPr>
                 <a:defRPr sz="1575" b="0">
                   <a:solidFill>
-                    <a:srgbClr val="243746"/>
+                    <a:srgbClr val="56636E"/>
                   </a:solidFill>
                   <a:latin typeface="Arial"/>
                   <a:ea typeface="Arial"/>
@@ -9344,7 +9350,7 @@
               <a:lvl9pPr>
                 <a:defRPr sz="1575" b="0">
                   <a:solidFill>
-                    <a:srgbClr val="243746"/>
+                    <a:srgbClr val="56636E"/>
                   </a:solidFill>
                   <a:latin typeface="Arial"/>
                   <a:ea typeface="Arial"/>
@@ -9356,7 +9362,7 @@
               <a:pPr>
                 <a:defRPr sz="1575" b="0">
                   <a:solidFill>
-                    <a:srgbClr val="243746"/>
+                    <a:srgbClr val="56636E"/>
                   </a:solidFill>
                   <a:latin typeface="Arial"/>
                   <a:ea typeface="Arial"/>
@@ -9366,7 +9372,7 @@
               <a:r>
                 <a:rPr sz="1575" b="0">
                   <a:solidFill>
-                    <a:srgbClr val="243746"/>
+                    <a:srgbClr val="56636E"/>
                   </a:solidFill>
                   <a:latin typeface="Arial"/>
                   <a:ea typeface="Arial"/>
@@ -9379,7 +9385,7 @@
               <a:pPr>
                 <a:defRPr sz="1575" b="0">
                   <a:solidFill>
-                    <a:srgbClr val="243746"/>
+                    <a:srgbClr val="56636E"/>
                   </a:solidFill>
                   <a:latin typeface="Arial"/>
                   <a:ea typeface="Arial"/>
@@ -9389,7 +9395,7 @@
               <a:r>
                 <a:rPr sz="1575" b="0">
                   <a:solidFill>
-                    <a:srgbClr val="243746"/>
+                    <a:srgbClr val="56636E"/>
                   </a:solidFill>
                   <a:latin typeface="Arial"/>
                   <a:ea typeface="Arial"/>
@@ -9436,7 +9442,7 @@
               <a:defPPr>
                 <a:defRPr sz="1200" b="1">
                   <a:solidFill>
-                    <a:srgbClr val="28637A"/>
+                    <a:srgbClr val="68737D"/>
                   </a:solidFill>
                   <a:latin typeface="Arial"/>
                   <a:ea typeface="Arial"/>
@@ -9446,7 +9452,7 @@
               <a:lvl1pPr>
                 <a:defRPr sz="1200" b="1">
                   <a:solidFill>
-                    <a:srgbClr val="28637A"/>
+                    <a:srgbClr val="68737D"/>
                   </a:solidFill>
                   <a:latin typeface="Arial"/>
                   <a:ea typeface="Arial"/>
@@ -9456,7 +9462,7 @@
               <a:lvl2pPr>
                 <a:defRPr sz="1200" b="1">
                   <a:solidFill>
-                    <a:srgbClr val="28637A"/>
+                    <a:srgbClr val="68737D"/>
                   </a:solidFill>
                   <a:latin typeface="Arial"/>
                   <a:ea typeface="Arial"/>
@@ -9466,7 +9472,7 @@
               <a:lvl3pPr>
                 <a:defRPr sz="1200" b="1">
                   <a:solidFill>
-                    <a:srgbClr val="28637A"/>
+                    <a:srgbClr val="68737D"/>
                   </a:solidFill>
                   <a:latin typeface="Arial"/>
                   <a:ea typeface="Arial"/>
@@ -9476,7 +9482,7 @@
               <a:lvl4pPr>
                 <a:defRPr sz="1200" b="1">
                   <a:solidFill>
-                    <a:srgbClr val="28637A"/>
+                    <a:srgbClr val="68737D"/>
                   </a:solidFill>
                   <a:latin typeface="Arial"/>
                   <a:ea typeface="Arial"/>
@@ -9486,7 +9492,7 @@
               <a:lvl5pPr>
                 <a:defRPr sz="1200" b="1">
                   <a:solidFill>
-                    <a:srgbClr val="28637A"/>
+                    <a:srgbClr val="68737D"/>
                   </a:solidFill>
                   <a:latin typeface="Arial"/>
                   <a:ea typeface="Arial"/>
@@ -9496,7 +9502,7 @@
               <a:lvl6pPr>
                 <a:defRPr sz="1200" b="1">
                   <a:solidFill>
-                    <a:srgbClr val="28637A"/>
+                    <a:srgbClr val="68737D"/>
                   </a:solidFill>
                   <a:latin typeface="Arial"/>
                   <a:ea typeface="Arial"/>
@@ -9506,7 +9512,7 @@
               <a:lvl7pPr>
                 <a:defRPr sz="1200" b="1">
                   <a:solidFill>
-                    <a:srgbClr val="28637A"/>
+                    <a:srgbClr val="68737D"/>
                   </a:solidFill>
                   <a:latin typeface="Arial"/>
                   <a:ea typeface="Arial"/>
@@ -9516,7 +9522,7 @@
               <a:lvl8pPr>
                 <a:defRPr sz="1200" b="1">
                   <a:solidFill>
-                    <a:srgbClr val="28637A"/>
+                    <a:srgbClr val="68737D"/>
                   </a:solidFill>
                   <a:latin typeface="Arial"/>
                   <a:ea typeface="Arial"/>
@@ -9526,7 +9532,7 @@
               <a:lvl9pPr>
                 <a:defRPr sz="1200" b="1">
                   <a:solidFill>
-                    <a:srgbClr val="28637A"/>
+                    <a:srgbClr val="68737D"/>
                   </a:solidFill>
                   <a:latin typeface="Arial"/>
                   <a:ea typeface="Arial"/>
@@ -9538,7 +9544,7 @@
               <a:pPr>
                 <a:defRPr sz="1200" b="1">
                   <a:solidFill>
-                    <a:srgbClr val="28637A"/>
+                    <a:srgbClr val="68737D"/>
                   </a:solidFill>
                   <a:latin typeface="Arial"/>
                   <a:ea typeface="Arial"/>
@@ -9548,7 +9554,7 @@
               <a:r>
                 <a:rPr sz="1200" b="1">
                   <a:solidFill>
-                    <a:srgbClr val="28637A"/>
+                    <a:srgbClr val="68737D"/>
                   </a:solidFill>
                   <a:latin typeface="Arial"/>
                   <a:ea typeface="Arial"/>
@@ -9972,11 +9978,13 @@
             <a:prstGeom xmlns:a="http://schemas.openxmlformats.org/drawingml/2006/main" prst="rect">
               <a:avLst/>
             </a:prstGeom>
-            <a:solidFill xmlns:a="http://schemas.openxmlformats.org/drawingml/2006/main">
-              <a:srgbClr val="D6DDE2"/>
-            </a:solidFill>
+            <ns0:solidFill xmlns:ns0="http://schemas.openxmlformats.org/drawingml/2006/main">
+              <ns0:srgbClr val="ECEEF0"/>
+            </ns0:solidFill>
             <a:ln xmlns:a="http://schemas.openxmlformats.org/drawingml/2006/main" w="0">
-              <a:noFill/>
+              <a:solidFill>
+                <a:srgbClr val="D3D7DB"/>
+              </a:solidFill>
               <a:prstDash val="solid"/>
             </a:ln>
           </p:spPr>
@@ -10003,12 +10011,12 @@
             <a:prstGeom xmlns:a="http://schemas.openxmlformats.org/drawingml/2006/main" prst="rect">
               <a:avLst/>
             </a:prstGeom>
-            <a:solidFill xmlns:a="http://schemas.openxmlformats.org/drawingml/2006/main">
-              <a:srgbClr val="FFFFFF"/>
-            </a:solidFill>
+            <ns0:solidFill xmlns:ns0="http://schemas.openxmlformats.org/drawingml/2006/main">
+              <ns0:srgbClr val="ECEEF0"/>
+            </ns0:solidFill>
             <a:ln xmlns:a="http://schemas.openxmlformats.org/drawingml/2006/main" w="9525">
               <a:solidFill>
-                <a:srgbClr val="D6DDE2"/>
+                <a:srgbClr val="D3D7DB"/>
               </a:solidFill>
               <a:prstDash val="solid"/>
             </a:ln>
@@ -10050,7 +10058,7 @@
               <a:defPPr>
                 <a:defRPr sz="1950" b="1">
                   <a:solidFill>
-                    <a:srgbClr val="142E49"/>
+                    <a:srgbClr val="56636E"/>
                   </a:solidFill>
                   <a:latin typeface="Arial"/>
                   <a:ea typeface="Arial"/>
@@ -10060,7 +10068,7 @@
               <a:lvl1pPr>
                 <a:defRPr sz="1950" b="1">
                   <a:solidFill>
-                    <a:srgbClr val="142E49"/>
+                    <a:srgbClr val="56636E"/>
                   </a:solidFill>
                   <a:latin typeface="Arial"/>
                   <a:ea typeface="Arial"/>
@@ -10070,7 +10078,7 @@
               <a:lvl2pPr>
                 <a:defRPr sz="1950" b="1">
                   <a:solidFill>
-                    <a:srgbClr val="142E49"/>
+                    <a:srgbClr val="56636E"/>
                   </a:solidFill>
                   <a:latin typeface="Arial"/>
                   <a:ea typeface="Arial"/>
@@ -10080,7 +10088,7 @@
               <a:lvl3pPr>
                 <a:defRPr sz="1950" b="1">
                   <a:solidFill>
-                    <a:srgbClr val="142E49"/>
+                    <a:srgbClr val="56636E"/>
                   </a:solidFill>
                   <a:latin typeface="Arial"/>
                   <a:ea typeface="Arial"/>
@@ -10090,7 +10098,7 @@
               <a:lvl4pPr>
                 <a:defRPr sz="1950" b="1">
                   <a:solidFill>
-                    <a:srgbClr val="142E49"/>
+                    <a:srgbClr val="56636E"/>
                   </a:solidFill>
                   <a:latin typeface="Arial"/>
                   <a:ea typeface="Arial"/>
@@ -10100,7 +10108,7 @@
               <a:lvl5pPr>
                 <a:defRPr sz="1950" b="1">
                   <a:solidFill>
-                    <a:srgbClr val="142E49"/>
+                    <a:srgbClr val="56636E"/>
                   </a:solidFill>
                   <a:latin typeface="Arial"/>
                   <a:ea typeface="Arial"/>
@@ -10110,7 +10118,7 @@
               <a:lvl6pPr>
                 <a:defRPr sz="1950" b="1">
                   <a:solidFill>
-                    <a:srgbClr val="142E49"/>
+                    <a:srgbClr val="56636E"/>
                   </a:solidFill>
                   <a:latin typeface="Arial"/>
                   <a:ea typeface="Arial"/>
@@ -10120,7 +10128,7 @@
               <a:lvl7pPr>
                 <a:defRPr sz="1950" b="1">
                   <a:solidFill>
-                    <a:srgbClr val="142E49"/>
+                    <a:srgbClr val="56636E"/>
                   </a:solidFill>
                   <a:latin typeface="Arial"/>
                   <a:ea typeface="Arial"/>
@@ -10130,7 +10138,7 @@
               <a:lvl8pPr>
                 <a:defRPr sz="1950" b="1">
                   <a:solidFill>
-                    <a:srgbClr val="142E49"/>
+                    <a:srgbClr val="56636E"/>
                   </a:solidFill>
                   <a:latin typeface="Arial"/>
                   <a:ea typeface="Arial"/>
@@ -10140,7 +10148,7 @@
               <a:lvl9pPr>
                 <a:defRPr sz="1950" b="1">
                   <a:solidFill>
-                    <a:srgbClr val="142E49"/>
+                    <a:srgbClr val="56636E"/>
                   </a:solidFill>
                   <a:latin typeface="Arial"/>
                   <a:ea typeface="Arial"/>
@@ -10152,7 +10160,7 @@
               <a:pPr>
                 <a:defRPr sz="1950" b="1">
                   <a:solidFill>
-                    <a:srgbClr val="142E49"/>
+                    <a:srgbClr val="56636E"/>
                   </a:solidFill>
                   <a:latin typeface="Arial"/>
                   <a:ea typeface="Arial"/>
@@ -10162,7 +10170,7 @@
               <a:r>
                 <a:rPr sz="1950" b="1">
                   <a:solidFill>
-                    <a:srgbClr val="142E49"/>
+                    <a:srgbClr val="56636E"/>
                   </a:solidFill>
                   <a:latin typeface="Arial"/>
                   <a:ea typeface="Arial"/>
@@ -10209,7 +10217,7 @@
               <a:defPPr>
                 <a:defRPr sz="1650" b="0">
                   <a:solidFill>
-                    <a:srgbClr val="243746"/>
+                    <a:srgbClr val="56636E"/>
                   </a:solidFill>
                   <a:latin typeface="Arial"/>
                   <a:ea typeface="Arial"/>
@@ -10219,7 +10227,7 @@
               <a:lvl1pPr>
                 <a:defRPr sz="1650" b="0">
                   <a:solidFill>
-                    <a:srgbClr val="243746"/>
+                    <a:srgbClr val="56636E"/>
                   </a:solidFill>
                   <a:latin typeface="Arial"/>
                   <a:ea typeface="Arial"/>
@@ -10229,7 +10237,7 @@
               <a:lvl2pPr>
                 <a:defRPr sz="1650" b="0">
                   <a:solidFill>
-                    <a:srgbClr val="243746"/>
+                    <a:srgbClr val="56636E"/>
                   </a:solidFill>
                   <a:latin typeface="Arial"/>
                   <a:ea typeface="Arial"/>
@@ -10239,7 +10247,7 @@
               <a:lvl3pPr>
                 <a:defRPr sz="1650" b="0">
                   <a:solidFill>
-                    <a:srgbClr val="243746"/>
+                    <a:srgbClr val="56636E"/>
                   </a:solidFill>
                   <a:latin typeface="Arial"/>
                   <a:ea typeface="Arial"/>
@@ -10249,7 +10257,7 @@
               <a:lvl4pPr>
                 <a:defRPr sz="1650" b="0">
                   <a:solidFill>
-                    <a:srgbClr val="243746"/>
+                    <a:srgbClr val="56636E"/>
                   </a:solidFill>
                   <a:latin typeface="Arial"/>
                   <a:ea typeface="Arial"/>
@@ -10259,7 +10267,7 @@
               <a:lvl5pPr>
                 <a:defRPr sz="1650" b="0">
                   <a:solidFill>
-                    <a:srgbClr val="243746"/>
+                    <a:srgbClr val="56636E"/>
                   </a:solidFill>
                   <a:latin typeface="Arial"/>
                   <a:ea typeface="Arial"/>
@@ -10269,7 +10277,7 @@
               <a:lvl6pPr>
                 <a:defRPr sz="1650" b="0">
                   <a:solidFill>
-                    <a:srgbClr val="243746"/>
+                    <a:srgbClr val="56636E"/>
                   </a:solidFill>
                   <a:latin typeface="Arial"/>
                   <a:ea typeface="Arial"/>
@@ -10279,7 +10287,7 @@
               <a:lvl7pPr>
                 <a:defRPr sz="1650" b="0">
                   <a:solidFill>
-                    <a:srgbClr val="243746"/>
+                    <a:srgbClr val="56636E"/>
                   </a:solidFill>
                   <a:latin typeface="Arial"/>
                   <a:ea typeface="Arial"/>
@@ -10289,7 +10297,7 @@
               <a:lvl8pPr>
                 <a:defRPr sz="1650" b="0">
                   <a:solidFill>
-                    <a:srgbClr val="243746"/>
+                    <a:srgbClr val="56636E"/>
                   </a:solidFill>
                   <a:latin typeface="Arial"/>
                   <a:ea typeface="Arial"/>
@@ -10299,7 +10307,7 @@
               <a:lvl9pPr>
                 <a:defRPr sz="1650" b="0">
                   <a:solidFill>
-                    <a:srgbClr val="243746"/>
+                    <a:srgbClr val="56636E"/>
                   </a:solidFill>
                   <a:latin typeface="Arial"/>
                   <a:ea typeface="Arial"/>
@@ -10311,7 +10319,7 @@
               <a:pPr>
                 <a:defRPr sz="1650" b="0">
                   <a:solidFill>
-                    <a:srgbClr val="243746"/>
+                    <a:srgbClr val="56636E"/>
                   </a:solidFill>
                   <a:latin typeface="Arial"/>
                   <a:ea typeface="Arial"/>
@@ -10321,7 +10329,7 @@
               <a:r>
                 <a:rPr sz="1650" b="0">
                   <a:solidFill>
-                    <a:srgbClr val="243746"/>
+                    <a:srgbClr val="56636E"/>
                   </a:solidFill>
                   <a:latin typeface="Arial"/>
                   <a:ea typeface="Arial"/>
@@ -10334,7 +10342,7 @@
               <a:pPr>
                 <a:defRPr sz="1650" b="0">
                   <a:solidFill>
-                    <a:srgbClr val="243746"/>
+                    <a:srgbClr val="56636E"/>
                   </a:solidFill>
                   <a:latin typeface="Arial"/>
                   <a:ea typeface="Arial"/>
@@ -10344,7 +10352,7 @@
               <a:r>
                 <a:rPr sz="1650" b="0">
                   <a:solidFill>
-                    <a:srgbClr val="243746"/>
+                    <a:srgbClr val="56636E"/>
                   </a:solidFill>
                   <a:latin typeface="Arial"/>
                   <a:ea typeface="Arial"/>
@@ -10391,7 +10399,7 @@
               <a:defPPr>
                 <a:defRPr sz="1200" b="1">
                   <a:solidFill>
-                    <a:srgbClr val="28637A"/>
+                    <a:srgbClr val="68737D"/>
                   </a:solidFill>
                   <a:latin typeface="Arial"/>
                   <a:ea typeface="Arial"/>
@@ -10401,7 +10409,7 @@
               <a:lvl1pPr>
                 <a:defRPr sz="1200" b="1">
                   <a:solidFill>
-                    <a:srgbClr val="28637A"/>
+                    <a:srgbClr val="68737D"/>
                   </a:solidFill>
                   <a:latin typeface="Arial"/>
                   <a:ea typeface="Arial"/>
@@ -10411,7 +10419,7 @@
               <a:lvl2pPr>
                 <a:defRPr sz="1200" b="1">
                   <a:solidFill>
-                    <a:srgbClr val="28637A"/>
+                    <a:srgbClr val="68737D"/>
                   </a:solidFill>
                   <a:latin typeface="Arial"/>
                   <a:ea typeface="Arial"/>
@@ -10421,7 +10429,7 @@
               <a:lvl3pPr>
                 <a:defRPr sz="1200" b="1">
                   <a:solidFill>
-                    <a:srgbClr val="28637A"/>
+                    <a:srgbClr val="68737D"/>
                   </a:solidFill>
                   <a:latin typeface="Arial"/>
                   <a:ea typeface="Arial"/>
@@ -10431,7 +10439,7 @@
               <a:lvl4pPr>
                 <a:defRPr sz="1200" b="1">
                   <a:solidFill>
-                    <a:srgbClr val="28637A"/>
+                    <a:srgbClr val="68737D"/>
                   </a:solidFill>
                   <a:latin typeface="Arial"/>
                   <a:ea typeface="Arial"/>
@@ -10441,7 +10449,7 @@
               <a:lvl5pPr>
                 <a:defRPr sz="1200" b="1">
                   <a:solidFill>
-                    <a:srgbClr val="28637A"/>
+                    <a:srgbClr val="68737D"/>
                   </a:solidFill>
                   <a:latin typeface="Arial"/>
                   <a:ea typeface="Arial"/>
@@ -10451,7 +10459,7 @@
               <a:lvl6pPr>
                 <a:defRPr sz="1200" b="1">
                   <a:solidFill>
-                    <a:srgbClr val="28637A"/>
+                    <a:srgbClr val="68737D"/>
                   </a:solidFill>
                   <a:latin typeface="Arial"/>
                   <a:ea typeface="Arial"/>
@@ -10461,7 +10469,7 @@
               <a:lvl7pPr>
                 <a:defRPr sz="1200" b="1">
                   <a:solidFill>
-                    <a:srgbClr val="28637A"/>
+                    <a:srgbClr val="68737D"/>
                   </a:solidFill>
                   <a:latin typeface="Arial"/>
                   <a:ea typeface="Arial"/>
@@ -10471,7 +10479,7 @@
               <a:lvl8pPr>
                 <a:defRPr sz="1200" b="1">
                   <a:solidFill>
-                    <a:srgbClr val="28637A"/>
+                    <a:srgbClr val="68737D"/>
                   </a:solidFill>
                   <a:latin typeface="Arial"/>
                   <a:ea typeface="Arial"/>
@@ -10481,7 +10489,7 @@
               <a:lvl9pPr>
                 <a:defRPr sz="1200" b="1">
                   <a:solidFill>
-                    <a:srgbClr val="28637A"/>
+                    <a:srgbClr val="68737D"/>
                   </a:solidFill>
                   <a:latin typeface="Arial"/>
                   <a:ea typeface="Arial"/>
@@ -10493,7 +10501,7 @@
               <a:pPr>
                 <a:defRPr sz="1200" b="1">
                   <a:solidFill>
-                    <a:srgbClr val="28637A"/>
+                    <a:srgbClr val="68737D"/>
                   </a:solidFill>
                   <a:latin typeface="Arial"/>
                   <a:ea typeface="Arial"/>
@@ -10503,7 +10511,7 @@
               <a:r>
                 <a:rPr sz="1200" b="1">
                   <a:solidFill>
-                    <a:srgbClr val="28637A"/>
+                    <a:srgbClr val="68737D"/>
                   </a:solidFill>
                   <a:latin typeface="Arial"/>
                   <a:ea typeface="Arial"/>
@@ -10536,12 +10544,12 @@
             <a:prstGeom xmlns:a="http://schemas.openxmlformats.org/drawingml/2006/main" prst="rect">
               <a:avLst/>
             </a:prstGeom>
-            <a:solidFill xmlns:a="http://schemas.openxmlformats.org/drawingml/2006/main">
-              <a:srgbClr val="FFFFFF"/>
-            </a:solidFill>
+            <ns0:solidFill xmlns:ns0="http://schemas.openxmlformats.org/drawingml/2006/main">
+              <ns0:srgbClr val="FBE9D8"/>
+            </ns0:solidFill>
             <a:ln xmlns:a="http://schemas.openxmlformats.org/drawingml/2006/main" w="9525">
               <a:solidFill>
-                <a:srgbClr val="D6DDE2"/>
+                <a:srgbClr val="E5C4A5"/>
               </a:solidFill>
               <a:prstDash val="solid"/>
             </a:ln>
@@ -10924,7 +10932,7 @@
               <a:defPPr>
                 <a:defRPr sz="1200" b="1">
                   <a:solidFill>
-                    <a:srgbClr val="685779"/>
+                    <a:srgbClr val="A95120"/>
                   </a:solidFill>
                   <a:latin typeface="Arial"/>
                   <a:ea typeface="Arial"/>
@@ -10934,7 +10942,7 @@
               <a:lvl1pPr>
                 <a:defRPr sz="1200" b="1">
                   <a:solidFill>
-                    <a:srgbClr val="685779"/>
+                    <a:srgbClr val="A95120"/>
                   </a:solidFill>
                   <a:latin typeface="Arial"/>
                   <a:ea typeface="Arial"/>
@@ -10944,7 +10952,7 @@
               <a:lvl2pPr>
                 <a:defRPr sz="1200" b="1">
                   <a:solidFill>
-                    <a:srgbClr val="685779"/>
+                    <a:srgbClr val="A95120"/>
                   </a:solidFill>
                   <a:latin typeface="Arial"/>
                   <a:ea typeface="Arial"/>
@@ -10954,7 +10962,7 @@
               <a:lvl3pPr>
                 <a:defRPr sz="1200" b="1">
                   <a:solidFill>
-                    <a:srgbClr val="685779"/>
+                    <a:srgbClr val="A95120"/>
                   </a:solidFill>
                   <a:latin typeface="Arial"/>
                   <a:ea typeface="Arial"/>
@@ -10964,7 +10972,7 @@
               <a:lvl4pPr>
                 <a:defRPr sz="1200" b="1">
                   <a:solidFill>
-                    <a:srgbClr val="685779"/>
+                    <a:srgbClr val="A95120"/>
                   </a:solidFill>
                   <a:latin typeface="Arial"/>
                   <a:ea typeface="Arial"/>
@@ -10974,7 +10982,7 @@
               <a:lvl5pPr>
                 <a:defRPr sz="1200" b="1">
                   <a:solidFill>
-                    <a:srgbClr val="685779"/>
+                    <a:srgbClr val="A95120"/>
                   </a:solidFill>
                   <a:latin typeface="Arial"/>
                   <a:ea typeface="Arial"/>
@@ -10984,7 +10992,7 @@
               <a:lvl6pPr>
                 <a:defRPr sz="1200" b="1">
                   <a:solidFill>
-                    <a:srgbClr val="685779"/>
+                    <a:srgbClr val="A95120"/>
                   </a:solidFill>
                   <a:latin typeface="Arial"/>
                   <a:ea typeface="Arial"/>
@@ -10994,7 +11002,7 @@
               <a:lvl7pPr>
                 <a:defRPr sz="1200" b="1">
                   <a:solidFill>
-                    <a:srgbClr val="685779"/>
+                    <a:srgbClr val="A95120"/>
                   </a:solidFill>
                   <a:latin typeface="Arial"/>
                   <a:ea typeface="Arial"/>
@@ -11004,7 +11012,7 @@
               <a:lvl8pPr>
                 <a:defRPr sz="1200" b="1">
                   <a:solidFill>
-                    <a:srgbClr val="685779"/>
+                    <a:srgbClr val="A95120"/>
                   </a:solidFill>
                   <a:latin typeface="Arial"/>
                   <a:ea typeface="Arial"/>
@@ -11014,7 +11022,7 @@
               <a:lvl9pPr>
                 <a:defRPr sz="1200" b="1">
                   <a:solidFill>
-                    <a:srgbClr val="685779"/>
+                    <a:srgbClr val="A95120"/>
                   </a:solidFill>
                   <a:latin typeface="Arial"/>
                   <a:ea typeface="Arial"/>
@@ -11026,7 +11034,7 @@
               <a:pPr>
                 <a:defRPr sz="1200" b="1">
                   <a:solidFill>
-                    <a:srgbClr val="685779"/>
+                    <a:srgbClr val="A95120"/>
                   </a:solidFill>
                   <a:latin typeface="Arial"/>
                   <a:ea typeface="Arial"/>
@@ -11036,7 +11044,7 @@
               <a:r>
                 <a:rPr sz="1200" b="1">
                   <a:solidFill>
-                    <a:srgbClr val="685779"/>
+                    <a:srgbClr val="A95120"/>
                   </a:solidFill>
                   <a:latin typeface="Arial"/>
                   <a:ea typeface="Arial"/>
@@ -11619,11 +11627,13 @@
             <a:prstGeom xmlns:a="http://schemas.openxmlformats.org/drawingml/2006/main" prst="rect">
               <a:avLst/>
             </a:prstGeom>
-            <a:solidFill xmlns:a="http://schemas.openxmlformats.org/drawingml/2006/main">
-              <a:srgbClr val="D6DDE2"/>
-            </a:solidFill>
+            <ns0:solidFill xmlns:ns0="http://schemas.openxmlformats.org/drawingml/2006/main">
+              <ns0:srgbClr val="ECEEF0"/>
+            </ns0:solidFill>
             <a:ln xmlns:a="http://schemas.openxmlformats.org/drawingml/2006/main" w="0">
-              <a:noFill/>
+              <a:solidFill>
+                <a:srgbClr val="D3D7DB"/>
+              </a:solidFill>
               <a:prstDash val="solid"/>
             </a:ln>
           </p:spPr>
@@ -11650,12 +11660,12 @@
             <a:prstGeom xmlns:a="http://schemas.openxmlformats.org/drawingml/2006/main" prst="rect">
               <a:avLst/>
             </a:prstGeom>
-            <a:solidFill xmlns:a="http://schemas.openxmlformats.org/drawingml/2006/main">
-              <a:srgbClr val="FFFFFF"/>
-            </a:solidFill>
+            <ns0:solidFill xmlns:ns0="http://schemas.openxmlformats.org/drawingml/2006/main">
+              <ns0:srgbClr val="FBE9D8"/>
+            </ns0:solidFill>
             <a:ln xmlns:a="http://schemas.openxmlformats.org/drawingml/2006/main" w="9525">
               <a:solidFill>
-                <a:srgbClr val="D6DDE2"/>
+                <a:srgbClr val="E5C4A5"/>
               </a:solidFill>
               <a:prstDash val="solid"/>
             </a:ln>
@@ -12038,7 +12048,7 @@
               <a:defPPr>
                 <a:defRPr sz="1200" b="1">
                   <a:solidFill>
-                    <a:srgbClr val="685779"/>
+                    <a:srgbClr val="A95120"/>
                   </a:solidFill>
                   <a:latin typeface="Arial"/>
                   <a:ea typeface="Arial"/>
@@ -12048,7 +12058,7 @@
               <a:lvl1pPr>
                 <a:defRPr sz="1200" b="1">
                   <a:solidFill>
-                    <a:srgbClr val="685779"/>
+                    <a:srgbClr val="A95120"/>
                   </a:solidFill>
                   <a:latin typeface="Arial"/>
                   <a:ea typeface="Arial"/>
@@ -12058,7 +12068,7 @@
               <a:lvl2pPr>
                 <a:defRPr sz="1200" b="1">
                   <a:solidFill>
-                    <a:srgbClr val="685779"/>
+                    <a:srgbClr val="A95120"/>
                   </a:solidFill>
                   <a:latin typeface="Arial"/>
                   <a:ea typeface="Arial"/>
@@ -12068,7 +12078,7 @@
               <a:lvl3pPr>
                 <a:defRPr sz="1200" b="1">
                   <a:solidFill>
-                    <a:srgbClr val="685779"/>
+                    <a:srgbClr val="A95120"/>
                   </a:solidFill>
                   <a:latin typeface="Arial"/>
                   <a:ea typeface="Arial"/>
@@ -12078,7 +12088,7 @@
               <a:lvl4pPr>
                 <a:defRPr sz="1200" b="1">
                   <a:solidFill>
-                    <a:srgbClr val="685779"/>
+                    <a:srgbClr val="A95120"/>
                   </a:solidFill>
                   <a:latin typeface="Arial"/>
                   <a:ea typeface="Arial"/>
@@ -12088,7 +12098,7 @@
               <a:lvl5pPr>
                 <a:defRPr sz="1200" b="1">
                   <a:solidFill>
-                    <a:srgbClr val="685779"/>
+                    <a:srgbClr val="A95120"/>
                   </a:solidFill>
                   <a:latin typeface="Arial"/>
                   <a:ea typeface="Arial"/>
@@ -12098,7 +12108,7 @@
               <a:lvl6pPr>
                 <a:defRPr sz="1200" b="1">
                   <a:solidFill>
-                    <a:srgbClr val="685779"/>
+                    <a:srgbClr val="A95120"/>
                   </a:solidFill>
                   <a:latin typeface="Arial"/>
                   <a:ea typeface="Arial"/>
@@ -12108,7 +12118,7 @@
               <a:lvl7pPr>
                 <a:defRPr sz="1200" b="1">
                   <a:solidFill>
-                    <a:srgbClr val="685779"/>
+                    <a:srgbClr val="A95120"/>
                   </a:solidFill>
                   <a:latin typeface="Arial"/>
                   <a:ea typeface="Arial"/>
@@ -12118,7 +12128,7 @@
               <a:lvl8pPr>
                 <a:defRPr sz="1200" b="1">
                   <a:solidFill>
-                    <a:srgbClr val="685779"/>
+                    <a:srgbClr val="A95120"/>
                   </a:solidFill>
                   <a:latin typeface="Arial"/>
                   <a:ea typeface="Arial"/>
@@ -12128,7 +12138,7 @@
               <a:lvl9pPr>
                 <a:defRPr sz="1200" b="1">
                   <a:solidFill>
-                    <a:srgbClr val="685779"/>
+                    <a:srgbClr val="A95120"/>
                   </a:solidFill>
                   <a:latin typeface="Arial"/>
                   <a:ea typeface="Arial"/>
@@ -12140,7 +12150,7 @@
               <a:pPr>
                 <a:defRPr sz="1200" b="1">
                   <a:solidFill>
-                    <a:srgbClr val="685779"/>
+                    <a:srgbClr val="A95120"/>
                   </a:solidFill>
                   <a:latin typeface="Arial"/>
                   <a:ea typeface="Arial"/>
@@ -12150,7 +12160,7 @@
               <a:r>
                 <a:rPr sz="1200" b="1">
                   <a:solidFill>
-                    <a:srgbClr val="685779"/>
+                    <a:srgbClr val="A95120"/>
                   </a:solidFill>
                   <a:latin typeface="Arial"/>
                   <a:ea typeface="Arial"/>
@@ -12183,12 +12193,12 @@
             <a:prstGeom xmlns:a="http://schemas.openxmlformats.org/drawingml/2006/main" prst="rect">
               <a:avLst/>
             </a:prstGeom>
-            <a:solidFill xmlns:a="http://schemas.openxmlformats.org/drawingml/2006/main">
-              <a:srgbClr val="FAF6F0"/>
-            </a:solidFill>
+            <ns0:solidFill xmlns:ns0="http://schemas.openxmlformats.org/drawingml/2006/main">
+              <ns0:srgbClr val="ECEEF0"/>
+            </ns0:solidFill>
             <a:ln xmlns:a="http://schemas.openxmlformats.org/drawingml/2006/main" w="9525">
               <a:solidFill>
-                <a:srgbClr val="D6DDE2"/>
+                <a:srgbClr val="D3D7DB"/>
               </a:solidFill>
               <a:prstDash val="solid"/>
             </a:ln>
@@ -12230,7 +12240,7 @@
               <a:defPPr>
                 <a:defRPr sz="1950" b="1">
                   <a:solidFill>
-                    <a:srgbClr val="142E49"/>
+                    <a:srgbClr val="56636E"/>
                   </a:solidFill>
                   <a:latin typeface="Arial"/>
                   <a:ea typeface="Arial"/>
@@ -12240,7 +12250,7 @@
               <a:lvl1pPr>
                 <a:defRPr sz="1950" b="1">
                   <a:solidFill>
-                    <a:srgbClr val="142E49"/>
+                    <a:srgbClr val="56636E"/>
                   </a:solidFill>
                   <a:latin typeface="Arial"/>
                   <a:ea typeface="Arial"/>
@@ -12250,7 +12260,7 @@
               <a:lvl2pPr>
                 <a:defRPr sz="1950" b="1">
                   <a:solidFill>
-                    <a:srgbClr val="142E49"/>
+                    <a:srgbClr val="56636E"/>
                   </a:solidFill>
                   <a:latin typeface="Arial"/>
                   <a:ea typeface="Arial"/>
@@ -12260,7 +12270,7 @@
               <a:lvl3pPr>
                 <a:defRPr sz="1950" b="1">
                   <a:solidFill>
-                    <a:srgbClr val="142E49"/>
+                    <a:srgbClr val="56636E"/>
                   </a:solidFill>
                   <a:latin typeface="Arial"/>
                   <a:ea typeface="Arial"/>
@@ -12270,7 +12280,7 @@
               <a:lvl4pPr>
                 <a:defRPr sz="1950" b="1">
                   <a:solidFill>
-                    <a:srgbClr val="142E49"/>
+                    <a:srgbClr val="56636E"/>
                   </a:solidFill>
                   <a:latin typeface="Arial"/>
                   <a:ea typeface="Arial"/>
@@ -12280,7 +12290,7 @@
               <a:lvl5pPr>
                 <a:defRPr sz="1950" b="1">
                   <a:solidFill>
-                    <a:srgbClr val="142E49"/>
+                    <a:srgbClr val="56636E"/>
                   </a:solidFill>
                   <a:latin typeface="Arial"/>
                   <a:ea typeface="Arial"/>
@@ -12290,7 +12300,7 @@
               <a:lvl6pPr>
                 <a:defRPr sz="1950" b="1">
                   <a:solidFill>
-                    <a:srgbClr val="142E49"/>
+                    <a:srgbClr val="56636E"/>
                   </a:solidFill>
                   <a:latin typeface="Arial"/>
                   <a:ea typeface="Arial"/>
@@ -12300,7 +12310,7 @@
               <a:lvl7pPr>
                 <a:defRPr sz="1950" b="1">
                   <a:solidFill>
-                    <a:srgbClr val="142E49"/>
+                    <a:srgbClr val="56636E"/>
                   </a:solidFill>
                   <a:latin typeface="Arial"/>
                   <a:ea typeface="Arial"/>
@@ -12310,7 +12320,7 @@
               <a:lvl8pPr>
                 <a:defRPr sz="1950" b="1">
                   <a:solidFill>
-                    <a:srgbClr val="142E49"/>
+                    <a:srgbClr val="56636E"/>
                   </a:solidFill>
                   <a:latin typeface="Arial"/>
                   <a:ea typeface="Arial"/>
@@ -12320,7 +12330,7 @@
               <a:lvl9pPr>
                 <a:defRPr sz="1950" b="1">
                   <a:solidFill>
-                    <a:srgbClr val="142E49"/>
+                    <a:srgbClr val="56636E"/>
                   </a:solidFill>
                   <a:latin typeface="Arial"/>
                   <a:ea typeface="Arial"/>
@@ -12332,7 +12342,7 @@
               <a:pPr>
                 <a:defRPr sz="1950" b="1">
                   <a:solidFill>
-                    <a:srgbClr val="142E49"/>
+                    <a:srgbClr val="56636E"/>
                   </a:solidFill>
                   <a:latin typeface="Arial"/>
                   <a:ea typeface="Arial"/>
@@ -12342,7 +12352,7 @@
               <a:r>
                 <a:rPr sz="1950" b="1">
                   <a:solidFill>
-                    <a:srgbClr val="142E49"/>
+                    <a:srgbClr val="56636E"/>
                   </a:solidFill>
                   <a:latin typeface="Arial"/>
                   <a:ea typeface="Arial"/>
@@ -12389,7 +12399,7 @@
               <a:defPPr>
                 <a:defRPr sz="1650" b="0">
                   <a:solidFill>
-                    <a:srgbClr val="243746"/>
+                    <a:srgbClr val="56636E"/>
                   </a:solidFill>
                   <a:latin typeface="Arial"/>
                   <a:ea typeface="Arial"/>
@@ -12399,7 +12409,7 @@
               <a:lvl1pPr>
                 <a:defRPr sz="1650" b="0">
                   <a:solidFill>
-                    <a:srgbClr val="243746"/>
+                    <a:srgbClr val="56636E"/>
                   </a:solidFill>
                   <a:latin typeface="Arial"/>
                   <a:ea typeface="Arial"/>
@@ -12409,7 +12419,7 @@
               <a:lvl2pPr>
                 <a:defRPr sz="1650" b="0">
                   <a:solidFill>
-                    <a:srgbClr val="243746"/>
+                    <a:srgbClr val="56636E"/>
                   </a:solidFill>
                   <a:latin typeface="Arial"/>
                   <a:ea typeface="Arial"/>
@@ -12419,7 +12429,7 @@
               <a:lvl3pPr>
                 <a:defRPr sz="1650" b="0">
                   <a:solidFill>
-                    <a:srgbClr val="243746"/>
+                    <a:srgbClr val="56636E"/>
                   </a:solidFill>
                   <a:latin typeface="Arial"/>
                   <a:ea typeface="Arial"/>
@@ -12429,7 +12439,7 @@
               <a:lvl4pPr>
                 <a:defRPr sz="1650" b="0">
                   <a:solidFill>
-                    <a:srgbClr val="243746"/>
+                    <a:srgbClr val="56636E"/>
                   </a:solidFill>
                   <a:latin typeface="Arial"/>
                   <a:ea typeface="Arial"/>
@@ -12439,7 +12449,7 @@
               <a:lvl5pPr>
                 <a:defRPr sz="1650" b="0">
                   <a:solidFill>
-                    <a:srgbClr val="243746"/>
+                    <a:srgbClr val="56636E"/>
                   </a:solidFill>
                   <a:latin typeface="Arial"/>
                   <a:ea typeface="Arial"/>
@@ -12449,7 +12459,7 @@
               <a:lvl6pPr>
                 <a:defRPr sz="1650" b="0">
                   <a:solidFill>
-                    <a:srgbClr val="243746"/>
+                    <a:srgbClr val="56636E"/>
                   </a:solidFill>
                   <a:latin typeface="Arial"/>
                   <a:ea typeface="Arial"/>
@@ -12459,7 +12469,7 @@
               <a:lvl7pPr>
                 <a:defRPr sz="1650" b="0">
                   <a:solidFill>
-                    <a:srgbClr val="243746"/>
+                    <a:srgbClr val="56636E"/>
                   </a:solidFill>
                   <a:latin typeface="Arial"/>
                   <a:ea typeface="Arial"/>
@@ -12469,7 +12479,7 @@
               <a:lvl8pPr>
                 <a:defRPr sz="1650" b="0">
                   <a:solidFill>
-                    <a:srgbClr val="243746"/>
+                    <a:srgbClr val="56636E"/>
                   </a:solidFill>
                   <a:latin typeface="Arial"/>
                   <a:ea typeface="Arial"/>
@@ -12479,7 +12489,7 @@
               <a:lvl9pPr>
                 <a:defRPr sz="1650" b="0">
                   <a:solidFill>
-                    <a:srgbClr val="243746"/>
+                    <a:srgbClr val="56636E"/>
                   </a:solidFill>
                   <a:latin typeface="Arial"/>
                   <a:ea typeface="Arial"/>
@@ -12491,7 +12501,7 @@
               <a:pPr>
                 <a:defRPr sz="1650" b="0">
                   <a:solidFill>
-                    <a:srgbClr val="243746"/>
+                    <a:srgbClr val="56636E"/>
                   </a:solidFill>
                   <a:latin typeface="Arial"/>
                   <a:ea typeface="Arial"/>
@@ -12501,7 +12511,7 @@
               <a:r>
                 <a:rPr sz="1650" b="0">
                   <a:solidFill>
-                    <a:srgbClr val="243746"/>
+                    <a:srgbClr val="56636E"/>
                   </a:solidFill>
                   <a:latin typeface="Arial"/>
                   <a:ea typeface="Arial"/>
@@ -12514,7 +12524,7 @@
               <a:pPr>
                 <a:defRPr sz="1650" b="0">
                   <a:solidFill>
-                    <a:srgbClr val="243746"/>
+                    <a:srgbClr val="56636E"/>
                   </a:solidFill>
                   <a:latin typeface="Arial"/>
                   <a:ea typeface="Arial"/>
@@ -12524,7 +12534,7 @@
               <a:r>
                 <a:rPr sz="1650" b="0">
                   <a:solidFill>
-                    <a:srgbClr val="243746"/>
+                    <a:srgbClr val="56636E"/>
                   </a:solidFill>
                   <a:latin typeface="Arial"/>
                   <a:ea typeface="Arial"/>
@@ -12623,6 +12633,741 @@
           </p:spPr>
         </p:cxnSp>
       </p:grpSp>
+      <p:sp>
+        <p:nvSpPr>
+          <p:cNvPr id="85" name="legend-heading">
+            <a:extLst xmlns:a="http://schemas.openxmlformats.org/drawingml/2006/main">
+              <a:ext uri="{FF2B5EF4-FFF2-40B4-BE49-F238E27FC236}">
+                <a16:creationId xmlns:a16="http://schemas.microsoft.com/office/drawing/2014/main" id="{66B13E87-837B-454B-9022-21A01ED37FAA}"/>
+              </a:ext>
+            </a:extLst>
+          </p:cNvPr>
+          <p:cNvSpPr>
+            <a:spLocks xmlns:a="http://schemas.openxmlformats.org/drawingml/2006/main" noGrp="1"/>
+          </p:cNvSpPr>
+          <p:nvPr/>
+        </p:nvSpPr>
+        <p:spPr>
+          <a:xfrm xmlns:a="http://schemas.openxmlformats.org/drawingml/2006/main">
+            <a:off x="8124825" y="228600"/>
+            <a:ext cx="762000" cy="257175"/>
+          </a:xfrm>
+          <a:prstGeom xmlns:a="http://schemas.openxmlformats.org/drawingml/2006/main" prst="rect">
+            <a:avLst/>
+          </a:prstGeom>
+          <a:noFill xmlns:a="http://schemas.openxmlformats.org/drawingml/2006/main"/>
+          <a:ln xmlns:a="http://schemas.openxmlformats.org/drawingml/2006/main" w="0">
+            <a:noFill/>
+            <a:prstDash val="solid"/>
+          </a:ln>
+        </p:spPr>
+        <p:txBody>
+          <a:bodyPr xmlns:a="http://schemas.openxmlformats.org/drawingml/2006/main" wrap="none" lIns="0" tIns="0" rIns="0" bIns="0">
+            <a:noAutofit/>
+          </a:bodyPr>
+          <a:lstStyle xmlns:a="http://schemas.openxmlformats.org/drawingml/2006/main">
+            <a:defPPr>
+              <a:defRPr sz="1350">
+                <a:solidFill>
+                  <a:srgbClr val="53616D"/>
+                </a:solidFill>
+                <a:latin typeface="Arial"/>
+                <a:ea typeface="Arial"/>
+                <a:cs typeface="Arial"/>
+              </a:defRPr>
+            </a:defPPr>
+            <a:lvl1pPr>
+              <a:defRPr sz="1350">
+                <a:solidFill>
+                  <a:srgbClr val="53616D"/>
+                </a:solidFill>
+                <a:latin typeface="Arial"/>
+                <a:ea typeface="Arial"/>
+                <a:cs typeface="Arial"/>
+              </a:defRPr>
+            </a:lvl1pPr>
+            <a:lvl2pPr>
+              <a:defRPr sz="1350">
+                <a:solidFill>
+                  <a:srgbClr val="53616D"/>
+                </a:solidFill>
+                <a:latin typeface="Arial"/>
+                <a:ea typeface="Arial"/>
+                <a:cs typeface="Arial"/>
+              </a:defRPr>
+            </a:lvl2pPr>
+            <a:lvl3pPr>
+              <a:defRPr sz="1350">
+                <a:solidFill>
+                  <a:srgbClr val="53616D"/>
+                </a:solidFill>
+                <a:latin typeface="Arial"/>
+                <a:ea typeface="Arial"/>
+                <a:cs typeface="Arial"/>
+              </a:defRPr>
+            </a:lvl3pPr>
+            <a:lvl4pPr>
+              <a:defRPr sz="1350">
+                <a:solidFill>
+                  <a:srgbClr val="53616D"/>
+                </a:solidFill>
+                <a:latin typeface="Arial"/>
+                <a:ea typeface="Arial"/>
+                <a:cs typeface="Arial"/>
+              </a:defRPr>
+            </a:lvl4pPr>
+            <a:lvl5pPr>
+              <a:defRPr sz="1350">
+                <a:solidFill>
+                  <a:srgbClr val="53616D"/>
+                </a:solidFill>
+                <a:latin typeface="Arial"/>
+                <a:ea typeface="Arial"/>
+                <a:cs typeface="Arial"/>
+              </a:defRPr>
+            </a:lvl5pPr>
+            <a:lvl6pPr>
+              <a:defRPr sz="1350">
+                <a:solidFill>
+                  <a:srgbClr val="53616D"/>
+                </a:solidFill>
+                <a:latin typeface="Arial"/>
+                <a:ea typeface="Arial"/>
+                <a:cs typeface="Arial"/>
+              </a:defRPr>
+            </a:lvl6pPr>
+            <a:lvl7pPr>
+              <a:defRPr sz="1350">
+                <a:solidFill>
+                  <a:srgbClr val="53616D"/>
+                </a:solidFill>
+                <a:latin typeface="Arial"/>
+                <a:ea typeface="Arial"/>
+                <a:cs typeface="Arial"/>
+              </a:defRPr>
+            </a:lvl7pPr>
+            <a:lvl8pPr>
+              <a:defRPr sz="1350">
+                <a:solidFill>
+                  <a:srgbClr val="53616D"/>
+                </a:solidFill>
+                <a:latin typeface="Arial"/>
+                <a:ea typeface="Arial"/>
+                <a:cs typeface="Arial"/>
+              </a:defRPr>
+            </a:lvl8pPr>
+            <a:lvl9pPr>
+              <a:defRPr sz="1350">
+                <a:solidFill>
+                  <a:srgbClr val="53616D"/>
+                </a:solidFill>
+                <a:latin typeface="Arial"/>
+                <a:ea typeface="Arial"/>
+                <a:cs typeface="Arial"/>
+              </a:defRPr>
+            </a:lvl9pPr>
+          </a:lstStyle>
+          <a:p xmlns:a="http://schemas.openxmlformats.org/drawingml/2006/main">
+            <a:pPr>
+              <a:defRPr sz="1350">
+                <a:solidFill>
+                  <a:srgbClr val="53616D"/>
+                </a:solidFill>
+                <a:latin typeface="Arial"/>
+                <a:ea typeface="Arial"/>
+                <a:cs typeface="Arial"/>
+              </a:defRPr>
+            </a:pPr>
+            <a:r>
+              <a:rPr sz="1350">
+                <a:solidFill>
+                  <a:srgbClr val="53616D"/>
+                </a:solidFill>
+                <a:latin typeface="Arial"/>
+                <a:ea typeface="Arial"/>
+                <a:cs typeface="Arial"/>
+              </a:rPr>
+              <a:t>STATUS</a:t>
+            </a:r>
+          </a:p>
+        </p:txBody>
+      </p:sp>
+      <p:sp>
+        <p:nvSpPr>
+          <p:cNvPr id="86" name="legend-Produção">
+            <a:extLst xmlns:a="http://schemas.openxmlformats.org/drawingml/2006/main">
+              <a:ext uri="{FF2B5EF4-FFF2-40B4-BE49-F238E27FC236}">
+                <a16:creationId xmlns:a16="http://schemas.microsoft.com/office/drawing/2014/main" id="{FB67E4E4-A7A0-43FC-91CB-41C1C4F879BC}"/>
+              </a:ext>
+            </a:extLst>
+          </p:cNvPr>
+          <p:cNvSpPr>
+            <a:spLocks xmlns:a="http://schemas.openxmlformats.org/drawingml/2006/main" noGrp="1"/>
+          </p:cNvSpPr>
+          <p:nvPr/>
+        </p:nvSpPr>
+        <p:spPr>
+          <a:xfrm xmlns:a="http://schemas.openxmlformats.org/drawingml/2006/main">
+            <a:off x="9020175" y="257175"/>
+            <a:ext cx="171450" cy="171450"/>
+          </a:xfrm>
+          <a:prstGeom xmlns:a="http://schemas.openxmlformats.org/drawingml/2006/main" prst="rect">
+            <a:avLst/>
+          </a:prstGeom>
+          <a:solidFill xmlns:a="http://schemas.openxmlformats.org/drawingml/2006/main">
+            <a:srgbClr val="E2F0E7"/>
+          </a:solidFill>
+          <a:ln xmlns:a="http://schemas.openxmlformats.org/drawingml/2006/main" w="9525">
+            <a:solidFill>
+              <a:srgbClr val="B8D6C4"/>
+            </a:solidFill>
+            <a:prstDash val="solid"/>
+          </a:ln>
+        </p:spPr>
+      </p:sp>
+      <p:sp>
+        <p:nvSpPr>
+          <p:cNvPr id="87" name="legend-text-Produção">
+            <a:extLst xmlns:a="http://schemas.openxmlformats.org/drawingml/2006/main">
+              <a:ext uri="{FF2B5EF4-FFF2-40B4-BE49-F238E27FC236}">
+                <a16:creationId xmlns:a16="http://schemas.microsoft.com/office/drawing/2014/main" id="{2C8D708B-625B-4714-B6E6-30A8E9BEA554}"/>
+              </a:ext>
+            </a:extLst>
+          </p:cNvPr>
+          <p:cNvSpPr>
+            <a:spLocks xmlns:a="http://schemas.openxmlformats.org/drawingml/2006/main" noGrp="1"/>
+          </p:cNvSpPr>
+          <p:nvPr/>
+        </p:nvSpPr>
+        <p:spPr>
+          <a:xfrm xmlns:a="http://schemas.openxmlformats.org/drawingml/2006/main">
+            <a:off x="9286875" y="228600"/>
+            <a:ext cx="1238250" cy="257175"/>
+          </a:xfrm>
+          <a:prstGeom xmlns:a="http://schemas.openxmlformats.org/drawingml/2006/main" prst="rect">
+            <a:avLst/>
+          </a:prstGeom>
+          <a:noFill xmlns:a="http://schemas.openxmlformats.org/drawingml/2006/main"/>
+          <a:ln xmlns:a="http://schemas.openxmlformats.org/drawingml/2006/main" w="0">
+            <a:noFill/>
+            <a:prstDash val="solid"/>
+          </a:ln>
+        </p:spPr>
+        <p:txBody>
+          <a:bodyPr xmlns:a="http://schemas.openxmlformats.org/drawingml/2006/main" wrap="none" lIns="0" tIns="0" rIns="0" bIns="0">
+            <a:noAutofit/>
+          </a:bodyPr>
+          <a:lstStyle xmlns:a="http://schemas.openxmlformats.org/drawingml/2006/main">
+            <a:defPPr>
+              <a:defRPr sz="1350">
+                <a:solidFill>
+                  <a:srgbClr val="53616D"/>
+                </a:solidFill>
+                <a:latin typeface="Arial"/>
+                <a:ea typeface="Arial"/>
+                <a:cs typeface="Arial"/>
+              </a:defRPr>
+            </a:defPPr>
+            <a:lvl1pPr>
+              <a:defRPr sz="1350">
+                <a:solidFill>
+                  <a:srgbClr val="53616D"/>
+                </a:solidFill>
+                <a:latin typeface="Arial"/>
+                <a:ea typeface="Arial"/>
+                <a:cs typeface="Arial"/>
+              </a:defRPr>
+            </a:lvl1pPr>
+            <a:lvl2pPr>
+              <a:defRPr sz="1350">
+                <a:solidFill>
+                  <a:srgbClr val="53616D"/>
+                </a:solidFill>
+                <a:latin typeface="Arial"/>
+                <a:ea typeface="Arial"/>
+                <a:cs typeface="Arial"/>
+              </a:defRPr>
+            </a:lvl2pPr>
+            <a:lvl3pPr>
+              <a:defRPr sz="1350">
+                <a:solidFill>
+                  <a:srgbClr val="53616D"/>
+                </a:solidFill>
+                <a:latin typeface="Arial"/>
+                <a:ea typeface="Arial"/>
+                <a:cs typeface="Arial"/>
+              </a:defRPr>
+            </a:lvl3pPr>
+            <a:lvl4pPr>
+              <a:defRPr sz="1350">
+                <a:solidFill>
+                  <a:srgbClr val="53616D"/>
+                </a:solidFill>
+                <a:latin typeface="Arial"/>
+                <a:ea typeface="Arial"/>
+                <a:cs typeface="Arial"/>
+              </a:defRPr>
+            </a:lvl4pPr>
+            <a:lvl5pPr>
+              <a:defRPr sz="1350">
+                <a:solidFill>
+                  <a:srgbClr val="53616D"/>
+                </a:solidFill>
+                <a:latin typeface="Arial"/>
+                <a:ea typeface="Arial"/>
+                <a:cs typeface="Arial"/>
+              </a:defRPr>
+            </a:lvl5pPr>
+            <a:lvl6pPr>
+              <a:defRPr sz="1350">
+                <a:solidFill>
+                  <a:srgbClr val="53616D"/>
+                </a:solidFill>
+                <a:latin typeface="Arial"/>
+                <a:ea typeface="Arial"/>
+                <a:cs typeface="Arial"/>
+              </a:defRPr>
+            </a:lvl6pPr>
+            <a:lvl7pPr>
+              <a:defRPr sz="1350">
+                <a:solidFill>
+                  <a:srgbClr val="53616D"/>
+                </a:solidFill>
+                <a:latin typeface="Arial"/>
+                <a:ea typeface="Arial"/>
+                <a:cs typeface="Arial"/>
+              </a:defRPr>
+            </a:lvl7pPr>
+            <a:lvl8pPr>
+              <a:defRPr sz="1350">
+                <a:solidFill>
+                  <a:srgbClr val="53616D"/>
+                </a:solidFill>
+                <a:latin typeface="Arial"/>
+                <a:ea typeface="Arial"/>
+                <a:cs typeface="Arial"/>
+              </a:defRPr>
+            </a:lvl8pPr>
+            <a:lvl9pPr>
+              <a:defRPr sz="1350">
+                <a:solidFill>
+                  <a:srgbClr val="53616D"/>
+                </a:solidFill>
+                <a:latin typeface="Arial"/>
+                <a:ea typeface="Arial"/>
+                <a:cs typeface="Arial"/>
+              </a:defRPr>
+            </a:lvl9pPr>
+          </a:lstStyle>
+          <a:p xmlns:a="http://schemas.openxmlformats.org/drawingml/2006/main">
+            <a:pPr>
+              <a:defRPr sz="1350">
+                <a:solidFill>
+                  <a:srgbClr val="53616D"/>
+                </a:solidFill>
+                <a:latin typeface="Arial"/>
+                <a:ea typeface="Arial"/>
+                <a:cs typeface="Arial"/>
+              </a:defRPr>
+            </a:pPr>
+            <a:r>
+              <a:rPr sz="1350">
+                <a:solidFill>
+                  <a:srgbClr val="53616D"/>
+                </a:solidFill>
+                <a:latin typeface="Arial"/>
+                <a:ea typeface="Arial"/>
+                <a:cs typeface="Arial"/>
+              </a:rPr>
+              <a:t>Produção</a:t>
+            </a:r>
+          </a:p>
+        </p:txBody>
+      </p:sp>
+      <p:sp>
+        <p:nvSpPr>
+          <p:cNvPr id="88" name="legend-Modelagem">
+            <a:extLst xmlns:a="http://schemas.openxmlformats.org/drawingml/2006/main">
+              <a:ext uri="{FF2B5EF4-FFF2-40B4-BE49-F238E27FC236}">
+                <a16:creationId xmlns:a16="http://schemas.microsoft.com/office/drawing/2014/main" id="{95BD87C3-F225-460A-9FB2-3F94DA0A41F6}"/>
+              </a:ext>
+            </a:extLst>
+          </p:cNvPr>
+          <p:cNvSpPr>
+            <a:spLocks xmlns:a="http://schemas.openxmlformats.org/drawingml/2006/main" noGrp="1"/>
+          </p:cNvSpPr>
+          <p:nvPr/>
+        </p:nvSpPr>
+        <p:spPr>
+          <a:xfrm xmlns:a="http://schemas.openxmlformats.org/drawingml/2006/main">
+            <a:off x="10677525" y="257175"/>
+            <a:ext cx="171450" cy="171450"/>
+          </a:xfrm>
+          <a:prstGeom xmlns:a="http://schemas.openxmlformats.org/drawingml/2006/main" prst="rect">
+            <a:avLst/>
+          </a:prstGeom>
+          <a:solidFill xmlns:a="http://schemas.openxmlformats.org/drawingml/2006/main">
+            <a:srgbClr val="FBE9D8"/>
+          </a:solidFill>
+          <a:ln xmlns:a="http://schemas.openxmlformats.org/drawingml/2006/main" w="9525">
+            <a:solidFill>
+              <a:srgbClr val="E5C4A5"/>
+            </a:solidFill>
+            <a:prstDash val="solid"/>
+          </a:ln>
+        </p:spPr>
+      </p:sp>
+      <p:sp>
+        <p:nvSpPr>
+          <p:cNvPr id="89" name="legend-text-Modelagem">
+            <a:extLst xmlns:a="http://schemas.openxmlformats.org/drawingml/2006/main">
+              <a:ext uri="{FF2B5EF4-FFF2-40B4-BE49-F238E27FC236}">
+                <a16:creationId xmlns:a16="http://schemas.microsoft.com/office/drawing/2014/main" id="{0682C43C-EB46-4887-AE4F-EF36531E06C9}"/>
+              </a:ext>
+            </a:extLst>
+          </p:cNvPr>
+          <p:cNvSpPr>
+            <a:spLocks xmlns:a="http://schemas.openxmlformats.org/drawingml/2006/main" noGrp="1"/>
+          </p:cNvSpPr>
+          <p:nvPr/>
+        </p:nvSpPr>
+        <p:spPr>
+          <a:xfrm xmlns:a="http://schemas.openxmlformats.org/drawingml/2006/main">
+            <a:off x="10944225" y="228600"/>
+            <a:ext cx="1333500" cy="257175"/>
+          </a:xfrm>
+          <a:prstGeom xmlns:a="http://schemas.openxmlformats.org/drawingml/2006/main" prst="rect">
+            <a:avLst/>
+          </a:prstGeom>
+          <a:noFill xmlns:a="http://schemas.openxmlformats.org/drawingml/2006/main"/>
+          <a:ln xmlns:a="http://schemas.openxmlformats.org/drawingml/2006/main" w="0">
+            <a:noFill/>
+            <a:prstDash val="solid"/>
+          </a:ln>
+        </p:spPr>
+        <p:txBody>
+          <a:bodyPr xmlns:a="http://schemas.openxmlformats.org/drawingml/2006/main" wrap="none" lIns="0" tIns="0" rIns="0" bIns="0">
+            <a:noAutofit/>
+          </a:bodyPr>
+          <a:lstStyle xmlns:a="http://schemas.openxmlformats.org/drawingml/2006/main">
+            <a:defPPr>
+              <a:defRPr sz="1350">
+                <a:solidFill>
+                  <a:srgbClr val="53616D"/>
+                </a:solidFill>
+                <a:latin typeface="Arial"/>
+                <a:ea typeface="Arial"/>
+                <a:cs typeface="Arial"/>
+              </a:defRPr>
+            </a:defPPr>
+            <a:lvl1pPr>
+              <a:defRPr sz="1350">
+                <a:solidFill>
+                  <a:srgbClr val="53616D"/>
+                </a:solidFill>
+                <a:latin typeface="Arial"/>
+                <a:ea typeface="Arial"/>
+                <a:cs typeface="Arial"/>
+              </a:defRPr>
+            </a:lvl1pPr>
+            <a:lvl2pPr>
+              <a:defRPr sz="1350">
+                <a:solidFill>
+                  <a:srgbClr val="53616D"/>
+                </a:solidFill>
+                <a:latin typeface="Arial"/>
+                <a:ea typeface="Arial"/>
+                <a:cs typeface="Arial"/>
+              </a:defRPr>
+            </a:lvl2pPr>
+            <a:lvl3pPr>
+              <a:defRPr sz="1350">
+                <a:solidFill>
+                  <a:srgbClr val="53616D"/>
+                </a:solidFill>
+                <a:latin typeface="Arial"/>
+                <a:ea typeface="Arial"/>
+                <a:cs typeface="Arial"/>
+              </a:defRPr>
+            </a:lvl3pPr>
+            <a:lvl4pPr>
+              <a:defRPr sz="1350">
+                <a:solidFill>
+                  <a:srgbClr val="53616D"/>
+                </a:solidFill>
+                <a:latin typeface="Arial"/>
+                <a:ea typeface="Arial"/>
+                <a:cs typeface="Arial"/>
+              </a:defRPr>
+            </a:lvl4pPr>
+            <a:lvl5pPr>
+              <a:defRPr sz="1350">
+                <a:solidFill>
+                  <a:srgbClr val="53616D"/>
+                </a:solidFill>
+                <a:latin typeface="Arial"/>
+                <a:ea typeface="Arial"/>
+                <a:cs typeface="Arial"/>
+              </a:defRPr>
+            </a:lvl5pPr>
+            <a:lvl6pPr>
+              <a:defRPr sz="1350">
+                <a:solidFill>
+                  <a:srgbClr val="53616D"/>
+                </a:solidFill>
+                <a:latin typeface="Arial"/>
+                <a:ea typeface="Arial"/>
+                <a:cs typeface="Arial"/>
+              </a:defRPr>
+            </a:lvl6pPr>
+            <a:lvl7pPr>
+              <a:defRPr sz="1350">
+                <a:solidFill>
+                  <a:srgbClr val="53616D"/>
+                </a:solidFill>
+                <a:latin typeface="Arial"/>
+                <a:ea typeface="Arial"/>
+                <a:cs typeface="Arial"/>
+              </a:defRPr>
+            </a:lvl7pPr>
+            <a:lvl8pPr>
+              <a:defRPr sz="1350">
+                <a:solidFill>
+                  <a:srgbClr val="53616D"/>
+                </a:solidFill>
+                <a:latin typeface="Arial"/>
+                <a:ea typeface="Arial"/>
+                <a:cs typeface="Arial"/>
+              </a:defRPr>
+            </a:lvl8pPr>
+            <a:lvl9pPr>
+              <a:defRPr sz="1350">
+                <a:solidFill>
+                  <a:srgbClr val="53616D"/>
+                </a:solidFill>
+                <a:latin typeface="Arial"/>
+                <a:ea typeface="Arial"/>
+                <a:cs typeface="Arial"/>
+              </a:defRPr>
+            </a:lvl9pPr>
+          </a:lstStyle>
+          <a:p xmlns:a="http://schemas.openxmlformats.org/drawingml/2006/main">
+            <a:pPr>
+              <a:defRPr sz="1350">
+                <a:solidFill>
+                  <a:srgbClr val="53616D"/>
+                </a:solidFill>
+                <a:latin typeface="Arial"/>
+                <a:ea typeface="Arial"/>
+                <a:cs typeface="Arial"/>
+              </a:defRPr>
+            </a:pPr>
+            <a:r>
+              <a:rPr sz="1350">
+                <a:solidFill>
+                  <a:srgbClr val="53616D"/>
+                </a:solidFill>
+                <a:latin typeface="Arial"/>
+                <a:ea typeface="Arial"/>
+                <a:cs typeface="Arial"/>
+              </a:rPr>
+              <a:t>Modelagem</a:t>
+            </a:r>
+          </a:p>
+        </p:txBody>
+      </p:sp>
+      <p:sp>
+        <p:nvSpPr>
+          <p:cNvPr id="90" name="legend-Em construção">
+            <a:extLst xmlns:a="http://schemas.openxmlformats.org/drawingml/2006/main">
+              <a:ext uri="{FF2B5EF4-FFF2-40B4-BE49-F238E27FC236}">
+                <a16:creationId xmlns:a16="http://schemas.microsoft.com/office/drawing/2014/main" id="{2A85B1AC-7A48-443C-9F17-57E59FE5E6D0}"/>
+              </a:ext>
+            </a:extLst>
+          </p:cNvPr>
+          <p:cNvSpPr>
+            <a:spLocks xmlns:a="http://schemas.openxmlformats.org/drawingml/2006/main" noGrp="1"/>
+          </p:cNvSpPr>
+          <p:nvPr/>
+        </p:nvSpPr>
+        <p:spPr>
+          <a:xfrm xmlns:a="http://schemas.openxmlformats.org/drawingml/2006/main">
+            <a:off x="12477750" y="257175"/>
+            <a:ext cx="171450" cy="171450"/>
+          </a:xfrm>
+          <a:prstGeom xmlns:a="http://schemas.openxmlformats.org/drawingml/2006/main" prst="rect">
+            <a:avLst/>
+          </a:prstGeom>
+          <a:solidFill xmlns:a="http://schemas.openxmlformats.org/drawingml/2006/main">
+            <a:srgbClr val="ECEEF0"/>
+          </a:solidFill>
+          <a:ln xmlns:a="http://schemas.openxmlformats.org/drawingml/2006/main" w="9525">
+            <a:solidFill>
+              <a:srgbClr val="D3D7DB"/>
+            </a:solidFill>
+            <a:prstDash val="solid"/>
+          </a:ln>
+        </p:spPr>
+      </p:sp>
+      <p:sp>
+        <p:nvSpPr>
+          <p:cNvPr id="91" name="legend-text-Em construção">
+            <a:extLst xmlns:a="http://schemas.openxmlformats.org/drawingml/2006/main">
+              <a:ext uri="{FF2B5EF4-FFF2-40B4-BE49-F238E27FC236}">
+                <a16:creationId xmlns:a16="http://schemas.microsoft.com/office/drawing/2014/main" id="{1BE476AF-BAF7-43D2-8A37-D4C91B8789AF}"/>
+              </a:ext>
+            </a:extLst>
+          </p:cNvPr>
+          <p:cNvSpPr>
+            <a:spLocks xmlns:a="http://schemas.openxmlformats.org/drawingml/2006/main" noGrp="1"/>
+          </p:cNvSpPr>
+          <p:nvPr/>
+        </p:nvSpPr>
+        <p:spPr>
+          <a:xfrm xmlns:a="http://schemas.openxmlformats.org/drawingml/2006/main">
+            <a:off x="12744450" y="228600"/>
+            <a:ext cx="2000250" cy="257175"/>
+          </a:xfrm>
+          <a:prstGeom xmlns:a="http://schemas.openxmlformats.org/drawingml/2006/main" prst="rect">
+            <a:avLst/>
+          </a:prstGeom>
+          <a:noFill xmlns:a="http://schemas.openxmlformats.org/drawingml/2006/main"/>
+          <a:ln xmlns:a="http://schemas.openxmlformats.org/drawingml/2006/main" w="0">
+            <a:noFill/>
+            <a:prstDash val="solid"/>
+          </a:ln>
+        </p:spPr>
+        <p:txBody>
+          <a:bodyPr xmlns:a="http://schemas.openxmlformats.org/drawingml/2006/main" wrap="none" lIns="0" tIns="0" rIns="0" bIns="0">
+            <a:noAutofit/>
+          </a:bodyPr>
+          <a:lstStyle xmlns:a="http://schemas.openxmlformats.org/drawingml/2006/main">
+            <a:defPPr>
+              <a:defRPr sz="1350">
+                <a:solidFill>
+                  <a:srgbClr val="53616D"/>
+                </a:solidFill>
+                <a:latin typeface="Arial"/>
+                <a:ea typeface="Arial"/>
+                <a:cs typeface="Arial"/>
+              </a:defRPr>
+            </a:defPPr>
+            <a:lvl1pPr>
+              <a:defRPr sz="1350">
+                <a:solidFill>
+                  <a:srgbClr val="53616D"/>
+                </a:solidFill>
+                <a:latin typeface="Arial"/>
+                <a:ea typeface="Arial"/>
+                <a:cs typeface="Arial"/>
+              </a:defRPr>
+            </a:lvl1pPr>
+            <a:lvl2pPr>
+              <a:defRPr sz="1350">
+                <a:solidFill>
+                  <a:srgbClr val="53616D"/>
+                </a:solidFill>
+                <a:latin typeface="Arial"/>
+                <a:ea typeface="Arial"/>
+                <a:cs typeface="Arial"/>
+              </a:defRPr>
+            </a:lvl2pPr>
+            <a:lvl3pPr>
+              <a:defRPr sz="1350">
+                <a:solidFill>
+                  <a:srgbClr val="53616D"/>
+                </a:solidFill>
+                <a:latin typeface="Arial"/>
+                <a:ea typeface="Arial"/>
+                <a:cs typeface="Arial"/>
+              </a:defRPr>
+            </a:lvl3pPr>
+            <a:lvl4pPr>
+              <a:defRPr sz="1350">
+                <a:solidFill>
+                  <a:srgbClr val="53616D"/>
+                </a:solidFill>
+                <a:latin typeface="Arial"/>
+                <a:ea typeface="Arial"/>
+                <a:cs typeface="Arial"/>
+              </a:defRPr>
+            </a:lvl4pPr>
+            <a:lvl5pPr>
+              <a:defRPr sz="1350">
+                <a:solidFill>
+                  <a:srgbClr val="53616D"/>
+                </a:solidFill>
+                <a:latin typeface="Arial"/>
+                <a:ea typeface="Arial"/>
+                <a:cs typeface="Arial"/>
+              </a:defRPr>
+            </a:lvl5pPr>
+            <a:lvl6pPr>
+              <a:defRPr sz="1350">
+                <a:solidFill>
+                  <a:srgbClr val="53616D"/>
+                </a:solidFill>
+                <a:latin typeface="Arial"/>
+                <a:ea typeface="Arial"/>
+                <a:cs typeface="Arial"/>
+              </a:defRPr>
+            </a:lvl6pPr>
+            <a:lvl7pPr>
+              <a:defRPr sz="1350">
+                <a:solidFill>
+                  <a:srgbClr val="53616D"/>
+                </a:solidFill>
+                <a:latin typeface="Arial"/>
+                <a:ea typeface="Arial"/>
+                <a:cs typeface="Arial"/>
+              </a:defRPr>
+            </a:lvl7pPr>
+            <a:lvl8pPr>
+              <a:defRPr sz="1350">
+                <a:solidFill>
+                  <a:srgbClr val="53616D"/>
+                </a:solidFill>
+                <a:latin typeface="Arial"/>
+                <a:ea typeface="Arial"/>
+                <a:cs typeface="Arial"/>
+              </a:defRPr>
+            </a:lvl8pPr>
+            <a:lvl9pPr>
+              <a:defRPr sz="1350">
+                <a:solidFill>
+                  <a:srgbClr val="53616D"/>
+                </a:solidFill>
+                <a:latin typeface="Arial"/>
+                <a:ea typeface="Arial"/>
+                <a:cs typeface="Arial"/>
+              </a:defRPr>
+            </a:lvl9pPr>
+          </a:lstStyle>
+          <a:p xmlns:a="http://schemas.openxmlformats.org/drawingml/2006/main">
+            <a:pPr>
+              <a:defRPr sz="1350">
+                <a:solidFill>
+                  <a:srgbClr val="53616D"/>
+                </a:solidFill>
+                <a:latin typeface="Arial"/>
+                <a:ea typeface="Arial"/>
+                <a:cs typeface="Arial"/>
+              </a:defRPr>
+            </a:pPr>
+            <a:r>
+              <a:rPr sz="1350">
+                <a:solidFill>
+                  <a:srgbClr val="53616D"/>
+                </a:solidFill>
+                <a:latin typeface="Arial"/>
+                <a:ea typeface="Arial"/>
+                <a:cs typeface="Arial"/>
+              </a:rPr>
+              <a:t>Em construção</a:t>
+            </a:r>
+          </a:p>
+        </p:txBody>
+      </p:sp>
     </p:spTree>
     <p:extLst>
       <p:ext uri="{BB962C8B-B14F-4D97-AF65-F5344CB8AC3E}">

</xml_diff>

<commit_message>
docs: atualiza cores de status, setas e legenda da arquitetura Beagle
</commit_message>
<xml_diff>
--- a/projects/Arquitetura Beagle/Arquitetura_Beagle.pptx
+++ b/projects/Arquitetura Beagle/Arquitetura_Beagle.pptx
@@ -5987,14 +5987,14 @@
             <p:nvPr/>
           </p:nvCxnSpPr>
           <p:spPr>
-            <a:xfrm xmlns:a="http://schemas.openxmlformats.org/drawingml/2006/main" flipV="1">
-              <a:off x="7620000" y="7105650"/>
-              <a:ext cx="0" cy="142875"/>
+            <a:xfrm xmlns:a="http://schemas.openxmlformats.org/drawingml/2006/main" rot="0" flipH="0" flipV="1">
+              <a:off x="7620000" y="7086600"/>
+              <a:ext cx="0" cy="180975"/>
             </a:xfrm>
             <a:prstGeom xmlns:a="http://schemas.openxmlformats.org/drawingml/2006/main" prst="straightConnector1">
               <a:avLst/>
             </a:prstGeom>
-            <a:ln xmlns:a="http://schemas.openxmlformats.org/drawingml/2006/main" w="15240">
+            <a:ln xmlns:a="http://schemas.openxmlformats.org/drawingml/2006/main" w="22860">
               <a:solidFill>
                 <a:srgbClr val="A95120"/>
               </a:solidFill>
@@ -7607,14 +7607,14 @@
             <p:nvPr/>
           </p:nvCxnSpPr>
           <p:spPr>
-            <a:xfrm xmlns:a="http://schemas.openxmlformats.org/drawingml/2006/main" flipV="1">
-              <a:off x="2047875" y="6096000"/>
-              <a:ext cx="0" cy="133350"/>
+            <a:xfrm xmlns:a="http://schemas.openxmlformats.org/drawingml/2006/main" rot="0" flipH="0" flipV="1">
+              <a:off x="2047875" y="6076950"/>
+              <a:ext cx="0" cy="171450"/>
             </a:xfrm>
             <a:prstGeom xmlns:a="http://schemas.openxmlformats.org/drawingml/2006/main" prst="straightConnector1">
               <a:avLst/>
             </a:prstGeom>
-            <a:ln xmlns:a="http://schemas.openxmlformats.org/drawingml/2006/main" w="15240">
+            <a:ln xmlns:a="http://schemas.openxmlformats.org/drawingml/2006/main" w="22860">
               <a:solidFill>
                 <a:srgbClr val="142E49"/>
               </a:solidFill>
@@ -8012,11 +8012,11 @@
               <a:avLst/>
             </a:prstGeom>
             <ns0:solidFill xmlns:ns0="http://schemas.openxmlformats.org/drawingml/2006/main">
-              <ns0:srgbClr val="ECEEF0"/>
+              <ns0:srgbClr val="E3EDF8"/>
             </ns0:solidFill>
             <a:ln xmlns:a="http://schemas.openxmlformats.org/drawingml/2006/main" w="9525">
               <a:solidFill>
-                <a:srgbClr val="D3D7DB"/>
+                <a:srgbClr val="B5CBE4"/>
               </a:solidFill>
               <a:prstDash val="solid"/>
             </a:ln>
@@ -8058,7 +8058,7 @@
               <a:defPPr>
                 <a:defRPr sz="1950" b="1">
                   <a:solidFill>
-                    <a:srgbClr val="56636E"/>
+                    <a:srgbClr val="142E49"/>
                   </a:solidFill>
                   <a:latin typeface="Arial"/>
                   <a:ea typeface="Arial"/>
@@ -8068,7 +8068,7 @@
               <a:lvl1pPr>
                 <a:defRPr sz="1950" b="1">
                   <a:solidFill>
-                    <a:srgbClr val="56636E"/>
+                    <a:srgbClr val="142E49"/>
                   </a:solidFill>
                   <a:latin typeface="Arial"/>
                   <a:ea typeface="Arial"/>
@@ -8078,7 +8078,7 @@
               <a:lvl2pPr>
                 <a:defRPr sz="1950" b="1">
                   <a:solidFill>
-                    <a:srgbClr val="56636E"/>
+                    <a:srgbClr val="142E49"/>
                   </a:solidFill>
                   <a:latin typeface="Arial"/>
                   <a:ea typeface="Arial"/>
@@ -8088,7 +8088,7 @@
               <a:lvl3pPr>
                 <a:defRPr sz="1950" b="1">
                   <a:solidFill>
-                    <a:srgbClr val="56636E"/>
+                    <a:srgbClr val="142E49"/>
                   </a:solidFill>
                   <a:latin typeface="Arial"/>
                   <a:ea typeface="Arial"/>
@@ -8098,7 +8098,7 @@
               <a:lvl4pPr>
                 <a:defRPr sz="1950" b="1">
                   <a:solidFill>
-                    <a:srgbClr val="56636E"/>
+                    <a:srgbClr val="142E49"/>
                   </a:solidFill>
                   <a:latin typeface="Arial"/>
                   <a:ea typeface="Arial"/>
@@ -8108,7 +8108,7 @@
               <a:lvl5pPr>
                 <a:defRPr sz="1950" b="1">
                   <a:solidFill>
-                    <a:srgbClr val="56636E"/>
+                    <a:srgbClr val="142E49"/>
                   </a:solidFill>
                   <a:latin typeface="Arial"/>
                   <a:ea typeface="Arial"/>
@@ -8118,7 +8118,7 @@
               <a:lvl6pPr>
                 <a:defRPr sz="1950" b="1">
                   <a:solidFill>
-                    <a:srgbClr val="56636E"/>
+                    <a:srgbClr val="142E49"/>
                   </a:solidFill>
                   <a:latin typeface="Arial"/>
                   <a:ea typeface="Arial"/>
@@ -8128,7 +8128,7 @@
               <a:lvl7pPr>
                 <a:defRPr sz="1950" b="1">
                   <a:solidFill>
-                    <a:srgbClr val="56636E"/>
+                    <a:srgbClr val="142E49"/>
                   </a:solidFill>
                   <a:latin typeface="Arial"/>
                   <a:ea typeface="Arial"/>
@@ -8138,7 +8138,7 @@
               <a:lvl8pPr>
                 <a:defRPr sz="1950" b="1">
                   <a:solidFill>
-                    <a:srgbClr val="56636E"/>
+                    <a:srgbClr val="142E49"/>
                   </a:solidFill>
                   <a:latin typeface="Arial"/>
                   <a:ea typeface="Arial"/>
@@ -8148,7 +8148,7 @@
               <a:lvl9pPr>
                 <a:defRPr sz="1950" b="1">
                   <a:solidFill>
-                    <a:srgbClr val="56636E"/>
+                    <a:srgbClr val="142E49"/>
                   </a:solidFill>
                   <a:latin typeface="Arial"/>
                   <a:ea typeface="Arial"/>
@@ -8160,7 +8160,7 @@
               <a:pPr>
                 <a:defRPr sz="1950" b="1">
                   <a:solidFill>
-                    <a:srgbClr val="56636E"/>
+                    <a:srgbClr val="142E49"/>
                   </a:solidFill>
                   <a:latin typeface="Arial"/>
                   <a:ea typeface="Arial"/>
@@ -8170,7 +8170,7 @@
               <a:r>
                 <a:rPr sz="1950" b="1">
                   <a:solidFill>
-                    <a:srgbClr val="56636E"/>
+                    <a:srgbClr val="142E49"/>
                   </a:solidFill>
                   <a:latin typeface="Arial"/>
                   <a:ea typeface="Arial"/>
@@ -8217,7 +8217,7 @@
               <a:defPPr>
                 <a:defRPr sz="1650" b="0">
                   <a:solidFill>
-                    <a:srgbClr val="56636E"/>
+                    <a:srgbClr val="142E49"/>
                   </a:solidFill>
                   <a:latin typeface="Arial"/>
                   <a:ea typeface="Arial"/>
@@ -8227,7 +8227,7 @@
               <a:lvl1pPr>
                 <a:defRPr sz="1650" b="0">
                   <a:solidFill>
-                    <a:srgbClr val="56636E"/>
+                    <a:srgbClr val="142E49"/>
                   </a:solidFill>
                   <a:latin typeface="Arial"/>
                   <a:ea typeface="Arial"/>
@@ -8237,7 +8237,7 @@
               <a:lvl2pPr>
                 <a:defRPr sz="1650" b="0">
                   <a:solidFill>
-                    <a:srgbClr val="56636E"/>
+                    <a:srgbClr val="142E49"/>
                   </a:solidFill>
                   <a:latin typeface="Arial"/>
                   <a:ea typeface="Arial"/>
@@ -8247,7 +8247,7 @@
               <a:lvl3pPr>
                 <a:defRPr sz="1650" b="0">
                   <a:solidFill>
-                    <a:srgbClr val="56636E"/>
+                    <a:srgbClr val="142E49"/>
                   </a:solidFill>
                   <a:latin typeface="Arial"/>
                   <a:ea typeface="Arial"/>
@@ -8257,7 +8257,7 @@
               <a:lvl4pPr>
                 <a:defRPr sz="1650" b="0">
                   <a:solidFill>
-                    <a:srgbClr val="56636E"/>
+                    <a:srgbClr val="142E49"/>
                   </a:solidFill>
                   <a:latin typeface="Arial"/>
                   <a:ea typeface="Arial"/>
@@ -8267,7 +8267,7 @@
               <a:lvl5pPr>
                 <a:defRPr sz="1650" b="0">
                   <a:solidFill>
-                    <a:srgbClr val="56636E"/>
+                    <a:srgbClr val="142E49"/>
                   </a:solidFill>
                   <a:latin typeface="Arial"/>
                   <a:ea typeface="Arial"/>
@@ -8277,7 +8277,7 @@
               <a:lvl6pPr>
                 <a:defRPr sz="1650" b="0">
                   <a:solidFill>
-                    <a:srgbClr val="56636E"/>
+                    <a:srgbClr val="142E49"/>
                   </a:solidFill>
                   <a:latin typeface="Arial"/>
                   <a:ea typeface="Arial"/>
@@ -8287,7 +8287,7 @@
               <a:lvl7pPr>
                 <a:defRPr sz="1650" b="0">
                   <a:solidFill>
-                    <a:srgbClr val="56636E"/>
+                    <a:srgbClr val="142E49"/>
                   </a:solidFill>
                   <a:latin typeface="Arial"/>
                   <a:ea typeface="Arial"/>
@@ -8297,7 +8297,7 @@
               <a:lvl8pPr>
                 <a:defRPr sz="1650" b="0">
                   <a:solidFill>
-                    <a:srgbClr val="56636E"/>
+                    <a:srgbClr val="142E49"/>
                   </a:solidFill>
                   <a:latin typeface="Arial"/>
                   <a:ea typeface="Arial"/>
@@ -8307,7 +8307,7 @@
               <a:lvl9pPr>
                 <a:defRPr sz="1650" b="0">
                   <a:solidFill>
-                    <a:srgbClr val="56636E"/>
+                    <a:srgbClr val="142E49"/>
                   </a:solidFill>
                   <a:latin typeface="Arial"/>
                   <a:ea typeface="Arial"/>
@@ -8319,7 +8319,7 @@
               <a:pPr>
                 <a:defRPr sz="1650" b="0">
                   <a:solidFill>
-                    <a:srgbClr val="56636E"/>
+                    <a:srgbClr val="142E49"/>
                   </a:solidFill>
                   <a:latin typeface="Arial"/>
                   <a:ea typeface="Arial"/>
@@ -8329,7 +8329,7 @@
               <a:r>
                 <a:rPr sz="1650" b="0">
                   <a:solidFill>
-                    <a:srgbClr val="56636E"/>
+                    <a:srgbClr val="142E49"/>
                   </a:solidFill>
                   <a:latin typeface="Arial"/>
                   <a:ea typeface="Arial"/>
@@ -8342,7 +8342,7 @@
               <a:pPr>
                 <a:defRPr sz="1650" b="0">
                   <a:solidFill>
-                    <a:srgbClr val="56636E"/>
+                    <a:srgbClr val="142E49"/>
                   </a:solidFill>
                   <a:latin typeface="Arial"/>
                   <a:ea typeface="Arial"/>
@@ -8352,7 +8352,7 @@
               <a:r>
                 <a:rPr sz="1650" b="0">
                   <a:solidFill>
-                    <a:srgbClr val="56636E"/>
+                    <a:srgbClr val="142E49"/>
                   </a:solidFill>
                   <a:latin typeface="Arial"/>
                   <a:ea typeface="Arial"/>
@@ -8399,7 +8399,7 @@
               <a:defPPr>
                 <a:defRPr sz="1200" b="1">
                   <a:solidFill>
-                    <a:srgbClr val="68737D"/>
+                    <a:srgbClr val="315F8A"/>
                   </a:solidFill>
                   <a:latin typeface="Arial"/>
                   <a:ea typeface="Arial"/>
@@ -8409,7 +8409,7 @@
               <a:lvl1pPr>
                 <a:defRPr sz="1200" b="1">
                   <a:solidFill>
-                    <a:srgbClr val="68737D"/>
+                    <a:srgbClr val="315F8A"/>
                   </a:solidFill>
                   <a:latin typeface="Arial"/>
                   <a:ea typeface="Arial"/>
@@ -8419,7 +8419,7 @@
               <a:lvl2pPr>
                 <a:defRPr sz="1200" b="1">
                   <a:solidFill>
-                    <a:srgbClr val="68737D"/>
+                    <a:srgbClr val="315F8A"/>
                   </a:solidFill>
                   <a:latin typeface="Arial"/>
                   <a:ea typeface="Arial"/>
@@ -8429,7 +8429,7 @@
               <a:lvl3pPr>
                 <a:defRPr sz="1200" b="1">
                   <a:solidFill>
-                    <a:srgbClr val="68737D"/>
+                    <a:srgbClr val="315F8A"/>
                   </a:solidFill>
                   <a:latin typeface="Arial"/>
                   <a:ea typeface="Arial"/>
@@ -8439,7 +8439,7 @@
               <a:lvl4pPr>
                 <a:defRPr sz="1200" b="1">
                   <a:solidFill>
-                    <a:srgbClr val="68737D"/>
+                    <a:srgbClr val="315F8A"/>
                   </a:solidFill>
                   <a:latin typeface="Arial"/>
                   <a:ea typeface="Arial"/>
@@ -8449,7 +8449,7 @@
               <a:lvl5pPr>
                 <a:defRPr sz="1200" b="1">
                   <a:solidFill>
-                    <a:srgbClr val="68737D"/>
+                    <a:srgbClr val="315F8A"/>
                   </a:solidFill>
                   <a:latin typeface="Arial"/>
                   <a:ea typeface="Arial"/>
@@ -8459,7 +8459,7 @@
               <a:lvl6pPr>
                 <a:defRPr sz="1200" b="1">
                   <a:solidFill>
-                    <a:srgbClr val="68737D"/>
+                    <a:srgbClr val="315F8A"/>
                   </a:solidFill>
                   <a:latin typeface="Arial"/>
                   <a:ea typeface="Arial"/>
@@ -8469,7 +8469,7 @@
               <a:lvl7pPr>
                 <a:defRPr sz="1200" b="1">
                   <a:solidFill>
-                    <a:srgbClr val="68737D"/>
+                    <a:srgbClr val="315F8A"/>
                   </a:solidFill>
                   <a:latin typeface="Arial"/>
                   <a:ea typeface="Arial"/>
@@ -8479,7 +8479,7 @@
               <a:lvl8pPr>
                 <a:defRPr sz="1200" b="1">
                   <a:solidFill>
-                    <a:srgbClr val="68737D"/>
+                    <a:srgbClr val="315F8A"/>
                   </a:solidFill>
                   <a:latin typeface="Arial"/>
                   <a:ea typeface="Arial"/>
@@ -8489,7 +8489,7 @@
               <a:lvl9pPr>
                 <a:defRPr sz="1200" b="1">
                   <a:solidFill>
-                    <a:srgbClr val="68737D"/>
+                    <a:srgbClr val="315F8A"/>
                   </a:solidFill>
                   <a:latin typeface="Arial"/>
                   <a:ea typeface="Arial"/>
@@ -8501,7 +8501,7 @@
               <a:pPr>
                 <a:defRPr sz="1200" b="1">
                   <a:solidFill>
-                    <a:srgbClr val="68737D"/>
+                    <a:srgbClr val="315F8A"/>
                   </a:solidFill>
                   <a:latin typeface="Arial"/>
                   <a:ea typeface="Arial"/>
@@ -8511,7 +8511,7 @@
               <a:r>
                 <a:rPr sz="1200" b="1">
                   <a:solidFill>
-                    <a:srgbClr val="68737D"/>
+                    <a:srgbClr val="315F8A"/>
                   </a:solidFill>
                   <a:latin typeface="Arial"/>
                   <a:ea typeface="Arial"/>
@@ -8545,11 +8545,11 @@
               <a:avLst/>
             </a:prstGeom>
             <ns0:solidFill xmlns:ns0="http://schemas.openxmlformats.org/drawingml/2006/main">
-              <ns0:srgbClr val="FBE9D8"/>
+              <ns0:srgbClr val="ECEEF0"/>
             </ns0:solidFill>
             <a:ln xmlns:a="http://schemas.openxmlformats.org/drawingml/2006/main" w="9525">
               <a:solidFill>
-                <a:srgbClr val="E5C4A5"/>
+                <a:srgbClr val="D5DADE"/>
               </a:solidFill>
               <a:prstDash val="solid"/>
             </a:ln>
@@ -8591,7 +8591,7 @@
               <a:defPPr>
                 <a:defRPr sz="1950" b="1">
                   <a:solidFill>
-                    <a:srgbClr val="142E49"/>
+                    <a:srgbClr val="56636E"/>
                   </a:solidFill>
                   <a:latin typeface="Arial"/>
                   <a:ea typeface="Arial"/>
@@ -8601,7 +8601,7 @@
               <a:lvl1pPr>
                 <a:defRPr sz="1950" b="1">
                   <a:solidFill>
-                    <a:srgbClr val="142E49"/>
+                    <a:srgbClr val="56636E"/>
                   </a:solidFill>
                   <a:latin typeface="Arial"/>
                   <a:ea typeface="Arial"/>
@@ -8611,7 +8611,7 @@
               <a:lvl2pPr>
                 <a:defRPr sz="1950" b="1">
                   <a:solidFill>
-                    <a:srgbClr val="142E49"/>
+                    <a:srgbClr val="56636E"/>
                   </a:solidFill>
                   <a:latin typeface="Arial"/>
                   <a:ea typeface="Arial"/>
@@ -8621,7 +8621,7 @@
               <a:lvl3pPr>
                 <a:defRPr sz="1950" b="1">
                   <a:solidFill>
-                    <a:srgbClr val="142E49"/>
+                    <a:srgbClr val="56636E"/>
                   </a:solidFill>
                   <a:latin typeface="Arial"/>
                   <a:ea typeface="Arial"/>
@@ -8631,7 +8631,7 @@
               <a:lvl4pPr>
                 <a:defRPr sz="1950" b="1">
                   <a:solidFill>
-                    <a:srgbClr val="142E49"/>
+                    <a:srgbClr val="56636E"/>
                   </a:solidFill>
                   <a:latin typeface="Arial"/>
                   <a:ea typeface="Arial"/>
@@ -8641,7 +8641,7 @@
               <a:lvl5pPr>
                 <a:defRPr sz="1950" b="1">
                   <a:solidFill>
-                    <a:srgbClr val="142E49"/>
+                    <a:srgbClr val="56636E"/>
                   </a:solidFill>
                   <a:latin typeface="Arial"/>
                   <a:ea typeface="Arial"/>
@@ -8651,7 +8651,7 @@
               <a:lvl6pPr>
                 <a:defRPr sz="1950" b="1">
                   <a:solidFill>
-                    <a:srgbClr val="142E49"/>
+                    <a:srgbClr val="56636E"/>
                   </a:solidFill>
                   <a:latin typeface="Arial"/>
                   <a:ea typeface="Arial"/>
@@ -8661,7 +8661,7 @@
               <a:lvl7pPr>
                 <a:defRPr sz="1950" b="1">
                   <a:solidFill>
-                    <a:srgbClr val="142E49"/>
+                    <a:srgbClr val="56636E"/>
                   </a:solidFill>
                   <a:latin typeface="Arial"/>
                   <a:ea typeface="Arial"/>
@@ -8671,7 +8671,7 @@
               <a:lvl8pPr>
                 <a:defRPr sz="1950" b="1">
                   <a:solidFill>
-                    <a:srgbClr val="142E49"/>
+                    <a:srgbClr val="56636E"/>
                   </a:solidFill>
                   <a:latin typeface="Arial"/>
                   <a:ea typeface="Arial"/>
@@ -8681,7 +8681,7 @@
               <a:lvl9pPr>
                 <a:defRPr sz="1950" b="1">
                   <a:solidFill>
-                    <a:srgbClr val="142E49"/>
+                    <a:srgbClr val="56636E"/>
                   </a:solidFill>
                   <a:latin typeface="Arial"/>
                   <a:ea typeface="Arial"/>
@@ -8693,7 +8693,7 @@
               <a:pPr>
                 <a:defRPr sz="1950" b="1">
                   <a:solidFill>
-                    <a:srgbClr val="142E49"/>
+                    <a:srgbClr val="56636E"/>
                   </a:solidFill>
                   <a:latin typeface="Arial"/>
                   <a:ea typeface="Arial"/>
@@ -8703,7 +8703,7 @@
               <a:r>
                 <a:rPr sz="1950" b="1">
                   <a:solidFill>
-                    <a:srgbClr val="142E49"/>
+                    <a:srgbClr val="56636E"/>
                   </a:solidFill>
                   <a:latin typeface="Arial"/>
                   <a:ea typeface="Arial"/>
@@ -8750,7 +8750,7 @@
               <a:defPPr>
                 <a:defRPr sz="1575" b="0">
                   <a:solidFill>
-                    <a:srgbClr val="243746"/>
+                    <a:srgbClr val="56636E"/>
                   </a:solidFill>
                   <a:latin typeface="Arial"/>
                   <a:ea typeface="Arial"/>
@@ -8760,7 +8760,7 @@
               <a:lvl1pPr>
                 <a:defRPr sz="1575" b="0">
                   <a:solidFill>
-                    <a:srgbClr val="243746"/>
+                    <a:srgbClr val="56636E"/>
                   </a:solidFill>
                   <a:latin typeface="Arial"/>
                   <a:ea typeface="Arial"/>
@@ -8770,7 +8770,7 @@
               <a:lvl2pPr>
                 <a:defRPr sz="1575" b="0">
                   <a:solidFill>
-                    <a:srgbClr val="243746"/>
+                    <a:srgbClr val="56636E"/>
                   </a:solidFill>
                   <a:latin typeface="Arial"/>
                   <a:ea typeface="Arial"/>
@@ -8780,7 +8780,7 @@
               <a:lvl3pPr>
                 <a:defRPr sz="1575" b="0">
                   <a:solidFill>
-                    <a:srgbClr val="243746"/>
+                    <a:srgbClr val="56636E"/>
                   </a:solidFill>
                   <a:latin typeface="Arial"/>
                   <a:ea typeface="Arial"/>
@@ -8790,7 +8790,7 @@
               <a:lvl4pPr>
                 <a:defRPr sz="1575" b="0">
                   <a:solidFill>
-                    <a:srgbClr val="243746"/>
+                    <a:srgbClr val="56636E"/>
                   </a:solidFill>
                   <a:latin typeface="Arial"/>
                   <a:ea typeface="Arial"/>
@@ -8800,7 +8800,7 @@
               <a:lvl5pPr>
                 <a:defRPr sz="1575" b="0">
                   <a:solidFill>
-                    <a:srgbClr val="243746"/>
+                    <a:srgbClr val="56636E"/>
                   </a:solidFill>
                   <a:latin typeface="Arial"/>
                   <a:ea typeface="Arial"/>
@@ -8810,7 +8810,7 @@
               <a:lvl6pPr>
                 <a:defRPr sz="1575" b="0">
                   <a:solidFill>
-                    <a:srgbClr val="243746"/>
+                    <a:srgbClr val="56636E"/>
                   </a:solidFill>
                   <a:latin typeface="Arial"/>
                   <a:ea typeface="Arial"/>
@@ -8820,7 +8820,7 @@
               <a:lvl7pPr>
                 <a:defRPr sz="1575" b="0">
                   <a:solidFill>
-                    <a:srgbClr val="243746"/>
+                    <a:srgbClr val="56636E"/>
                   </a:solidFill>
                   <a:latin typeface="Arial"/>
                   <a:ea typeface="Arial"/>
@@ -8830,7 +8830,7 @@
               <a:lvl8pPr>
                 <a:defRPr sz="1575" b="0">
                   <a:solidFill>
-                    <a:srgbClr val="243746"/>
+                    <a:srgbClr val="56636E"/>
                   </a:solidFill>
                   <a:latin typeface="Arial"/>
                   <a:ea typeface="Arial"/>
@@ -8840,7 +8840,7 @@
               <a:lvl9pPr>
                 <a:defRPr sz="1575" b="0">
                   <a:solidFill>
-                    <a:srgbClr val="243746"/>
+                    <a:srgbClr val="56636E"/>
                   </a:solidFill>
                   <a:latin typeface="Arial"/>
                   <a:ea typeface="Arial"/>
@@ -8852,7 +8852,7 @@
               <a:pPr>
                 <a:defRPr sz="1575" b="0">
                   <a:solidFill>
-                    <a:srgbClr val="243746"/>
+                    <a:srgbClr val="56636E"/>
                   </a:solidFill>
                   <a:latin typeface="Arial"/>
                   <a:ea typeface="Arial"/>
@@ -8862,7 +8862,7 @@
               <a:r>
                 <a:rPr sz="1575" b="0">
                   <a:solidFill>
-                    <a:srgbClr val="243746"/>
+                    <a:srgbClr val="56636E"/>
                   </a:solidFill>
                   <a:latin typeface="Arial"/>
                   <a:ea typeface="Arial"/>
@@ -8909,7 +8909,7 @@
               <a:defPPr>
                 <a:defRPr sz="1200" b="1">
                   <a:solidFill>
-                    <a:srgbClr val="A95120"/>
+                    <a:srgbClr val="687580"/>
                   </a:solidFill>
                   <a:latin typeface="Arial"/>
                   <a:ea typeface="Arial"/>
@@ -8919,7 +8919,7 @@
               <a:lvl1pPr>
                 <a:defRPr sz="1200" b="1">
                   <a:solidFill>
-                    <a:srgbClr val="A95120"/>
+                    <a:srgbClr val="687580"/>
                   </a:solidFill>
                   <a:latin typeface="Arial"/>
                   <a:ea typeface="Arial"/>
@@ -8929,7 +8929,7 @@
               <a:lvl2pPr>
                 <a:defRPr sz="1200" b="1">
                   <a:solidFill>
-                    <a:srgbClr val="A95120"/>
+                    <a:srgbClr val="687580"/>
                   </a:solidFill>
                   <a:latin typeface="Arial"/>
                   <a:ea typeface="Arial"/>
@@ -8939,7 +8939,7 @@
               <a:lvl3pPr>
                 <a:defRPr sz="1200" b="1">
                   <a:solidFill>
-                    <a:srgbClr val="A95120"/>
+                    <a:srgbClr val="687580"/>
                   </a:solidFill>
                   <a:latin typeface="Arial"/>
                   <a:ea typeface="Arial"/>
@@ -8949,7 +8949,7 @@
               <a:lvl4pPr>
                 <a:defRPr sz="1200" b="1">
                   <a:solidFill>
-                    <a:srgbClr val="A95120"/>
+                    <a:srgbClr val="687580"/>
                   </a:solidFill>
                   <a:latin typeface="Arial"/>
                   <a:ea typeface="Arial"/>
@@ -8959,7 +8959,7 @@
               <a:lvl5pPr>
                 <a:defRPr sz="1200" b="1">
                   <a:solidFill>
-                    <a:srgbClr val="A95120"/>
+                    <a:srgbClr val="687580"/>
                   </a:solidFill>
                   <a:latin typeface="Arial"/>
                   <a:ea typeface="Arial"/>
@@ -8969,7 +8969,7 @@
               <a:lvl6pPr>
                 <a:defRPr sz="1200" b="1">
                   <a:solidFill>
-                    <a:srgbClr val="A95120"/>
+                    <a:srgbClr val="687580"/>
                   </a:solidFill>
                   <a:latin typeface="Arial"/>
                   <a:ea typeface="Arial"/>
@@ -8979,7 +8979,7 @@
               <a:lvl7pPr>
                 <a:defRPr sz="1200" b="1">
                   <a:solidFill>
-                    <a:srgbClr val="A95120"/>
+                    <a:srgbClr val="687580"/>
                   </a:solidFill>
                   <a:latin typeface="Arial"/>
                   <a:ea typeface="Arial"/>
@@ -8989,7 +8989,7 @@
               <a:lvl8pPr>
                 <a:defRPr sz="1200" b="1">
                   <a:solidFill>
-                    <a:srgbClr val="A95120"/>
+                    <a:srgbClr val="687580"/>
                   </a:solidFill>
                   <a:latin typeface="Arial"/>
                   <a:ea typeface="Arial"/>
@@ -8999,7 +8999,7 @@
               <a:lvl9pPr>
                 <a:defRPr sz="1200" b="1">
                   <a:solidFill>
-                    <a:srgbClr val="A95120"/>
+                    <a:srgbClr val="687580"/>
                   </a:solidFill>
                   <a:latin typeface="Arial"/>
                   <a:ea typeface="Arial"/>
@@ -9011,7 +9011,7 @@
               <a:pPr>
                 <a:defRPr sz="1200" b="1">
                   <a:solidFill>
-                    <a:srgbClr val="A95120"/>
+                    <a:srgbClr val="687580"/>
                   </a:solidFill>
                   <a:latin typeface="Arial"/>
                   <a:ea typeface="Arial"/>
@@ -9021,7 +9021,7 @@
               <a:r>
                 <a:rPr sz="1200" b="1">
                   <a:solidFill>
-                    <a:srgbClr val="A95120"/>
+                    <a:srgbClr val="687580"/>
                   </a:solidFill>
                   <a:latin typeface="Arial"/>
                   <a:ea typeface="Arial"/>
@@ -9055,11 +9055,11 @@
               <a:avLst/>
             </a:prstGeom>
             <ns0:solidFill xmlns:ns0="http://schemas.openxmlformats.org/drawingml/2006/main">
-              <ns0:srgbClr val="ECEEF0"/>
+              <ns0:srgbClr val="E3EDF8"/>
             </ns0:solidFill>
             <a:ln xmlns:a="http://schemas.openxmlformats.org/drawingml/2006/main" w="9525">
               <a:solidFill>
-                <a:srgbClr val="D3D7DB"/>
+                <a:srgbClr val="B5CBE4"/>
               </a:solidFill>
               <a:prstDash val="solid"/>
             </a:ln>
@@ -9101,7 +9101,7 @@
               <a:defPPr>
                 <a:defRPr sz="1950" b="1">
                   <a:solidFill>
-                    <a:srgbClr val="56636E"/>
+                    <a:srgbClr val="142E49"/>
                   </a:solidFill>
                   <a:latin typeface="Arial"/>
                   <a:ea typeface="Arial"/>
@@ -9111,7 +9111,7 @@
               <a:lvl1pPr>
                 <a:defRPr sz="1950" b="1">
                   <a:solidFill>
-                    <a:srgbClr val="56636E"/>
+                    <a:srgbClr val="142E49"/>
                   </a:solidFill>
                   <a:latin typeface="Arial"/>
                   <a:ea typeface="Arial"/>
@@ -9121,7 +9121,7 @@
               <a:lvl2pPr>
                 <a:defRPr sz="1950" b="1">
                   <a:solidFill>
-                    <a:srgbClr val="56636E"/>
+                    <a:srgbClr val="142E49"/>
                   </a:solidFill>
                   <a:latin typeface="Arial"/>
                   <a:ea typeface="Arial"/>
@@ -9131,7 +9131,7 @@
               <a:lvl3pPr>
                 <a:defRPr sz="1950" b="1">
                   <a:solidFill>
-                    <a:srgbClr val="56636E"/>
+                    <a:srgbClr val="142E49"/>
                   </a:solidFill>
                   <a:latin typeface="Arial"/>
                   <a:ea typeface="Arial"/>
@@ -9141,7 +9141,7 @@
               <a:lvl4pPr>
                 <a:defRPr sz="1950" b="1">
                   <a:solidFill>
-                    <a:srgbClr val="56636E"/>
+                    <a:srgbClr val="142E49"/>
                   </a:solidFill>
                   <a:latin typeface="Arial"/>
                   <a:ea typeface="Arial"/>
@@ -9151,7 +9151,7 @@
               <a:lvl5pPr>
                 <a:defRPr sz="1950" b="1">
                   <a:solidFill>
-                    <a:srgbClr val="56636E"/>
+                    <a:srgbClr val="142E49"/>
                   </a:solidFill>
                   <a:latin typeface="Arial"/>
                   <a:ea typeface="Arial"/>
@@ -9161,7 +9161,7 @@
               <a:lvl6pPr>
                 <a:defRPr sz="1950" b="1">
                   <a:solidFill>
-                    <a:srgbClr val="56636E"/>
+                    <a:srgbClr val="142E49"/>
                   </a:solidFill>
                   <a:latin typeface="Arial"/>
                   <a:ea typeface="Arial"/>
@@ -9171,7 +9171,7 @@
               <a:lvl7pPr>
                 <a:defRPr sz="1950" b="1">
                   <a:solidFill>
-                    <a:srgbClr val="56636E"/>
+                    <a:srgbClr val="142E49"/>
                   </a:solidFill>
                   <a:latin typeface="Arial"/>
                   <a:ea typeface="Arial"/>
@@ -9181,7 +9181,7 @@
               <a:lvl8pPr>
                 <a:defRPr sz="1950" b="1">
                   <a:solidFill>
-                    <a:srgbClr val="56636E"/>
+                    <a:srgbClr val="142E49"/>
                   </a:solidFill>
                   <a:latin typeface="Arial"/>
                   <a:ea typeface="Arial"/>
@@ -9191,7 +9191,7 @@
               <a:lvl9pPr>
                 <a:defRPr sz="1950" b="1">
                   <a:solidFill>
-                    <a:srgbClr val="56636E"/>
+                    <a:srgbClr val="142E49"/>
                   </a:solidFill>
                   <a:latin typeface="Arial"/>
                   <a:ea typeface="Arial"/>
@@ -9203,7 +9203,7 @@
               <a:pPr>
                 <a:defRPr sz="1950" b="1">
                   <a:solidFill>
-                    <a:srgbClr val="56636E"/>
+                    <a:srgbClr val="142E49"/>
                   </a:solidFill>
                   <a:latin typeface="Arial"/>
                   <a:ea typeface="Arial"/>
@@ -9213,7 +9213,7 @@
               <a:r>
                 <a:rPr sz="1950" b="1">
                   <a:solidFill>
-                    <a:srgbClr val="56636E"/>
+                    <a:srgbClr val="142E49"/>
                   </a:solidFill>
                   <a:latin typeface="Arial"/>
                   <a:ea typeface="Arial"/>
@@ -9260,7 +9260,7 @@
               <a:defPPr>
                 <a:defRPr sz="1575" b="0">
                   <a:solidFill>
-                    <a:srgbClr val="56636E"/>
+                    <a:srgbClr val="142E49"/>
                   </a:solidFill>
                   <a:latin typeface="Arial"/>
                   <a:ea typeface="Arial"/>
@@ -9270,7 +9270,7 @@
               <a:lvl1pPr>
                 <a:defRPr sz="1575" b="0">
                   <a:solidFill>
-                    <a:srgbClr val="56636E"/>
+                    <a:srgbClr val="142E49"/>
                   </a:solidFill>
                   <a:latin typeface="Arial"/>
                   <a:ea typeface="Arial"/>
@@ -9280,7 +9280,7 @@
               <a:lvl2pPr>
                 <a:defRPr sz="1575" b="0">
                   <a:solidFill>
-                    <a:srgbClr val="56636E"/>
+                    <a:srgbClr val="142E49"/>
                   </a:solidFill>
                   <a:latin typeface="Arial"/>
                   <a:ea typeface="Arial"/>
@@ -9290,7 +9290,7 @@
               <a:lvl3pPr>
                 <a:defRPr sz="1575" b="0">
                   <a:solidFill>
-                    <a:srgbClr val="56636E"/>
+                    <a:srgbClr val="142E49"/>
                   </a:solidFill>
                   <a:latin typeface="Arial"/>
                   <a:ea typeface="Arial"/>
@@ -9300,7 +9300,7 @@
               <a:lvl4pPr>
                 <a:defRPr sz="1575" b="0">
                   <a:solidFill>
-                    <a:srgbClr val="56636E"/>
+                    <a:srgbClr val="142E49"/>
                   </a:solidFill>
                   <a:latin typeface="Arial"/>
                   <a:ea typeface="Arial"/>
@@ -9310,7 +9310,7 @@
               <a:lvl5pPr>
                 <a:defRPr sz="1575" b="0">
                   <a:solidFill>
-                    <a:srgbClr val="56636E"/>
+                    <a:srgbClr val="142E49"/>
                   </a:solidFill>
                   <a:latin typeface="Arial"/>
                   <a:ea typeface="Arial"/>
@@ -9320,7 +9320,7 @@
               <a:lvl6pPr>
                 <a:defRPr sz="1575" b="0">
                   <a:solidFill>
-                    <a:srgbClr val="56636E"/>
+                    <a:srgbClr val="142E49"/>
                   </a:solidFill>
                   <a:latin typeface="Arial"/>
                   <a:ea typeface="Arial"/>
@@ -9330,7 +9330,7 @@
               <a:lvl7pPr>
                 <a:defRPr sz="1575" b="0">
                   <a:solidFill>
-                    <a:srgbClr val="56636E"/>
+                    <a:srgbClr val="142E49"/>
                   </a:solidFill>
                   <a:latin typeface="Arial"/>
                   <a:ea typeface="Arial"/>
@@ -9340,7 +9340,7 @@
               <a:lvl8pPr>
                 <a:defRPr sz="1575" b="0">
                   <a:solidFill>
-                    <a:srgbClr val="56636E"/>
+                    <a:srgbClr val="142E49"/>
                   </a:solidFill>
                   <a:latin typeface="Arial"/>
                   <a:ea typeface="Arial"/>
@@ -9350,7 +9350,7 @@
               <a:lvl9pPr>
                 <a:defRPr sz="1575" b="0">
                   <a:solidFill>
-                    <a:srgbClr val="56636E"/>
+                    <a:srgbClr val="142E49"/>
                   </a:solidFill>
                   <a:latin typeface="Arial"/>
                   <a:ea typeface="Arial"/>
@@ -9362,7 +9362,7 @@
               <a:pPr>
                 <a:defRPr sz="1575" b="0">
                   <a:solidFill>
-                    <a:srgbClr val="56636E"/>
+                    <a:srgbClr val="142E49"/>
                   </a:solidFill>
                   <a:latin typeface="Arial"/>
                   <a:ea typeface="Arial"/>
@@ -9372,7 +9372,7 @@
               <a:r>
                 <a:rPr sz="1575" b="0">
                   <a:solidFill>
-                    <a:srgbClr val="56636E"/>
+                    <a:srgbClr val="142E49"/>
                   </a:solidFill>
                   <a:latin typeface="Arial"/>
                   <a:ea typeface="Arial"/>
@@ -9385,7 +9385,7 @@
               <a:pPr>
                 <a:defRPr sz="1575" b="0">
                   <a:solidFill>
-                    <a:srgbClr val="56636E"/>
+                    <a:srgbClr val="142E49"/>
                   </a:solidFill>
                   <a:latin typeface="Arial"/>
                   <a:ea typeface="Arial"/>
@@ -9395,7 +9395,7 @@
               <a:r>
                 <a:rPr sz="1575" b="0">
                   <a:solidFill>
-                    <a:srgbClr val="56636E"/>
+                    <a:srgbClr val="142E49"/>
                   </a:solidFill>
                   <a:latin typeface="Arial"/>
                   <a:ea typeface="Arial"/>
@@ -9442,7 +9442,7 @@
               <a:defPPr>
                 <a:defRPr sz="1200" b="1">
                   <a:solidFill>
-                    <a:srgbClr val="68737D"/>
+                    <a:srgbClr val="315F8A"/>
                   </a:solidFill>
                   <a:latin typeface="Arial"/>
                   <a:ea typeface="Arial"/>
@@ -9452,7 +9452,7 @@
               <a:lvl1pPr>
                 <a:defRPr sz="1200" b="1">
                   <a:solidFill>
-                    <a:srgbClr val="68737D"/>
+                    <a:srgbClr val="315F8A"/>
                   </a:solidFill>
                   <a:latin typeface="Arial"/>
                   <a:ea typeface="Arial"/>
@@ -9462,7 +9462,7 @@
               <a:lvl2pPr>
                 <a:defRPr sz="1200" b="1">
                   <a:solidFill>
-                    <a:srgbClr val="68737D"/>
+                    <a:srgbClr val="315F8A"/>
                   </a:solidFill>
                   <a:latin typeface="Arial"/>
                   <a:ea typeface="Arial"/>
@@ -9472,7 +9472,7 @@
               <a:lvl3pPr>
                 <a:defRPr sz="1200" b="1">
                   <a:solidFill>
-                    <a:srgbClr val="68737D"/>
+                    <a:srgbClr val="315F8A"/>
                   </a:solidFill>
                   <a:latin typeface="Arial"/>
                   <a:ea typeface="Arial"/>
@@ -9482,7 +9482,7 @@
               <a:lvl4pPr>
                 <a:defRPr sz="1200" b="1">
                   <a:solidFill>
-                    <a:srgbClr val="68737D"/>
+                    <a:srgbClr val="315F8A"/>
                   </a:solidFill>
                   <a:latin typeface="Arial"/>
                   <a:ea typeface="Arial"/>
@@ -9492,7 +9492,7 @@
               <a:lvl5pPr>
                 <a:defRPr sz="1200" b="1">
                   <a:solidFill>
-                    <a:srgbClr val="68737D"/>
+                    <a:srgbClr val="315F8A"/>
                   </a:solidFill>
                   <a:latin typeface="Arial"/>
                   <a:ea typeface="Arial"/>
@@ -9502,7 +9502,7 @@
               <a:lvl6pPr>
                 <a:defRPr sz="1200" b="1">
                   <a:solidFill>
-                    <a:srgbClr val="68737D"/>
+                    <a:srgbClr val="315F8A"/>
                   </a:solidFill>
                   <a:latin typeface="Arial"/>
                   <a:ea typeface="Arial"/>
@@ -9512,7 +9512,7 @@
               <a:lvl7pPr>
                 <a:defRPr sz="1200" b="1">
                   <a:solidFill>
-                    <a:srgbClr val="68737D"/>
+                    <a:srgbClr val="315F8A"/>
                   </a:solidFill>
                   <a:latin typeface="Arial"/>
                   <a:ea typeface="Arial"/>
@@ -9522,7 +9522,7 @@
               <a:lvl8pPr>
                 <a:defRPr sz="1200" b="1">
                   <a:solidFill>
-                    <a:srgbClr val="68737D"/>
+                    <a:srgbClr val="315F8A"/>
                   </a:solidFill>
                   <a:latin typeface="Arial"/>
                   <a:ea typeface="Arial"/>
@@ -9532,7 +9532,7 @@
               <a:lvl9pPr>
                 <a:defRPr sz="1200" b="1">
                   <a:solidFill>
-                    <a:srgbClr val="68737D"/>
+                    <a:srgbClr val="315F8A"/>
                   </a:solidFill>
                   <a:latin typeface="Arial"/>
                   <a:ea typeface="Arial"/>
@@ -9544,7 +9544,7 @@
               <a:pPr>
                 <a:defRPr sz="1200" b="1">
                   <a:solidFill>
-                    <a:srgbClr val="68737D"/>
+                    <a:srgbClr val="315F8A"/>
                   </a:solidFill>
                   <a:latin typeface="Arial"/>
                   <a:ea typeface="Arial"/>
@@ -9554,7 +9554,7 @@
               <a:r>
                 <a:rPr sz="1200" b="1">
                   <a:solidFill>
-                    <a:srgbClr val="68737D"/>
+                    <a:srgbClr val="315F8A"/>
                   </a:solidFill>
                   <a:latin typeface="Arial"/>
                   <a:ea typeface="Arial"/>
@@ -9578,14 +9578,14 @@
             <p:nvPr/>
           </p:nvCxnSpPr>
           <p:spPr>
-            <a:xfrm xmlns:a="http://schemas.openxmlformats.org/drawingml/2006/main" flipV="0">
-              <a:off x="3771900" y="3009900"/>
-              <a:ext cx="247650" cy="0"/>
+            <a:xfrm xmlns:a="http://schemas.openxmlformats.org/drawingml/2006/main" rot="0" flipH="0" flipV="0">
+              <a:off x="3743325" y="3009900"/>
+              <a:ext cx="304800" cy="0"/>
             </a:xfrm>
             <a:prstGeom xmlns:a="http://schemas.openxmlformats.org/drawingml/2006/main" prst="straightConnector1">
               <a:avLst/>
             </a:prstGeom>
-            <a:ln xmlns:a="http://schemas.openxmlformats.org/drawingml/2006/main" w="15240">
+            <a:ln xmlns:a="http://schemas.openxmlformats.org/drawingml/2006/main" w="22860">
               <a:solidFill>
                 <a:srgbClr val="142E49"/>
               </a:solidFill>
@@ -9607,14 +9607,14 @@
             <p:nvPr/>
           </p:nvCxnSpPr>
           <p:spPr>
-            <a:xfrm xmlns:a="http://schemas.openxmlformats.org/drawingml/2006/main" flipV="1">
-              <a:off x="5762625" y="6096000"/>
-              <a:ext cx="0" cy="133350"/>
+            <a:xfrm xmlns:a="http://schemas.openxmlformats.org/drawingml/2006/main" rot="0" flipH="0" flipV="1">
+              <a:off x="5762625" y="6076950"/>
+              <a:ext cx="0" cy="171450"/>
             </a:xfrm>
             <a:prstGeom xmlns:a="http://schemas.openxmlformats.org/drawingml/2006/main" prst="straightConnector1">
               <a:avLst/>
             </a:prstGeom>
-            <a:ln xmlns:a="http://schemas.openxmlformats.org/drawingml/2006/main" w="15240">
+            <a:ln xmlns:a="http://schemas.openxmlformats.org/drawingml/2006/main" w="22860">
               <a:solidFill>
                 <a:srgbClr val="142E49"/>
               </a:solidFill>
@@ -10012,11 +10012,11 @@
               <a:avLst/>
             </a:prstGeom>
             <ns0:solidFill xmlns:ns0="http://schemas.openxmlformats.org/drawingml/2006/main">
-              <ns0:srgbClr val="ECEEF0"/>
+              <ns0:srgbClr val="E3EDF8"/>
             </ns0:solidFill>
             <a:ln xmlns:a="http://schemas.openxmlformats.org/drawingml/2006/main" w="9525">
               <a:solidFill>
-                <a:srgbClr val="D3D7DB"/>
+                <a:srgbClr val="B5CBE4"/>
               </a:solidFill>
               <a:prstDash val="solid"/>
             </a:ln>
@@ -10058,7 +10058,7 @@
               <a:defPPr>
                 <a:defRPr sz="1950" b="1">
                   <a:solidFill>
-                    <a:srgbClr val="56636E"/>
+                    <a:srgbClr val="142E49"/>
                   </a:solidFill>
                   <a:latin typeface="Arial"/>
                   <a:ea typeface="Arial"/>
@@ -10068,7 +10068,7 @@
               <a:lvl1pPr>
                 <a:defRPr sz="1950" b="1">
                   <a:solidFill>
-                    <a:srgbClr val="56636E"/>
+                    <a:srgbClr val="142E49"/>
                   </a:solidFill>
                   <a:latin typeface="Arial"/>
                   <a:ea typeface="Arial"/>
@@ -10078,7 +10078,7 @@
               <a:lvl2pPr>
                 <a:defRPr sz="1950" b="1">
                   <a:solidFill>
-                    <a:srgbClr val="56636E"/>
+                    <a:srgbClr val="142E49"/>
                   </a:solidFill>
                   <a:latin typeface="Arial"/>
                   <a:ea typeface="Arial"/>
@@ -10088,7 +10088,7 @@
               <a:lvl3pPr>
                 <a:defRPr sz="1950" b="1">
                   <a:solidFill>
-                    <a:srgbClr val="56636E"/>
+                    <a:srgbClr val="142E49"/>
                   </a:solidFill>
                   <a:latin typeface="Arial"/>
                   <a:ea typeface="Arial"/>
@@ -10098,7 +10098,7 @@
               <a:lvl4pPr>
                 <a:defRPr sz="1950" b="1">
                   <a:solidFill>
-                    <a:srgbClr val="56636E"/>
+                    <a:srgbClr val="142E49"/>
                   </a:solidFill>
                   <a:latin typeface="Arial"/>
                   <a:ea typeface="Arial"/>
@@ -10108,7 +10108,7 @@
               <a:lvl5pPr>
                 <a:defRPr sz="1950" b="1">
                   <a:solidFill>
-                    <a:srgbClr val="56636E"/>
+                    <a:srgbClr val="142E49"/>
                   </a:solidFill>
                   <a:latin typeface="Arial"/>
                   <a:ea typeface="Arial"/>
@@ -10118,7 +10118,7 @@
               <a:lvl6pPr>
                 <a:defRPr sz="1950" b="1">
                   <a:solidFill>
-                    <a:srgbClr val="56636E"/>
+                    <a:srgbClr val="142E49"/>
                   </a:solidFill>
                   <a:latin typeface="Arial"/>
                   <a:ea typeface="Arial"/>
@@ -10128,7 +10128,7 @@
               <a:lvl7pPr>
                 <a:defRPr sz="1950" b="1">
                   <a:solidFill>
-                    <a:srgbClr val="56636E"/>
+                    <a:srgbClr val="142E49"/>
                   </a:solidFill>
                   <a:latin typeface="Arial"/>
                   <a:ea typeface="Arial"/>
@@ -10138,7 +10138,7 @@
               <a:lvl8pPr>
                 <a:defRPr sz="1950" b="1">
                   <a:solidFill>
-                    <a:srgbClr val="56636E"/>
+                    <a:srgbClr val="142E49"/>
                   </a:solidFill>
                   <a:latin typeface="Arial"/>
                   <a:ea typeface="Arial"/>
@@ -10148,7 +10148,7 @@
               <a:lvl9pPr>
                 <a:defRPr sz="1950" b="1">
                   <a:solidFill>
-                    <a:srgbClr val="56636E"/>
+                    <a:srgbClr val="142E49"/>
                   </a:solidFill>
                   <a:latin typeface="Arial"/>
                   <a:ea typeface="Arial"/>
@@ -10160,7 +10160,7 @@
               <a:pPr>
                 <a:defRPr sz="1950" b="1">
                   <a:solidFill>
-                    <a:srgbClr val="56636E"/>
+                    <a:srgbClr val="142E49"/>
                   </a:solidFill>
                   <a:latin typeface="Arial"/>
                   <a:ea typeface="Arial"/>
@@ -10170,7 +10170,7 @@
               <a:r>
                 <a:rPr sz="1950" b="1">
                   <a:solidFill>
-                    <a:srgbClr val="56636E"/>
+                    <a:srgbClr val="142E49"/>
                   </a:solidFill>
                   <a:latin typeface="Arial"/>
                   <a:ea typeface="Arial"/>
@@ -10217,7 +10217,7 @@
               <a:defPPr>
                 <a:defRPr sz="1650" b="0">
                   <a:solidFill>
-                    <a:srgbClr val="56636E"/>
+                    <a:srgbClr val="142E49"/>
                   </a:solidFill>
                   <a:latin typeface="Arial"/>
                   <a:ea typeface="Arial"/>
@@ -10227,7 +10227,7 @@
               <a:lvl1pPr>
                 <a:defRPr sz="1650" b="0">
                   <a:solidFill>
-                    <a:srgbClr val="56636E"/>
+                    <a:srgbClr val="142E49"/>
                   </a:solidFill>
                   <a:latin typeface="Arial"/>
                   <a:ea typeface="Arial"/>
@@ -10237,7 +10237,7 @@
               <a:lvl2pPr>
                 <a:defRPr sz="1650" b="0">
                   <a:solidFill>
-                    <a:srgbClr val="56636E"/>
+                    <a:srgbClr val="142E49"/>
                   </a:solidFill>
                   <a:latin typeface="Arial"/>
                   <a:ea typeface="Arial"/>
@@ -10247,7 +10247,7 @@
               <a:lvl3pPr>
                 <a:defRPr sz="1650" b="0">
                   <a:solidFill>
-                    <a:srgbClr val="56636E"/>
+                    <a:srgbClr val="142E49"/>
                   </a:solidFill>
                   <a:latin typeface="Arial"/>
                   <a:ea typeface="Arial"/>
@@ -10257,7 +10257,7 @@
               <a:lvl4pPr>
                 <a:defRPr sz="1650" b="0">
                   <a:solidFill>
-                    <a:srgbClr val="56636E"/>
+                    <a:srgbClr val="142E49"/>
                   </a:solidFill>
                   <a:latin typeface="Arial"/>
                   <a:ea typeface="Arial"/>
@@ -10267,7 +10267,7 @@
               <a:lvl5pPr>
                 <a:defRPr sz="1650" b="0">
                   <a:solidFill>
-                    <a:srgbClr val="56636E"/>
+                    <a:srgbClr val="142E49"/>
                   </a:solidFill>
                   <a:latin typeface="Arial"/>
                   <a:ea typeface="Arial"/>
@@ -10277,7 +10277,7 @@
               <a:lvl6pPr>
                 <a:defRPr sz="1650" b="0">
                   <a:solidFill>
-                    <a:srgbClr val="56636E"/>
+                    <a:srgbClr val="142E49"/>
                   </a:solidFill>
                   <a:latin typeface="Arial"/>
                   <a:ea typeface="Arial"/>
@@ -10287,7 +10287,7 @@
               <a:lvl7pPr>
                 <a:defRPr sz="1650" b="0">
                   <a:solidFill>
-                    <a:srgbClr val="56636E"/>
+                    <a:srgbClr val="142E49"/>
                   </a:solidFill>
                   <a:latin typeface="Arial"/>
                   <a:ea typeface="Arial"/>
@@ -10297,7 +10297,7 @@
               <a:lvl8pPr>
                 <a:defRPr sz="1650" b="0">
                   <a:solidFill>
-                    <a:srgbClr val="56636E"/>
+                    <a:srgbClr val="142E49"/>
                   </a:solidFill>
                   <a:latin typeface="Arial"/>
                   <a:ea typeface="Arial"/>
@@ -10307,7 +10307,7 @@
               <a:lvl9pPr>
                 <a:defRPr sz="1650" b="0">
                   <a:solidFill>
-                    <a:srgbClr val="56636E"/>
+                    <a:srgbClr val="142E49"/>
                   </a:solidFill>
                   <a:latin typeface="Arial"/>
                   <a:ea typeface="Arial"/>
@@ -10319,7 +10319,7 @@
               <a:pPr>
                 <a:defRPr sz="1650" b="0">
                   <a:solidFill>
-                    <a:srgbClr val="56636E"/>
+                    <a:srgbClr val="142E49"/>
                   </a:solidFill>
                   <a:latin typeface="Arial"/>
                   <a:ea typeface="Arial"/>
@@ -10329,7 +10329,7 @@
               <a:r>
                 <a:rPr sz="1650" b="0">
                   <a:solidFill>
-                    <a:srgbClr val="56636E"/>
+                    <a:srgbClr val="142E49"/>
                   </a:solidFill>
                   <a:latin typeface="Arial"/>
                   <a:ea typeface="Arial"/>
@@ -10342,7 +10342,7 @@
               <a:pPr>
                 <a:defRPr sz="1650" b="0">
                   <a:solidFill>
-                    <a:srgbClr val="56636E"/>
+                    <a:srgbClr val="142E49"/>
                   </a:solidFill>
                   <a:latin typeface="Arial"/>
                   <a:ea typeface="Arial"/>
@@ -10352,7 +10352,7 @@
               <a:r>
                 <a:rPr sz="1650" b="0">
                   <a:solidFill>
-                    <a:srgbClr val="56636E"/>
+                    <a:srgbClr val="142E49"/>
                   </a:solidFill>
                   <a:latin typeface="Arial"/>
                   <a:ea typeface="Arial"/>
@@ -10399,7 +10399,7 @@
               <a:defPPr>
                 <a:defRPr sz="1200" b="1">
                   <a:solidFill>
-                    <a:srgbClr val="68737D"/>
+                    <a:srgbClr val="315F8A"/>
                   </a:solidFill>
                   <a:latin typeface="Arial"/>
                   <a:ea typeface="Arial"/>
@@ -10409,7 +10409,7 @@
               <a:lvl1pPr>
                 <a:defRPr sz="1200" b="1">
                   <a:solidFill>
-                    <a:srgbClr val="68737D"/>
+                    <a:srgbClr val="315F8A"/>
                   </a:solidFill>
                   <a:latin typeface="Arial"/>
                   <a:ea typeface="Arial"/>
@@ -10419,7 +10419,7 @@
               <a:lvl2pPr>
                 <a:defRPr sz="1200" b="1">
                   <a:solidFill>
-                    <a:srgbClr val="68737D"/>
+                    <a:srgbClr val="315F8A"/>
                   </a:solidFill>
                   <a:latin typeface="Arial"/>
                   <a:ea typeface="Arial"/>
@@ -10429,7 +10429,7 @@
               <a:lvl3pPr>
                 <a:defRPr sz="1200" b="1">
                   <a:solidFill>
-                    <a:srgbClr val="68737D"/>
+                    <a:srgbClr val="315F8A"/>
                   </a:solidFill>
                   <a:latin typeface="Arial"/>
                   <a:ea typeface="Arial"/>
@@ -10439,7 +10439,7 @@
               <a:lvl4pPr>
                 <a:defRPr sz="1200" b="1">
                   <a:solidFill>
-                    <a:srgbClr val="68737D"/>
+                    <a:srgbClr val="315F8A"/>
                   </a:solidFill>
                   <a:latin typeface="Arial"/>
                   <a:ea typeface="Arial"/>
@@ -10449,7 +10449,7 @@
               <a:lvl5pPr>
                 <a:defRPr sz="1200" b="1">
                   <a:solidFill>
-                    <a:srgbClr val="68737D"/>
+                    <a:srgbClr val="315F8A"/>
                   </a:solidFill>
                   <a:latin typeface="Arial"/>
                   <a:ea typeface="Arial"/>
@@ -10459,7 +10459,7 @@
               <a:lvl6pPr>
                 <a:defRPr sz="1200" b="1">
                   <a:solidFill>
-                    <a:srgbClr val="68737D"/>
+                    <a:srgbClr val="315F8A"/>
                   </a:solidFill>
                   <a:latin typeface="Arial"/>
                   <a:ea typeface="Arial"/>
@@ -10469,7 +10469,7 @@
               <a:lvl7pPr>
                 <a:defRPr sz="1200" b="1">
                   <a:solidFill>
-                    <a:srgbClr val="68737D"/>
+                    <a:srgbClr val="315F8A"/>
                   </a:solidFill>
                   <a:latin typeface="Arial"/>
                   <a:ea typeface="Arial"/>
@@ -10479,7 +10479,7 @@
               <a:lvl8pPr>
                 <a:defRPr sz="1200" b="1">
                   <a:solidFill>
-                    <a:srgbClr val="68737D"/>
+                    <a:srgbClr val="315F8A"/>
                   </a:solidFill>
                   <a:latin typeface="Arial"/>
                   <a:ea typeface="Arial"/>
@@ -10489,7 +10489,7 @@
               <a:lvl9pPr>
                 <a:defRPr sz="1200" b="1">
                   <a:solidFill>
-                    <a:srgbClr val="68737D"/>
+                    <a:srgbClr val="315F8A"/>
                   </a:solidFill>
                   <a:latin typeface="Arial"/>
                   <a:ea typeface="Arial"/>
@@ -10501,7 +10501,7 @@
               <a:pPr>
                 <a:defRPr sz="1200" b="1">
                   <a:solidFill>
-                    <a:srgbClr val="68737D"/>
+                    <a:srgbClr val="315F8A"/>
                   </a:solidFill>
                   <a:latin typeface="Arial"/>
                   <a:ea typeface="Arial"/>
@@ -10511,7 +10511,7 @@
               <a:r>
                 <a:rPr sz="1200" b="1">
                   <a:solidFill>
-                    <a:srgbClr val="68737D"/>
+                    <a:srgbClr val="315F8A"/>
                   </a:solidFill>
                   <a:latin typeface="Arial"/>
                   <a:ea typeface="Arial"/>
@@ -10545,11 +10545,11 @@
               <a:avLst/>
             </a:prstGeom>
             <ns0:solidFill xmlns:ns0="http://schemas.openxmlformats.org/drawingml/2006/main">
-              <ns0:srgbClr val="FBE9D8"/>
+              <ns0:srgbClr val="ECEEF0"/>
             </ns0:solidFill>
             <a:ln xmlns:a="http://schemas.openxmlformats.org/drawingml/2006/main" w="9525">
               <a:solidFill>
-                <a:srgbClr val="E5C4A5"/>
+                <a:srgbClr val="D5DADE"/>
               </a:solidFill>
               <a:prstDash val="solid"/>
             </a:ln>
@@ -10591,7 +10591,7 @@
               <a:defPPr>
                 <a:defRPr sz="1950" b="1">
                   <a:solidFill>
-                    <a:srgbClr val="142E49"/>
+                    <a:srgbClr val="56636E"/>
                   </a:solidFill>
                   <a:latin typeface="Arial"/>
                   <a:ea typeface="Arial"/>
@@ -10601,7 +10601,7 @@
               <a:lvl1pPr>
                 <a:defRPr sz="1950" b="1">
                   <a:solidFill>
-                    <a:srgbClr val="142E49"/>
+                    <a:srgbClr val="56636E"/>
                   </a:solidFill>
                   <a:latin typeface="Arial"/>
                   <a:ea typeface="Arial"/>
@@ -10611,7 +10611,7 @@
               <a:lvl2pPr>
                 <a:defRPr sz="1950" b="1">
                   <a:solidFill>
-                    <a:srgbClr val="142E49"/>
+                    <a:srgbClr val="56636E"/>
                   </a:solidFill>
                   <a:latin typeface="Arial"/>
                   <a:ea typeface="Arial"/>
@@ -10621,7 +10621,7 @@
               <a:lvl3pPr>
                 <a:defRPr sz="1950" b="1">
                   <a:solidFill>
-                    <a:srgbClr val="142E49"/>
+                    <a:srgbClr val="56636E"/>
                   </a:solidFill>
                   <a:latin typeface="Arial"/>
                   <a:ea typeface="Arial"/>
@@ -10631,7 +10631,7 @@
               <a:lvl4pPr>
                 <a:defRPr sz="1950" b="1">
                   <a:solidFill>
-                    <a:srgbClr val="142E49"/>
+                    <a:srgbClr val="56636E"/>
                   </a:solidFill>
                   <a:latin typeface="Arial"/>
                   <a:ea typeface="Arial"/>
@@ -10641,7 +10641,7 @@
               <a:lvl5pPr>
                 <a:defRPr sz="1950" b="1">
                   <a:solidFill>
-                    <a:srgbClr val="142E49"/>
+                    <a:srgbClr val="56636E"/>
                   </a:solidFill>
                   <a:latin typeface="Arial"/>
                   <a:ea typeface="Arial"/>
@@ -10651,7 +10651,7 @@
               <a:lvl6pPr>
                 <a:defRPr sz="1950" b="1">
                   <a:solidFill>
-                    <a:srgbClr val="142E49"/>
+                    <a:srgbClr val="56636E"/>
                   </a:solidFill>
                   <a:latin typeface="Arial"/>
                   <a:ea typeface="Arial"/>
@@ -10661,7 +10661,7 @@
               <a:lvl7pPr>
                 <a:defRPr sz="1950" b="1">
                   <a:solidFill>
-                    <a:srgbClr val="142E49"/>
+                    <a:srgbClr val="56636E"/>
                   </a:solidFill>
                   <a:latin typeface="Arial"/>
                   <a:ea typeface="Arial"/>
@@ -10671,7 +10671,7 @@
               <a:lvl8pPr>
                 <a:defRPr sz="1950" b="1">
                   <a:solidFill>
-                    <a:srgbClr val="142E49"/>
+                    <a:srgbClr val="56636E"/>
                   </a:solidFill>
                   <a:latin typeface="Arial"/>
                   <a:ea typeface="Arial"/>
@@ -10681,7 +10681,7 @@
               <a:lvl9pPr>
                 <a:defRPr sz="1950" b="1">
                   <a:solidFill>
-                    <a:srgbClr val="142E49"/>
+                    <a:srgbClr val="56636E"/>
                   </a:solidFill>
                   <a:latin typeface="Arial"/>
                   <a:ea typeface="Arial"/>
@@ -10693,7 +10693,7 @@
               <a:pPr>
                 <a:defRPr sz="1950" b="1">
                   <a:solidFill>
-                    <a:srgbClr val="142E49"/>
+                    <a:srgbClr val="56636E"/>
                   </a:solidFill>
                   <a:latin typeface="Arial"/>
                   <a:ea typeface="Arial"/>
@@ -10703,7 +10703,7 @@
               <a:r>
                 <a:rPr sz="1950" b="1">
                   <a:solidFill>
-                    <a:srgbClr val="142E49"/>
+                    <a:srgbClr val="56636E"/>
                   </a:solidFill>
                   <a:latin typeface="Arial"/>
                   <a:ea typeface="Arial"/>
@@ -10750,7 +10750,7 @@
               <a:defPPr>
                 <a:defRPr sz="1650" b="0">
                   <a:solidFill>
-                    <a:srgbClr val="243746"/>
+                    <a:srgbClr val="56636E"/>
                   </a:solidFill>
                   <a:latin typeface="Arial"/>
                   <a:ea typeface="Arial"/>
@@ -10760,7 +10760,7 @@
               <a:lvl1pPr>
                 <a:defRPr sz="1650" b="0">
                   <a:solidFill>
-                    <a:srgbClr val="243746"/>
+                    <a:srgbClr val="56636E"/>
                   </a:solidFill>
                   <a:latin typeface="Arial"/>
                   <a:ea typeface="Arial"/>
@@ -10770,7 +10770,7 @@
               <a:lvl2pPr>
                 <a:defRPr sz="1650" b="0">
                   <a:solidFill>
-                    <a:srgbClr val="243746"/>
+                    <a:srgbClr val="56636E"/>
                   </a:solidFill>
                   <a:latin typeface="Arial"/>
                   <a:ea typeface="Arial"/>
@@ -10780,7 +10780,7 @@
               <a:lvl3pPr>
                 <a:defRPr sz="1650" b="0">
                   <a:solidFill>
-                    <a:srgbClr val="243746"/>
+                    <a:srgbClr val="56636E"/>
                   </a:solidFill>
                   <a:latin typeface="Arial"/>
                   <a:ea typeface="Arial"/>
@@ -10790,7 +10790,7 @@
               <a:lvl4pPr>
                 <a:defRPr sz="1650" b="0">
                   <a:solidFill>
-                    <a:srgbClr val="243746"/>
+                    <a:srgbClr val="56636E"/>
                   </a:solidFill>
                   <a:latin typeface="Arial"/>
                   <a:ea typeface="Arial"/>
@@ -10800,7 +10800,7 @@
               <a:lvl5pPr>
                 <a:defRPr sz="1650" b="0">
                   <a:solidFill>
-                    <a:srgbClr val="243746"/>
+                    <a:srgbClr val="56636E"/>
                   </a:solidFill>
                   <a:latin typeface="Arial"/>
                   <a:ea typeface="Arial"/>
@@ -10810,7 +10810,7 @@
               <a:lvl6pPr>
                 <a:defRPr sz="1650" b="0">
                   <a:solidFill>
-                    <a:srgbClr val="243746"/>
+                    <a:srgbClr val="56636E"/>
                   </a:solidFill>
                   <a:latin typeface="Arial"/>
                   <a:ea typeface="Arial"/>
@@ -10820,7 +10820,7 @@
               <a:lvl7pPr>
                 <a:defRPr sz="1650" b="0">
                   <a:solidFill>
-                    <a:srgbClr val="243746"/>
+                    <a:srgbClr val="56636E"/>
                   </a:solidFill>
                   <a:latin typeface="Arial"/>
                   <a:ea typeface="Arial"/>
@@ -10830,7 +10830,7 @@
               <a:lvl8pPr>
                 <a:defRPr sz="1650" b="0">
                   <a:solidFill>
-                    <a:srgbClr val="243746"/>
+                    <a:srgbClr val="56636E"/>
                   </a:solidFill>
                   <a:latin typeface="Arial"/>
                   <a:ea typeface="Arial"/>
@@ -10840,7 +10840,7 @@
               <a:lvl9pPr>
                 <a:defRPr sz="1650" b="0">
                   <a:solidFill>
-                    <a:srgbClr val="243746"/>
+                    <a:srgbClr val="56636E"/>
                   </a:solidFill>
                   <a:latin typeface="Arial"/>
                   <a:ea typeface="Arial"/>
@@ -10852,7 +10852,7 @@
               <a:pPr>
                 <a:defRPr sz="1650" b="0">
                   <a:solidFill>
-                    <a:srgbClr val="243746"/>
+                    <a:srgbClr val="56636E"/>
                   </a:solidFill>
                   <a:latin typeface="Arial"/>
                   <a:ea typeface="Arial"/>
@@ -10862,7 +10862,7 @@
               <a:r>
                 <a:rPr sz="1650" b="0">
                   <a:solidFill>
-                    <a:srgbClr val="243746"/>
+                    <a:srgbClr val="56636E"/>
                   </a:solidFill>
                   <a:latin typeface="Arial"/>
                   <a:ea typeface="Arial"/>
@@ -10875,7 +10875,7 @@
               <a:pPr>
                 <a:defRPr sz="1650" b="0">
                   <a:solidFill>
-                    <a:srgbClr val="243746"/>
+                    <a:srgbClr val="56636E"/>
                   </a:solidFill>
                   <a:latin typeface="Arial"/>
                   <a:ea typeface="Arial"/>
@@ -10885,7 +10885,7 @@
               <a:r>
                 <a:rPr sz="1650" b="0">
                   <a:solidFill>
-                    <a:srgbClr val="243746"/>
+                    <a:srgbClr val="56636E"/>
                   </a:solidFill>
                   <a:latin typeface="Arial"/>
                   <a:ea typeface="Arial"/>
@@ -10932,7 +10932,7 @@
               <a:defPPr>
                 <a:defRPr sz="1200" b="1">
                   <a:solidFill>
-                    <a:srgbClr val="A95120"/>
+                    <a:srgbClr val="687580"/>
                   </a:solidFill>
                   <a:latin typeface="Arial"/>
                   <a:ea typeface="Arial"/>
@@ -10942,7 +10942,7 @@
               <a:lvl1pPr>
                 <a:defRPr sz="1200" b="1">
                   <a:solidFill>
-                    <a:srgbClr val="A95120"/>
+                    <a:srgbClr val="687580"/>
                   </a:solidFill>
                   <a:latin typeface="Arial"/>
                   <a:ea typeface="Arial"/>
@@ -10952,7 +10952,7 @@
               <a:lvl2pPr>
                 <a:defRPr sz="1200" b="1">
                   <a:solidFill>
-                    <a:srgbClr val="A95120"/>
+                    <a:srgbClr val="687580"/>
                   </a:solidFill>
                   <a:latin typeface="Arial"/>
                   <a:ea typeface="Arial"/>
@@ -10962,7 +10962,7 @@
               <a:lvl3pPr>
                 <a:defRPr sz="1200" b="1">
                   <a:solidFill>
-                    <a:srgbClr val="A95120"/>
+                    <a:srgbClr val="687580"/>
                   </a:solidFill>
                   <a:latin typeface="Arial"/>
                   <a:ea typeface="Arial"/>
@@ -10972,7 +10972,7 @@
               <a:lvl4pPr>
                 <a:defRPr sz="1200" b="1">
                   <a:solidFill>
-                    <a:srgbClr val="A95120"/>
+                    <a:srgbClr val="687580"/>
                   </a:solidFill>
                   <a:latin typeface="Arial"/>
                   <a:ea typeface="Arial"/>
@@ -10982,7 +10982,7 @@
               <a:lvl5pPr>
                 <a:defRPr sz="1200" b="1">
                   <a:solidFill>
-                    <a:srgbClr val="A95120"/>
+                    <a:srgbClr val="687580"/>
                   </a:solidFill>
                   <a:latin typeface="Arial"/>
                   <a:ea typeface="Arial"/>
@@ -10992,7 +10992,7 @@
               <a:lvl6pPr>
                 <a:defRPr sz="1200" b="1">
                   <a:solidFill>
-                    <a:srgbClr val="A95120"/>
+                    <a:srgbClr val="687580"/>
                   </a:solidFill>
                   <a:latin typeface="Arial"/>
                   <a:ea typeface="Arial"/>
@@ -11002,7 +11002,7 @@
               <a:lvl7pPr>
                 <a:defRPr sz="1200" b="1">
                   <a:solidFill>
-                    <a:srgbClr val="A95120"/>
+                    <a:srgbClr val="687580"/>
                   </a:solidFill>
                   <a:latin typeface="Arial"/>
                   <a:ea typeface="Arial"/>
@@ -11012,7 +11012,7 @@
               <a:lvl8pPr>
                 <a:defRPr sz="1200" b="1">
                   <a:solidFill>
-                    <a:srgbClr val="A95120"/>
+                    <a:srgbClr val="687580"/>
                   </a:solidFill>
                   <a:latin typeface="Arial"/>
                   <a:ea typeface="Arial"/>
@@ -11022,7 +11022,7 @@
               <a:lvl9pPr>
                 <a:defRPr sz="1200" b="1">
                   <a:solidFill>
-                    <a:srgbClr val="A95120"/>
+                    <a:srgbClr val="687580"/>
                   </a:solidFill>
                   <a:latin typeface="Arial"/>
                   <a:ea typeface="Arial"/>
@@ -11034,7 +11034,7 @@
               <a:pPr>
                 <a:defRPr sz="1200" b="1">
                   <a:solidFill>
-                    <a:srgbClr val="A95120"/>
+                    <a:srgbClr val="687580"/>
                   </a:solidFill>
                   <a:latin typeface="Arial"/>
                   <a:ea typeface="Arial"/>
@@ -11044,7 +11044,7 @@
               <a:r>
                 <a:rPr sz="1200" b="1">
                   <a:solidFill>
-                    <a:srgbClr val="A95120"/>
+                    <a:srgbClr val="687580"/>
                   </a:solidFill>
                   <a:latin typeface="Arial"/>
                   <a:ea typeface="Arial"/>
@@ -11227,14 +11227,14 @@
             <p:nvPr/>
           </p:nvCxnSpPr>
           <p:spPr>
-            <a:xfrm xmlns:a="http://schemas.openxmlformats.org/drawingml/2006/main" flipV="0">
-              <a:off x="7486650" y="3009900"/>
-              <a:ext cx="247650" cy="0"/>
+            <a:xfrm xmlns:a="http://schemas.openxmlformats.org/drawingml/2006/main" rot="0" flipH="0" flipV="0">
+              <a:off x="7458075" y="3009900"/>
+              <a:ext cx="304800" cy="0"/>
             </a:xfrm>
             <a:prstGeom xmlns:a="http://schemas.openxmlformats.org/drawingml/2006/main" prst="straightConnector1">
               <a:avLst/>
             </a:prstGeom>
-            <a:ln xmlns:a="http://schemas.openxmlformats.org/drawingml/2006/main" w="15240">
+            <a:ln xmlns:a="http://schemas.openxmlformats.org/drawingml/2006/main" w="22860">
               <a:solidFill>
                 <a:srgbClr val="142E49"/>
               </a:solidFill>
@@ -11256,14 +11256,14 @@
             <p:nvPr/>
           </p:nvCxnSpPr>
           <p:spPr>
-            <a:xfrm xmlns:a="http://schemas.openxmlformats.org/drawingml/2006/main" flipV="1">
-              <a:off x="9477375" y="6096000"/>
-              <a:ext cx="0" cy="133350"/>
+            <a:xfrm xmlns:a="http://schemas.openxmlformats.org/drawingml/2006/main" rot="0" flipH="0" flipV="1">
+              <a:off x="9477375" y="6076950"/>
+              <a:ext cx="0" cy="171450"/>
             </a:xfrm>
             <a:prstGeom xmlns:a="http://schemas.openxmlformats.org/drawingml/2006/main" prst="straightConnector1">
               <a:avLst/>
             </a:prstGeom>
-            <a:ln xmlns:a="http://schemas.openxmlformats.org/drawingml/2006/main" w="15240">
+            <a:ln xmlns:a="http://schemas.openxmlformats.org/drawingml/2006/main" w="22860">
               <a:solidFill>
                 <a:srgbClr val="142E49"/>
               </a:solidFill>
@@ -11661,11 +11661,11 @@
               <a:avLst/>
             </a:prstGeom>
             <ns0:solidFill xmlns:ns0="http://schemas.openxmlformats.org/drawingml/2006/main">
-              <ns0:srgbClr val="FBE9D8"/>
+              <ns0:srgbClr val="ECEEF0"/>
             </ns0:solidFill>
             <a:ln xmlns:a="http://schemas.openxmlformats.org/drawingml/2006/main" w="9525">
               <a:solidFill>
-                <a:srgbClr val="E5C4A5"/>
+                <a:srgbClr val="D5DADE"/>
               </a:solidFill>
               <a:prstDash val="solid"/>
             </a:ln>
@@ -11707,7 +11707,7 @@
               <a:defPPr>
                 <a:defRPr sz="1950" b="1">
                   <a:solidFill>
-                    <a:srgbClr val="142E49"/>
+                    <a:srgbClr val="56636E"/>
                   </a:solidFill>
                   <a:latin typeface="Arial"/>
                   <a:ea typeface="Arial"/>
@@ -11717,7 +11717,7 @@
               <a:lvl1pPr>
                 <a:defRPr sz="1950" b="1">
                   <a:solidFill>
-                    <a:srgbClr val="142E49"/>
+                    <a:srgbClr val="56636E"/>
                   </a:solidFill>
                   <a:latin typeface="Arial"/>
                   <a:ea typeface="Arial"/>
@@ -11727,7 +11727,7 @@
               <a:lvl2pPr>
                 <a:defRPr sz="1950" b="1">
                   <a:solidFill>
-                    <a:srgbClr val="142E49"/>
+                    <a:srgbClr val="56636E"/>
                   </a:solidFill>
                   <a:latin typeface="Arial"/>
                   <a:ea typeface="Arial"/>
@@ -11737,7 +11737,7 @@
               <a:lvl3pPr>
                 <a:defRPr sz="1950" b="1">
                   <a:solidFill>
-                    <a:srgbClr val="142E49"/>
+                    <a:srgbClr val="56636E"/>
                   </a:solidFill>
                   <a:latin typeface="Arial"/>
                   <a:ea typeface="Arial"/>
@@ -11747,7 +11747,7 @@
               <a:lvl4pPr>
                 <a:defRPr sz="1950" b="1">
                   <a:solidFill>
-                    <a:srgbClr val="142E49"/>
+                    <a:srgbClr val="56636E"/>
                   </a:solidFill>
                   <a:latin typeface="Arial"/>
                   <a:ea typeface="Arial"/>
@@ -11757,7 +11757,7 @@
               <a:lvl5pPr>
                 <a:defRPr sz="1950" b="1">
                   <a:solidFill>
-                    <a:srgbClr val="142E49"/>
+                    <a:srgbClr val="56636E"/>
                   </a:solidFill>
                   <a:latin typeface="Arial"/>
                   <a:ea typeface="Arial"/>
@@ -11767,7 +11767,7 @@
               <a:lvl6pPr>
                 <a:defRPr sz="1950" b="1">
                   <a:solidFill>
-                    <a:srgbClr val="142E49"/>
+                    <a:srgbClr val="56636E"/>
                   </a:solidFill>
                   <a:latin typeface="Arial"/>
                   <a:ea typeface="Arial"/>
@@ -11777,7 +11777,7 @@
               <a:lvl7pPr>
                 <a:defRPr sz="1950" b="1">
                   <a:solidFill>
-                    <a:srgbClr val="142E49"/>
+                    <a:srgbClr val="56636E"/>
                   </a:solidFill>
                   <a:latin typeface="Arial"/>
                   <a:ea typeface="Arial"/>
@@ -11787,7 +11787,7 @@
               <a:lvl8pPr>
                 <a:defRPr sz="1950" b="1">
                   <a:solidFill>
-                    <a:srgbClr val="142E49"/>
+                    <a:srgbClr val="56636E"/>
                   </a:solidFill>
                   <a:latin typeface="Arial"/>
                   <a:ea typeface="Arial"/>
@@ -11797,7 +11797,7 @@
               <a:lvl9pPr>
                 <a:defRPr sz="1950" b="1">
                   <a:solidFill>
-                    <a:srgbClr val="142E49"/>
+                    <a:srgbClr val="56636E"/>
                   </a:solidFill>
                   <a:latin typeface="Arial"/>
                   <a:ea typeface="Arial"/>
@@ -11809,7 +11809,7 @@
               <a:pPr>
                 <a:defRPr sz="1950" b="1">
                   <a:solidFill>
-                    <a:srgbClr val="142E49"/>
+                    <a:srgbClr val="56636E"/>
                   </a:solidFill>
                   <a:latin typeface="Arial"/>
                   <a:ea typeface="Arial"/>
@@ -11819,7 +11819,7 @@
               <a:r>
                 <a:rPr sz="1950" b="1">
                   <a:solidFill>
-                    <a:srgbClr val="142E49"/>
+                    <a:srgbClr val="56636E"/>
                   </a:solidFill>
                   <a:latin typeface="Arial"/>
                   <a:ea typeface="Arial"/>
@@ -11866,7 +11866,7 @@
               <a:defPPr>
                 <a:defRPr sz="1650" b="0">
                   <a:solidFill>
-                    <a:srgbClr val="243746"/>
+                    <a:srgbClr val="56636E"/>
                   </a:solidFill>
                   <a:latin typeface="Arial"/>
                   <a:ea typeface="Arial"/>
@@ -11876,7 +11876,7 @@
               <a:lvl1pPr>
                 <a:defRPr sz="1650" b="0">
                   <a:solidFill>
-                    <a:srgbClr val="243746"/>
+                    <a:srgbClr val="56636E"/>
                   </a:solidFill>
                   <a:latin typeface="Arial"/>
                   <a:ea typeface="Arial"/>
@@ -11886,7 +11886,7 @@
               <a:lvl2pPr>
                 <a:defRPr sz="1650" b="0">
                   <a:solidFill>
-                    <a:srgbClr val="243746"/>
+                    <a:srgbClr val="56636E"/>
                   </a:solidFill>
                   <a:latin typeface="Arial"/>
                   <a:ea typeface="Arial"/>
@@ -11896,7 +11896,7 @@
               <a:lvl3pPr>
                 <a:defRPr sz="1650" b="0">
                   <a:solidFill>
-                    <a:srgbClr val="243746"/>
+                    <a:srgbClr val="56636E"/>
                   </a:solidFill>
                   <a:latin typeface="Arial"/>
                   <a:ea typeface="Arial"/>
@@ -11906,7 +11906,7 @@
               <a:lvl4pPr>
                 <a:defRPr sz="1650" b="0">
                   <a:solidFill>
-                    <a:srgbClr val="243746"/>
+                    <a:srgbClr val="56636E"/>
                   </a:solidFill>
                   <a:latin typeface="Arial"/>
                   <a:ea typeface="Arial"/>
@@ -11916,7 +11916,7 @@
               <a:lvl5pPr>
                 <a:defRPr sz="1650" b="0">
                   <a:solidFill>
-                    <a:srgbClr val="243746"/>
+                    <a:srgbClr val="56636E"/>
                   </a:solidFill>
                   <a:latin typeface="Arial"/>
                   <a:ea typeface="Arial"/>
@@ -11926,7 +11926,7 @@
               <a:lvl6pPr>
                 <a:defRPr sz="1650" b="0">
                   <a:solidFill>
-                    <a:srgbClr val="243746"/>
+                    <a:srgbClr val="56636E"/>
                   </a:solidFill>
                   <a:latin typeface="Arial"/>
                   <a:ea typeface="Arial"/>
@@ -11936,7 +11936,7 @@
               <a:lvl7pPr>
                 <a:defRPr sz="1650" b="0">
                   <a:solidFill>
-                    <a:srgbClr val="243746"/>
+                    <a:srgbClr val="56636E"/>
                   </a:solidFill>
                   <a:latin typeface="Arial"/>
                   <a:ea typeface="Arial"/>
@@ -11946,7 +11946,7 @@
               <a:lvl8pPr>
                 <a:defRPr sz="1650" b="0">
                   <a:solidFill>
-                    <a:srgbClr val="243746"/>
+                    <a:srgbClr val="56636E"/>
                   </a:solidFill>
                   <a:latin typeface="Arial"/>
                   <a:ea typeface="Arial"/>
@@ -11956,7 +11956,7 @@
               <a:lvl9pPr>
                 <a:defRPr sz="1650" b="0">
                   <a:solidFill>
-                    <a:srgbClr val="243746"/>
+                    <a:srgbClr val="56636E"/>
                   </a:solidFill>
                   <a:latin typeface="Arial"/>
                   <a:ea typeface="Arial"/>
@@ -11968,7 +11968,7 @@
               <a:pPr>
                 <a:defRPr sz="1650" b="0">
                   <a:solidFill>
-                    <a:srgbClr val="243746"/>
+                    <a:srgbClr val="56636E"/>
                   </a:solidFill>
                   <a:latin typeface="Arial"/>
                   <a:ea typeface="Arial"/>
@@ -11978,7 +11978,7 @@
               <a:r>
                 <a:rPr sz="1650" b="0">
                   <a:solidFill>
-                    <a:srgbClr val="243746"/>
+                    <a:srgbClr val="56636E"/>
                   </a:solidFill>
                   <a:latin typeface="Arial"/>
                   <a:ea typeface="Arial"/>
@@ -11991,7 +11991,7 @@
               <a:pPr>
                 <a:defRPr sz="1650" b="0">
                   <a:solidFill>
-                    <a:srgbClr val="243746"/>
+                    <a:srgbClr val="56636E"/>
                   </a:solidFill>
                   <a:latin typeface="Arial"/>
                   <a:ea typeface="Arial"/>
@@ -12001,7 +12001,7 @@
               <a:r>
                 <a:rPr sz="1650" b="0">
                   <a:solidFill>
-                    <a:srgbClr val="243746"/>
+                    <a:srgbClr val="56636E"/>
                   </a:solidFill>
                   <a:latin typeface="Arial"/>
                   <a:ea typeface="Arial"/>
@@ -12048,7 +12048,7 @@
               <a:defPPr>
                 <a:defRPr sz="1200" b="1">
                   <a:solidFill>
-                    <a:srgbClr val="A95120"/>
+                    <a:srgbClr val="687580"/>
                   </a:solidFill>
                   <a:latin typeface="Arial"/>
                   <a:ea typeface="Arial"/>
@@ -12058,7 +12058,7 @@
               <a:lvl1pPr>
                 <a:defRPr sz="1200" b="1">
                   <a:solidFill>
-                    <a:srgbClr val="A95120"/>
+                    <a:srgbClr val="687580"/>
                   </a:solidFill>
                   <a:latin typeface="Arial"/>
                   <a:ea typeface="Arial"/>
@@ -12068,7 +12068,7 @@
               <a:lvl2pPr>
                 <a:defRPr sz="1200" b="1">
                   <a:solidFill>
-                    <a:srgbClr val="A95120"/>
+                    <a:srgbClr val="687580"/>
                   </a:solidFill>
                   <a:latin typeface="Arial"/>
                   <a:ea typeface="Arial"/>
@@ -12078,7 +12078,7 @@
               <a:lvl3pPr>
                 <a:defRPr sz="1200" b="1">
                   <a:solidFill>
-                    <a:srgbClr val="A95120"/>
+                    <a:srgbClr val="687580"/>
                   </a:solidFill>
                   <a:latin typeface="Arial"/>
                   <a:ea typeface="Arial"/>
@@ -12088,7 +12088,7 @@
               <a:lvl4pPr>
                 <a:defRPr sz="1200" b="1">
                   <a:solidFill>
-                    <a:srgbClr val="A95120"/>
+                    <a:srgbClr val="687580"/>
                   </a:solidFill>
                   <a:latin typeface="Arial"/>
                   <a:ea typeface="Arial"/>
@@ -12098,7 +12098,7 @@
               <a:lvl5pPr>
                 <a:defRPr sz="1200" b="1">
                   <a:solidFill>
-                    <a:srgbClr val="A95120"/>
+                    <a:srgbClr val="687580"/>
                   </a:solidFill>
                   <a:latin typeface="Arial"/>
                   <a:ea typeface="Arial"/>
@@ -12108,7 +12108,7 @@
               <a:lvl6pPr>
                 <a:defRPr sz="1200" b="1">
                   <a:solidFill>
-                    <a:srgbClr val="A95120"/>
+                    <a:srgbClr val="687580"/>
                   </a:solidFill>
                   <a:latin typeface="Arial"/>
                   <a:ea typeface="Arial"/>
@@ -12118,7 +12118,7 @@
               <a:lvl7pPr>
                 <a:defRPr sz="1200" b="1">
                   <a:solidFill>
-                    <a:srgbClr val="A95120"/>
+                    <a:srgbClr val="687580"/>
                   </a:solidFill>
                   <a:latin typeface="Arial"/>
                   <a:ea typeface="Arial"/>
@@ -12128,7 +12128,7 @@
               <a:lvl8pPr>
                 <a:defRPr sz="1200" b="1">
                   <a:solidFill>
-                    <a:srgbClr val="A95120"/>
+                    <a:srgbClr val="687580"/>
                   </a:solidFill>
                   <a:latin typeface="Arial"/>
                   <a:ea typeface="Arial"/>
@@ -12138,7 +12138,7 @@
               <a:lvl9pPr>
                 <a:defRPr sz="1200" b="1">
                   <a:solidFill>
-                    <a:srgbClr val="A95120"/>
+                    <a:srgbClr val="687580"/>
                   </a:solidFill>
                   <a:latin typeface="Arial"/>
                   <a:ea typeface="Arial"/>
@@ -12150,7 +12150,7 @@
               <a:pPr>
                 <a:defRPr sz="1200" b="1">
                   <a:solidFill>
-                    <a:srgbClr val="A95120"/>
+                    <a:srgbClr val="687580"/>
                   </a:solidFill>
                   <a:latin typeface="Arial"/>
                   <a:ea typeface="Arial"/>
@@ -12160,7 +12160,7 @@
               <a:r>
                 <a:rPr sz="1200" b="1">
                   <a:solidFill>
-                    <a:srgbClr val="A95120"/>
+                    <a:srgbClr val="687580"/>
                   </a:solidFill>
                   <a:latin typeface="Arial"/>
                   <a:ea typeface="Arial"/>
@@ -12558,14 +12558,14 @@
             <p:nvPr/>
           </p:nvCxnSpPr>
           <p:spPr>
-            <a:xfrm xmlns:a="http://schemas.openxmlformats.org/drawingml/2006/main" flipV="0">
-              <a:off x="11201400" y="3009900"/>
-              <a:ext cx="247650" cy="0"/>
+            <a:xfrm xmlns:a="http://schemas.openxmlformats.org/drawingml/2006/main" rot="0" flipH="0" flipV="0">
+              <a:off x="11172825" y="3009900"/>
+              <a:ext cx="304800" cy="0"/>
             </a:xfrm>
             <a:prstGeom xmlns:a="http://schemas.openxmlformats.org/drawingml/2006/main" prst="straightConnector1">
               <a:avLst/>
             </a:prstGeom>
-            <a:ln xmlns:a="http://schemas.openxmlformats.org/drawingml/2006/main" w="15240">
+            <a:ln xmlns:a="http://schemas.openxmlformats.org/drawingml/2006/main" w="22860">
               <a:solidFill>
                 <a:srgbClr val="142E49"/>
               </a:solidFill>
@@ -12587,14 +12587,14 @@
             <p:nvPr/>
           </p:nvCxnSpPr>
           <p:spPr>
-            <a:xfrm xmlns:a="http://schemas.openxmlformats.org/drawingml/2006/main" flipV="0">
-              <a:off x="13192125" y="3829050"/>
-              <a:ext cx="0" cy="323850"/>
+            <a:xfrm xmlns:a="http://schemas.openxmlformats.org/drawingml/2006/main" rot="0" flipH="0" flipV="0">
+              <a:off x="13192125" y="3800475"/>
+              <a:ext cx="0" cy="381000"/>
             </a:xfrm>
             <a:prstGeom xmlns:a="http://schemas.openxmlformats.org/drawingml/2006/main" prst="straightConnector1">
               <a:avLst/>
             </a:prstGeom>
-            <a:ln xmlns:a="http://schemas.openxmlformats.org/drawingml/2006/main" w="15240">
+            <a:ln xmlns:a="http://schemas.openxmlformats.org/drawingml/2006/main" w="22860">
               <a:solidFill>
                 <a:srgbClr val="A95120"/>
               </a:solidFill>
@@ -12616,14 +12616,14 @@
             <p:nvPr/>
           </p:nvCxnSpPr>
           <p:spPr>
-            <a:xfrm xmlns:a="http://schemas.openxmlformats.org/drawingml/2006/main" flipV="1">
-              <a:off x="13192125" y="6096000"/>
-              <a:ext cx="0" cy="133350"/>
+            <a:xfrm xmlns:a="http://schemas.openxmlformats.org/drawingml/2006/main" rot="0" flipH="0" flipV="1">
+              <a:off x="13192125" y="6076950"/>
+              <a:ext cx="0" cy="171450"/>
             </a:xfrm>
             <a:prstGeom xmlns:a="http://schemas.openxmlformats.org/drawingml/2006/main" prst="straightConnector1">
               <a:avLst/>
             </a:prstGeom>
-            <a:ln xmlns:a="http://schemas.openxmlformats.org/drawingml/2006/main" w="15240">
+            <a:ln xmlns:a="http://schemas.openxmlformats.org/drawingml/2006/main" w="22860">
               <a:solidFill>
                 <a:srgbClr val="142E49"/>
               </a:solidFill>
@@ -12649,8 +12649,8 @@
         </p:nvSpPr>
         <p:spPr>
           <a:xfrm xmlns:a="http://schemas.openxmlformats.org/drawingml/2006/main">
-            <a:off x="8124825" y="228600"/>
-            <a:ext cx="762000" cy="257175"/>
+            <a:off x="7810500" y="219075"/>
+            <a:ext cx="876300" cy="304800"/>
           </a:xfrm>
           <a:prstGeom xmlns:a="http://schemas.openxmlformats.org/drawingml/2006/main" prst="rect">
             <a:avLst/>
@@ -12667,7 +12667,7 @@
           </a:bodyPr>
           <a:lstStyle xmlns:a="http://schemas.openxmlformats.org/drawingml/2006/main">
             <a:defPPr>
-              <a:defRPr sz="1350">
+              <a:defRPr sz="1500">
                 <a:solidFill>
                   <a:srgbClr val="53616D"/>
                 </a:solidFill>
@@ -12677,7 +12677,7 @@
               </a:defRPr>
             </a:defPPr>
             <a:lvl1pPr>
-              <a:defRPr sz="1350">
+              <a:defRPr sz="1500">
                 <a:solidFill>
                   <a:srgbClr val="53616D"/>
                 </a:solidFill>
@@ -12687,7 +12687,7 @@
               </a:defRPr>
             </a:lvl1pPr>
             <a:lvl2pPr>
-              <a:defRPr sz="1350">
+              <a:defRPr sz="1500">
                 <a:solidFill>
                   <a:srgbClr val="53616D"/>
                 </a:solidFill>
@@ -12697,7 +12697,7 @@
               </a:defRPr>
             </a:lvl2pPr>
             <a:lvl3pPr>
-              <a:defRPr sz="1350">
+              <a:defRPr sz="1500">
                 <a:solidFill>
                   <a:srgbClr val="53616D"/>
                 </a:solidFill>
@@ -12707,7 +12707,7 @@
               </a:defRPr>
             </a:lvl3pPr>
             <a:lvl4pPr>
-              <a:defRPr sz="1350">
+              <a:defRPr sz="1500">
                 <a:solidFill>
                   <a:srgbClr val="53616D"/>
                 </a:solidFill>
@@ -12717,7 +12717,7 @@
               </a:defRPr>
             </a:lvl4pPr>
             <a:lvl5pPr>
-              <a:defRPr sz="1350">
+              <a:defRPr sz="1500">
                 <a:solidFill>
                   <a:srgbClr val="53616D"/>
                 </a:solidFill>
@@ -12727,7 +12727,7 @@
               </a:defRPr>
             </a:lvl5pPr>
             <a:lvl6pPr>
-              <a:defRPr sz="1350">
+              <a:defRPr sz="1500">
                 <a:solidFill>
                   <a:srgbClr val="53616D"/>
                 </a:solidFill>
@@ -12737,7 +12737,7 @@
               </a:defRPr>
             </a:lvl6pPr>
             <a:lvl7pPr>
-              <a:defRPr sz="1350">
+              <a:defRPr sz="1500">
                 <a:solidFill>
                   <a:srgbClr val="53616D"/>
                 </a:solidFill>
@@ -12747,7 +12747,7 @@
               </a:defRPr>
             </a:lvl7pPr>
             <a:lvl8pPr>
-              <a:defRPr sz="1350">
+              <a:defRPr sz="1500">
                 <a:solidFill>
                   <a:srgbClr val="53616D"/>
                 </a:solidFill>
@@ -12757,7 +12757,7 @@
               </a:defRPr>
             </a:lvl8pPr>
             <a:lvl9pPr>
-              <a:defRPr sz="1350">
+              <a:defRPr sz="1500">
                 <a:solidFill>
                   <a:srgbClr val="53616D"/>
                 </a:solidFill>
@@ -12769,7 +12769,7 @@
           </a:lstStyle>
           <a:p xmlns:a="http://schemas.openxmlformats.org/drawingml/2006/main">
             <a:pPr>
-              <a:defRPr sz="1350">
+              <a:defRPr sz="1500">
                 <a:solidFill>
                   <a:srgbClr val="53616D"/>
                 </a:solidFill>
@@ -12779,7 +12779,7 @@
               </a:defRPr>
             </a:pPr>
             <a:r>
-              <a:rPr sz="1350">
+              <a:rPr sz="1500">
                 <a:solidFill>
                   <a:srgbClr val="53616D"/>
                 </a:solidFill>
@@ -12808,8 +12808,8 @@
         </p:nvSpPr>
         <p:spPr>
           <a:xfrm xmlns:a="http://schemas.openxmlformats.org/drawingml/2006/main">
-            <a:off x="9020175" y="257175"/>
-            <a:ext cx="171450" cy="171450"/>
+            <a:off x="8810625" y="247650"/>
+            <a:ext cx="209550" cy="209550"/>
           </a:xfrm>
           <a:prstGeom xmlns:a="http://schemas.openxmlformats.org/drawingml/2006/main" prst="rect">
             <a:avLst/>
@@ -12841,8 +12841,8 @@
         </p:nvSpPr>
         <p:spPr>
           <a:xfrm xmlns:a="http://schemas.openxmlformats.org/drawingml/2006/main">
-            <a:off x="9286875" y="228600"/>
-            <a:ext cx="1238250" cy="257175"/>
+            <a:off x="9144000" y="209550"/>
+            <a:ext cx="1143000" cy="333375"/>
           </a:xfrm>
           <a:prstGeom xmlns:a="http://schemas.openxmlformats.org/drawingml/2006/main" prst="rect">
             <a:avLst/>
@@ -12859,7 +12859,7 @@
           </a:bodyPr>
           <a:lstStyle xmlns:a="http://schemas.openxmlformats.org/drawingml/2006/main">
             <a:defPPr>
-              <a:defRPr sz="1350">
+              <a:defRPr sz="1650">
                 <a:solidFill>
                   <a:srgbClr val="53616D"/>
                 </a:solidFill>
@@ -12869,7 +12869,7 @@
               </a:defRPr>
             </a:defPPr>
             <a:lvl1pPr>
-              <a:defRPr sz="1350">
+              <a:defRPr sz="1650">
                 <a:solidFill>
                   <a:srgbClr val="53616D"/>
                 </a:solidFill>
@@ -12879,7 +12879,7 @@
               </a:defRPr>
             </a:lvl1pPr>
             <a:lvl2pPr>
-              <a:defRPr sz="1350">
+              <a:defRPr sz="1650">
                 <a:solidFill>
                   <a:srgbClr val="53616D"/>
                 </a:solidFill>
@@ -12889,7 +12889,7 @@
               </a:defRPr>
             </a:lvl2pPr>
             <a:lvl3pPr>
-              <a:defRPr sz="1350">
+              <a:defRPr sz="1650">
                 <a:solidFill>
                   <a:srgbClr val="53616D"/>
                 </a:solidFill>
@@ -12899,7 +12899,7 @@
               </a:defRPr>
             </a:lvl3pPr>
             <a:lvl4pPr>
-              <a:defRPr sz="1350">
+              <a:defRPr sz="1650">
                 <a:solidFill>
                   <a:srgbClr val="53616D"/>
                 </a:solidFill>
@@ -12909,7 +12909,7 @@
               </a:defRPr>
             </a:lvl4pPr>
             <a:lvl5pPr>
-              <a:defRPr sz="1350">
+              <a:defRPr sz="1650">
                 <a:solidFill>
                   <a:srgbClr val="53616D"/>
                 </a:solidFill>
@@ -12919,7 +12919,7 @@
               </a:defRPr>
             </a:lvl5pPr>
             <a:lvl6pPr>
-              <a:defRPr sz="1350">
+              <a:defRPr sz="1650">
                 <a:solidFill>
                   <a:srgbClr val="53616D"/>
                 </a:solidFill>
@@ -12929,7 +12929,7 @@
               </a:defRPr>
             </a:lvl6pPr>
             <a:lvl7pPr>
-              <a:defRPr sz="1350">
+              <a:defRPr sz="1650">
                 <a:solidFill>
                   <a:srgbClr val="53616D"/>
                 </a:solidFill>
@@ -12939,7 +12939,7 @@
               </a:defRPr>
             </a:lvl7pPr>
             <a:lvl8pPr>
-              <a:defRPr sz="1350">
+              <a:defRPr sz="1650">
                 <a:solidFill>
                   <a:srgbClr val="53616D"/>
                 </a:solidFill>
@@ -12949,7 +12949,7 @@
               </a:defRPr>
             </a:lvl8pPr>
             <a:lvl9pPr>
-              <a:defRPr sz="1350">
+              <a:defRPr sz="1650">
                 <a:solidFill>
                   <a:srgbClr val="53616D"/>
                 </a:solidFill>
@@ -12961,7 +12961,7 @@
           </a:lstStyle>
           <a:p xmlns:a="http://schemas.openxmlformats.org/drawingml/2006/main">
             <a:pPr>
-              <a:defRPr sz="1350">
+              <a:defRPr sz="1650">
                 <a:solidFill>
                   <a:srgbClr val="53616D"/>
                 </a:solidFill>
@@ -12971,7 +12971,7 @@
               </a:defRPr>
             </a:pPr>
             <a:r>
-              <a:rPr sz="1350">
+              <a:rPr sz="1650">
                 <a:solidFill>
                   <a:srgbClr val="53616D"/>
                 </a:solidFill>
@@ -13000,18 +13000,18 @@
         </p:nvSpPr>
         <p:spPr>
           <a:xfrm xmlns:a="http://schemas.openxmlformats.org/drawingml/2006/main">
-            <a:off x="10677525" y="257175"/>
-            <a:ext cx="171450" cy="171450"/>
+            <a:off x="10620375" y="247650"/>
+            <a:ext cx="209550" cy="209550"/>
           </a:xfrm>
           <a:prstGeom xmlns:a="http://schemas.openxmlformats.org/drawingml/2006/main" prst="rect">
             <a:avLst/>
           </a:prstGeom>
           <a:solidFill xmlns:a="http://schemas.openxmlformats.org/drawingml/2006/main">
-            <a:srgbClr val="FBE9D8"/>
+            <a:srgbClr val="E3EDF8"/>
           </a:solidFill>
           <a:ln xmlns:a="http://schemas.openxmlformats.org/drawingml/2006/main" w="9525">
             <a:solidFill>
-              <a:srgbClr val="E5C4A5"/>
+              <a:srgbClr val="B5CBE4"/>
             </a:solidFill>
             <a:prstDash val="solid"/>
           </a:ln>
@@ -13033,8 +13033,8 @@
         </p:nvSpPr>
         <p:spPr>
           <a:xfrm xmlns:a="http://schemas.openxmlformats.org/drawingml/2006/main">
-            <a:off x="10944225" y="228600"/>
-            <a:ext cx="1333500" cy="257175"/>
+            <a:off x="10953750" y="209550"/>
+            <a:ext cx="952500" cy="333375"/>
           </a:xfrm>
           <a:prstGeom xmlns:a="http://schemas.openxmlformats.org/drawingml/2006/main" prst="rect">
             <a:avLst/>
@@ -13051,7 +13051,7 @@
           </a:bodyPr>
           <a:lstStyle xmlns:a="http://schemas.openxmlformats.org/drawingml/2006/main">
             <a:defPPr>
-              <a:defRPr sz="1350">
+              <a:defRPr sz="1650">
                 <a:solidFill>
                   <a:srgbClr val="53616D"/>
                 </a:solidFill>
@@ -13061,7 +13061,7 @@
               </a:defRPr>
             </a:defPPr>
             <a:lvl1pPr>
-              <a:defRPr sz="1350">
+              <a:defRPr sz="1650">
                 <a:solidFill>
                   <a:srgbClr val="53616D"/>
                 </a:solidFill>
@@ -13071,7 +13071,7 @@
               </a:defRPr>
             </a:lvl1pPr>
             <a:lvl2pPr>
-              <a:defRPr sz="1350">
+              <a:defRPr sz="1650">
                 <a:solidFill>
                   <a:srgbClr val="53616D"/>
                 </a:solidFill>
@@ -13081,7 +13081,7 @@
               </a:defRPr>
             </a:lvl2pPr>
             <a:lvl3pPr>
-              <a:defRPr sz="1350">
+              <a:defRPr sz="1650">
                 <a:solidFill>
                   <a:srgbClr val="53616D"/>
                 </a:solidFill>
@@ -13091,7 +13091,7 @@
               </a:defRPr>
             </a:lvl3pPr>
             <a:lvl4pPr>
-              <a:defRPr sz="1350">
+              <a:defRPr sz="1650">
                 <a:solidFill>
                   <a:srgbClr val="53616D"/>
                 </a:solidFill>
@@ -13101,7 +13101,7 @@
               </a:defRPr>
             </a:lvl4pPr>
             <a:lvl5pPr>
-              <a:defRPr sz="1350">
+              <a:defRPr sz="1650">
                 <a:solidFill>
                   <a:srgbClr val="53616D"/>
                 </a:solidFill>
@@ -13111,7 +13111,7 @@
               </a:defRPr>
             </a:lvl5pPr>
             <a:lvl6pPr>
-              <a:defRPr sz="1350">
+              <a:defRPr sz="1650">
                 <a:solidFill>
                   <a:srgbClr val="53616D"/>
                 </a:solidFill>
@@ -13121,7 +13121,7 @@
               </a:defRPr>
             </a:lvl6pPr>
             <a:lvl7pPr>
-              <a:defRPr sz="1350">
+              <a:defRPr sz="1650">
                 <a:solidFill>
                   <a:srgbClr val="53616D"/>
                 </a:solidFill>
@@ -13131,7 +13131,7 @@
               </a:defRPr>
             </a:lvl7pPr>
             <a:lvl8pPr>
-              <a:defRPr sz="1350">
+              <a:defRPr sz="1650">
                 <a:solidFill>
                   <a:srgbClr val="53616D"/>
                 </a:solidFill>
@@ -13141,7 +13141,7 @@
               </a:defRPr>
             </a:lvl8pPr>
             <a:lvl9pPr>
-              <a:defRPr sz="1350">
+              <a:defRPr sz="1650">
                 <a:solidFill>
                   <a:srgbClr val="53616D"/>
                 </a:solidFill>
@@ -13153,7 +13153,7 @@
           </a:lstStyle>
           <a:p xmlns:a="http://schemas.openxmlformats.org/drawingml/2006/main">
             <a:pPr>
-              <a:defRPr sz="1350">
+              <a:defRPr sz="1650">
                 <a:solidFill>
                   <a:srgbClr val="53616D"/>
                 </a:solidFill>
@@ -13163,7 +13163,7 @@
               </a:defRPr>
             </a:pPr>
             <a:r>
-              <a:rPr sz="1350">
+              <a:rPr sz="1650">
                 <a:solidFill>
                   <a:srgbClr val="53616D"/>
                 </a:solidFill>
@@ -13171,7 +13171,7 @@
                 <a:ea typeface="Arial"/>
                 <a:cs typeface="Arial"/>
               </a:rPr>
-              <a:t>Modelagem</a:t>
+              <a:t>Deploy</a:t>
             </a:r>
           </a:p>
         </p:txBody>
@@ -13192,8 +13192,8 @@
         </p:nvSpPr>
         <p:spPr>
           <a:xfrm xmlns:a="http://schemas.openxmlformats.org/drawingml/2006/main">
-            <a:off x="12477750" y="257175"/>
-            <a:ext cx="171450" cy="171450"/>
+            <a:off x="12430125" y="247650"/>
+            <a:ext cx="209550" cy="209550"/>
           </a:xfrm>
           <a:prstGeom xmlns:a="http://schemas.openxmlformats.org/drawingml/2006/main" prst="rect">
             <a:avLst/>
@@ -13203,7 +13203,7 @@
           </a:solidFill>
           <a:ln xmlns:a="http://schemas.openxmlformats.org/drawingml/2006/main" w="9525">
             <a:solidFill>
-              <a:srgbClr val="D3D7DB"/>
+              <a:srgbClr val="D5DADE"/>
             </a:solidFill>
             <a:prstDash val="solid"/>
           </a:ln>
@@ -13225,8 +13225,8 @@
         </p:nvSpPr>
         <p:spPr>
           <a:xfrm xmlns:a="http://schemas.openxmlformats.org/drawingml/2006/main">
-            <a:off x="12744450" y="228600"/>
-            <a:ext cx="2000250" cy="257175"/>
+            <a:off x="12763500" y="209550"/>
+            <a:ext cx="1952625" cy="333375"/>
           </a:xfrm>
           <a:prstGeom xmlns:a="http://schemas.openxmlformats.org/drawingml/2006/main" prst="rect">
             <a:avLst/>
@@ -13243,7 +13243,7 @@
           </a:bodyPr>
           <a:lstStyle xmlns:a="http://schemas.openxmlformats.org/drawingml/2006/main">
             <a:defPPr>
-              <a:defRPr sz="1350">
+              <a:defRPr sz="1650">
                 <a:solidFill>
                   <a:srgbClr val="53616D"/>
                 </a:solidFill>
@@ -13253,7 +13253,7 @@
               </a:defRPr>
             </a:defPPr>
             <a:lvl1pPr>
-              <a:defRPr sz="1350">
+              <a:defRPr sz="1650">
                 <a:solidFill>
                   <a:srgbClr val="53616D"/>
                 </a:solidFill>
@@ -13263,7 +13263,7 @@
               </a:defRPr>
             </a:lvl1pPr>
             <a:lvl2pPr>
-              <a:defRPr sz="1350">
+              <a:defRPr sz="1650">
                 <a:solidFill>
                   <a:srgbClr val="53616D"/>
                 </a:solidFill>
@@ -13273,7 +13273,7 @@
               </a:defRPr>
             </a:lvl2pPr>
             <a:lvl3pPr>
-              <a:defRPr sz="1350">
+              <a:defRPr sz="1650">
                 <a:solidFill>
                   <a:srgbClr val="53616D"/>
                 </a:solidFill>
@@ -13283,7 +13283,7 @@
               </a:defRPr>
             </a:lvl3pPr>
             <a:lvl4pPr>
-              <a:defRPr sz="1350">
+              <a:defRPr sz="1650">
                 <a:solidFill>
                   <a:srgbClr val="53616D"/>
                 </a:solidFill>
@@ -13293,7 +13293,7 @@
               </a:defRPr>
             </a:lvl4pPr>
             <a:lvl5pPr>
-              <a:defRPr sz="1350">
+              <a:defRPr sz="1650">
                 <a:solidFill>
                   <a:srgbClr val="53616D"/>
                 </a:solidFill>
@@ -13303,7 +13303,7 @@
               </a:defRPr>
             </a:lvl5pPr>
             <a:lvl6pPr>
-              <a:defRPr sz="1350">
+              <a:defRPr sz="1650">
                 <a:solidFill>
                   <a:srgbClr val="53616D"/>
                 </a:solidFill>
@@ -13313,7 +13313,7 @@
               </a:defRPr>
             </a:lvl6pPr>
             <a:lvl7pPr>
-              <a:defRPr sz="1350">
+              <a:defRPr sz="1650">
                 <a:solidFill>
                   <a:srgbClr val="53616D"/>
                 </a:solidFill>
@@ -13323,7 +13323,7 @@
               </a:defRPr>
             </a:lvl7pPr>
             <a:lvl8pPr>
-              <a:defRPr sz="1350">
+              <a:defRPr sz="1650">
                 <a:solidFill>
                   <a:srgbClr val="53616D"/>
                 </a:solidFill>
@@ -13333,7 +13333,7 @@
               </a:defRPr>
             </a:lvl8pPr>
             <a:lvl9pPr>
-              <a:defRPr sz="1350">
+              <a:defRPr sz="1650">
                 <a:solidFill>
                   <a:srgbClr val="53616D"/>
                 </a:solidFill>
@@ -13345,7 +13345,7 @@
           </a:lstStyle>
           <a:p xmlns:a="http://schemas.openxmlformats.org/drawingml/2006/main">
             <a:pPr>
-              <a:defRPr sz="1350">
+              <a:defRPr sz="1650">
                 <a:solidFill>
                   <a:srgbClr val="53616D"/>
                 </a:solidFill>
@@ -13355,7 +13355,7 @@
               </a:defRPr>
             </a:pPr>
             <a:r>
-              <a:rPr sz="1350">
+              <a:rPr sz="1650">
                 <a:solidFill>
                   <a:srgbClr val="53616D"/>
                 </a:solidFill>
@@ -13363,7 +13363,7 @@
                 <a:ea typeface="Arial"/>
                 <a:cs typeface="Arial"/>
               </a:rPr>
-              <a:t>Em construção</a:t>
+              <a:t>Modelagem</a:t>
             </a:r>
           </a:p>
         </p:txBody>

</xml_diff>